<commit_message>
feat: add guided full MFA approval entrypoints
</commit_message>
<xml_diff>
--- a/outputs/presentations/MFA_research_infrastructure_final_prebulk_20260801.pptx
+++ b/outputs/presentations/MFA_research_infrastructure_final_prebulk_20260801.pptx
@@ -204,7 +204,7 @@
             </a:lvl1pPr>
           </a:lstStyle>
           <a:p>
-            <a:fld id="{751EF66E-ABDB-4997-9297-22CAE6C0F03C}" type="datetimeFigureOut">
+            <a:fld id="{1F722071-0E4E-4346-B89F-5D1CF6F9C096}" type="datetimeFigureOut">
               <a:rPr lang="ko-KR" altLang="en-US" smtClean="0"/>
               <a:t>2026-08-01</a:t>
             </a:fld>
@@ -362,7 +362,7 @@
             </a:lvl1pPr>
           </a:lstStyle>
           <a:p>
-            <a:fld id="{C558F5F9-59A5-4407-87D2-86A17158B0E7}" type="slidenum">
+            <a:fld id="{FD758144-D535-4834-B96C-AC1D7ABFAF6F}" type="slidenum">
               <a:rPr lang="ko-KR" altLang="en-US" smtClean="0"/>
               <a:t>‹#›</a:t>
             </a:fld>
@@ -373,7 +373,7 @@
     </p:spTree>
     <p:extLst>
       <p:ext uri="{BB962C8B-B14F-4D97-AF65-F5344CB8AC3E}">
-        <p14:creationId xmlns:p14="http://schemas.microsoft.com/office/powerpoint/2010/main" val="3830477151"/>
+        <p14:creationId xmlns:p14="http://schemas.microsoft.com/office/powerpoint/2010/main" val="292322190"/>
       </p:ext>
     </p:extLst>
   </p:cSld>
@@ -558,7 +558,7 @@
           <a:bodyPr/>
           <a:lstStyle/>
           <a:p>
-            <a:fld id="{C558F5F9-59A5-4407-87D2-86A17158B0E7}" type="slidenum">
+            <a:fld id="{FD758144-D535-4834-B96C-AC1D7ABFAF6F}" type="slidenum">
               <a:rPr lang="ko-KR" altLang="en-US" smtClean="0"/>
               <a:t>1</a:t>
             </a:fld>
@@ -569,7 +569,7 @@
     </p:spTree>
     <p:extLst>
       <p:ext uri="{BB962C8B-B14F-4D97-AF65-F5344CB8AC3E}">
-        <p14:creationId xmlns:p14="http://schemas.microsoft.com/office/powerpoint/2010/main" val="2211810177"/>
+        <p14:creationId xmlns:p14="http://schemas.microsoft.com/office/powerpoint/2010/main" val="889557861"/>
       </p:ext>
     </p:extLst>
   </p:cSld>
@@ -664,7 +664,7 @@
           <a:bodyPr/>
           <a:lstStyle/>
           <a:p>
-            <a:fld id="{C558F5F9-59A5-4407-87D2-86A17158B0E7}" type="slidenum">
+            <a:fld id="{FD758144-D535-4834-B96C-AC1D7ABFAF6F}" type="slidenum">
               <a:rPr lang="ko-KR" altLang="en-US" smtClean="0"/>
               <a:t>10</a:t>
             </a:fld>
@@ -675,7 +675,7 @@
     </p:spTree>
     <p:extLst>
       <p:ext uri="{BB962C8B-B14F-4D97-AF65-F5344CB8AC3E}">
-        <p14:creationId xmlns:p14="http://schemas.microsoft.com/office/powerpoint/2010/main" val="4249546915"/>
+        <p14:creationId xmlns:p14="http://schemas.microsoft.com/office/powerpoint/2010/main" val="2670958192"/>
       </p:ext>
     </p:extLst>
   </p:cSld>
@@ -786,7 +786,7 @@
           <a:bodyPr/>
           <a:lstStyle/>
           <a:p>
-            <a:fld id="{C558F5F9-59A5-4407-87D2-86A17158B0E7}" type="slidenum">
+            <a:fld id="{FD758144-D535-4834-B96C-AC1D7ABFAF6F}" type="slidenum">
               <a:rPr lang="ko-KR" altLang="en-US" smtClean="0"/>
               <a:t>11</a:t>
             </a:fld>
@@ -797,7 +797,7 @@
     </p:spTree>
     <p:extLst>
       <p:ext uri="{BB962C8B-B14F-4D97-AF65-F5344CB8AC3E}">
-        <p14:creationId xmlns:p14="http://schemas.microsoft.com/office/powerpoint/2010/main" val="185398646"/>
+        <p14:creationId xmlns:p14="http://schemas.microsoft.com/office/powerpoint/2010/main" val="3582724659"/>
       </p:ext>
     </p:extLst>
   </p:cSld>
@@ -898,7 +898,7 @@
           <a:bodyPr/>
           <a:lstStyle/>
           <a:p>
-            <a:fld id="{C558F5F9-59A5-4407-87D2-86A17158B0E7}" type="slidenum">
+            <a:fld id="{FD758144-D535-4834-B96C-AC1D7ABFAF6F}" type="slidenum">
               <a:rPr lang="ko-KR" altLang="en-US" smtClean="0"/>
               <a:t>12</a:t>
             </a:fld>
@@ -909,7 +909,7 @@
     </p:spTree>
     <p:extLst>
       <p:ext uri="{BB962C8B-B14F-4D97-AF65-F5344CB8AC3E}">
-        <p14:creationId xmlns:p14="http://schemas.microsoft.com/office/powerpoint/2010/main" val="569233613"/>
+        <p14:creationId xmlns:p14="http://schemas.microsoft.com/office/powerpoint/2010/main" val="3796276022"/>
       </p:ext>
     </p:extLst>
   </p:cSld>
@@ -1004,7 +1004,7 @@
           <a:bodyPr/>
           <a:lstStyle/>
           <a:p>
-            <a:fld id="{C558F5F9-59A5-4407-87D2-86A17158B0E7}" type="slidenum">
+            <a:fld id="{FD758144-D535-4834-B96C-AC1D7ABFAF6F}" type="slidenum">
               <a:rPr lang="ko-KR" altLang="en-US" smtClean="0"/>
               <a:t>13</a:t>
             </a:fld>
@@ -1015,7 +1015,7 @@
     </p:spTree>
     <p:extLst>
       <p:ext uri="{BB962C8B-B14F-4D97-AF65-F5344CB8AC3E}">
-        <p14:creationId xmlns:p14="http://schemas.microsoft.com/office/powerpoint/2010/main" val="1523358691"/>
+        <p14:creationId xmlns:p14="http://schemas.microsoft.com/office/powerpoint/2010/main" val="1797853363"/>
       </p:ext>
     </p:extLst>
   </p:cSld>
@@ -1077,13 +1077,13 @@
           <a:p>
             <a:r>
               <a:rPr lang="en-US" altLang="ko-KR"/>
-              <a:t>- C:\Users\ari30\research\2026_summer_research\scripts\run_mfa_year_queue_safe.ps1</a:t>
+              <a:t>- C:\Users\ari30\research\2026_summer_research\scripts\prepare_full_mfa_approval_reviews.ps1</a:t>
             </a:r>
           </a:p>
           <a:p>
             <a:r>
               <a:rPr lang="en-US" altLang="ko-KR"/>
-              <a:t>- C:\Users\ari30\research\2026_summer_research\scripts\preflight_mfa_year_queue.ps1</a:t>
+              <a:t>- C:\Users\ari30\research\2026_summer_research\scripts\start_full_mfa_after_review.ps1</a:t>
             </a:r>
           </a:p>
           <a:p>
@@ -1116,7 +1116,7 @@
           <a:bodyPr/>
           <a:lstStyle/>
           <a:p>
-            <a:fld id="{C558F5F9-59A5-4407-87D2-86A17158B0E7}" type="slidenum">
+            <a:fld id="{FD758144-D535-4834-B96C-AC1D7ABFAF6F}" type="slidenum">
               <a:rPr lang="ko-KR" altLang="en-US" smtClean="0"/>
               <a:t>14</a:t>
             </a:fld>
@@ -1127,7 +1127,7 @@
     </p:spTree>
     <p:extLst>
       <p:ext uri="{BB962C8B-B14F-4D97-AF65-F5344CB8AC3E}">
-        <p14:creationId xmlns:p14="http://schemas.microsoft.com/office/powerpoint/2010/main" val="643254166"/>
+        <p14:creationId xmlns:p14="http://schemas.microsoft.com/office/powerpoint/2010/main" val="880546679"/>
       </p:ext>
     </p:extLst>
   </p:cSld>
@@ -1222,7 +1222,7 @@
           <a:bodyPr/>
           <a:lstStyle/>
           <a:p>
-            <a:fld id="{C558F5F9-59A5-4407-87D2-86A17158B0E7}" type="slidenum">
+            <a:fld id="{FD758144-D535-4834-B96C-AC1D7ABFAF6F}" type="slidenum">
               <a:rPr lang="ko-KR" altLang="en-US" smtClean="0"/>
               <a:t>15</a:t>
             </a:fld>
@@ -1233,7 +1233,7 @@
     </p:spTree>
     <p:extLst>
       <p:ext uri="{BB962C8B-B14F-4D97-AF65-F5344CB8AC3E}">
-        <p14:creationId xmlns:p14="http://schemas.microsoft.com/office/powerpoint/2010/main" val="1035153188"/>
+        <p14:creationId xmlns:p14="http://schemas.microsoft.com/office/powerpoint/2010/main" val="1656118544"/>
       </p:ext>
     </p:extLst>
   </p:cSld>
@@ -1322,7 +1322,7 @@
           <a:bodyPr/>
           <a:lstStyle/>
           <a:p>
-            <a:fld id="{C558F5F9-59A5-4407-87D2-86A17158B0E7}" type="slidenum">
+            <a:fld id="{FD758144-D535-4834-B96C-AC1D7ABFAF6F}" type="slidenum">
               <a:rPr lang="ko-KR" altLang="en-US" smtClean="0"/>
               <a:t>2</a:t>
             </a:fld>
@@ -1333,7 +1333,7 @@
     </p:spTree>
     <p:extLst>
       <p:ext uri="{BB962C8B-B14F-4D97-AF65-F5344CB8AC3E}">
-        <p14:creationId xmlns:p14="http://schemas.microsoft.com/office/powerpoint/2010/main" val="219137279"/>
+        <p14:creationId xmlns:p14="http://schemas.microsoft.com/office/powerpoint/2010/main" val="3742725400"/>
       </p:ext>
     </p:extLst>
   </p:cSld>
@@ -1428,7 +1428,7 @@
           <a:bodyPr/>
           <a:lstStyle/>
           <a:p>
-            <a:fld id="{C558F5F9-59A5-4407-87D2-86A17158B0E7}" type="slidenum">
+            <a:fld id="{FD758144-D535-4834-B96C-AC1D7ABFAF6F}" type="slidenum">
               <a:rPr lang="ko-KR" altLang="en-US" smtClean="0"/>
               <a:t>3</a:t>
             </a:fld>
@@ -1439,7 +1439,7 @@
     </p:spTree>
     <p:extLst>
       <p:ext uri="{BB962C8B-B14F-4D97-AF65-F5344CB8AC3E}">
-        <p14:creationId xmlns:p14="http://schemas.microsoft.com/office/powerpoint/2010/main" val="4089518743"/>
+        <p14:creationId xmlns:p14="http://schemas.microsoft.com/office/powerpoint/2010/main" val="960286781"/>
       </p:ext>
     </p:extLst>
   </p:cSld>
@@ -1528,7 +1528,7 @@
           <a:bodyPr/>
           <a:lstStyle/>
           <a:p>
-            <a:fld id="{C558F5F9-59A5-4407-87D2-86A17158B0E7}" type="slidenum">
+            <a:fld id="{FD758144-D535-4834-B96C-AC1D7ABFAF6F}" type="slidenum">
               <a:rPr lang="ko-KR" altLang="en-US" smtClean="0"/>
               <a:t>4</a:t>
             </a:fld>
@@ -1539,7 +1539,7 @@
     </p:spTree>
     <p:extLst>
       <p:ext uri="{BB962C8B-B14F-4D97-AF65-F5344CB8AC3E}">
-        <p14:creationId xmlns:p14="http://schemas.microsoft.com/office/powerpoint/2010/main" val="2134857868"/>
+        <p14:creationId xmlns:p14="http://schemas.microsoft.com/office/powerpoint/2010/main" val="2785223404"/>
       </p:ext>
     </p:extLst>
   </p:cSld>
@@ -1628,7 +1628,7 @@
           <a:bodyPr/>
           <a:lstStyle/>
           <a:p>
-            <a:fld id="{C558F5F9-59A5-4407-87D2-86A17158B0E7}" type="slidenum">
+            <a:fld id="{FD758144-D535-4834-B96C-AC1D7ABFAF6F}" type="slidenum">
               <a:rPr lang="ko-KR" altLang="en-US" smtClean="0"/>
               <a:t>5</a:t>
             </a:fld>
@@ -1639,7 +1639,7 @@
     </p:spTree>
     <p:extLst>
       <p:ext uri="{BB962C8B-B14F-4D97-AF65-F5344CB8AC3E}">
-        <p14:creationId xmlns:p14="http://schemas.microsoft.com/office/powerpoint/2010/main" val="703404630"/>
+        <p14:creationId xmlns:p14="http://schemas.microsoft.com/office/powerpoint/2010/main" val="41304212"/>
       </p:ext>
     </p:extLst>
   </p:cSld>
@@ -1734,7 +1734,7 @@
           <a:bodyPr/>
           <a:lstStyle/>
           <a:p>
-            <a:fld id="{C558F5F9-59A5-4407-87D2-86A17158B0E7}" type="slidenum">
+            <a:fld id="{FD758144-D535-4834-B96C-AC1D7ABFAF6F}" type="slidenum">
               <a:rPr lang="ko-KR" altLang="en-US" smtClean="0"/>
               <a:t>6</a:t>
             </a:fld>
@@ -1745,7 +1745,7 @@
     </p:spTree>
     <p:extLst>
       <p:ext uri="{BB962C8B-B14F-4D97-AF65-F5344CB8AC3E}">
-        <p14:creationId xmlns:p14="http://schemas.microsoft.com/office/powerpoint/2010/main" val="2476886632"/>
+        <p14:creationId xmlns:p14="http://schemas.microsoft.com/office/powerpoint/2010/main" val="2922533169"/>
       </p:ext>
     </p:extLst>
   </p:cSld>
@@ -1840,7 +1840,7 @@
           <a:bodyPr/>
           <a:lstStyle/>
           <a:p>
-            <a:fld id="{C558F5F9-59A5-4407-87D2-86A17158B0E7}" type="slidenum">
+            <a:fld id="{FD758144-D535-4834-B96C-AC1D7ABFAF6F}" type="slidenum">
               <a:rPr lang="ko-KR" altLang="en-US" smtClean="0"/>
               <a:t>7</a:t>
             </a:fld>
@@ -1851,7 +1851,7 @@
     </p:spTree>
     <p:extLst>
       <p:ext uri="{BB962C8B-B14F-4D97-AF65-F5344CB8AC3E}">
-        <p14:creationId xmlns:p14="http://schemas.microsoft.com/office/powerpoint/2010/main" val="2547988330"/>
+        <p14:creationId xmlns:p14="http://schemas.microsoft.com/office/powerpoint/2010/main" val="1247524531"/>
       </p:ext>
     </p:extLst>
   </p:cSld>
@@ -1940,7 +1940,7 @@
           <a:bodyPr/>
           <a:lstStyle/>
           <a:p>
-            <a:fld id="{C558F5F9-59A5-4407-87D2-86A17158B0E7}" type="slidenum">
+            <a:fld id="{FD758144-D535-4834-B96C-AC1D7ABFAF6F}" type="slidenum">
               <a:rPr lang="ko-KR" altLang="en-US" smtClean="0"/>
               <a:t>8</a:t>
             </a:fld>
@@ -1951,7 +1951,7 @@
     </p:spTree>
     <p:extLst>
       <p:ext uri="{BB962C8B-B14F-4D97-AF65-F5344CB8AC3E}">
-        <p14:creationId xmlns:p14="http://schemas.microsoft.com/office/powerpoint/2010/main" val="1034053278"/>
+        <p14:creationId xmlns:p14="http://schemas.microsoft.com/office/powerpoint/2010/main" val="129131844"/>
       </p:ext>
     </p:extLst>
   </p:cSld>
@@ -2054,7 +2054,7 @@
           <a:bodyPr/>
           <a:lstStyle/>
           <a:p>
-            <a:fld id="{C558F5F9-59A5-4407-87D2-86A17158B0E7}" type="slidenum">
+            <a:fld id="{FD758144-D535-4834-B96C-AC1D7ABFAF6F}" type="slidenum">
               <a:rPr lang="ko-KR" altLang="en-US" smtClean="0"/>
               <a:t>9</a:t>
             </a:fld>
@@ -2065,7 +2065,7 @@
     </p:spTree>
     <p:extLst>
       <p:ext uri="{BB962C8B-B14F-4D97-AF65-F5344CB8AC3E}">
-        <p14:creationId xmlns:p14="http://schemas.microsoft.com/office/powerpoint/2010/main" val="3557122479"/>
+        <p14:creationId xmlns:p14="http://schemas.microsoft.com/office/powerpoint/2010/main" val="468463116"/>
       </p:ext>
     </p:extLst>
   </p:cSld>
@@ -2097,7 +2097,7 @@
           <p:cNvPr id="2" name="제목 1">
             <a:extLst>
               <a:ext uri="{FF2B5EF4-FFF2-40B4-BE49-F238E27FC236}">
-                <a16:creationId xmlns:a16="http://schemas.microsoft.com/office/drawing/2014/main" id="{94C9A578-76B8-A19C-28A2-659F7C4B6E4D}"/>
+                <a16:creationId xmlns:a16="http://schemas.microsoft.com/office/drawing/2014/main" id="{CE396D5B-CCC0-755D-2BBC-1D639A047F0F}"/>
               </a:ext>
             </a:extLst>
           </p:cNvPr>
@@ -2134,7 +2134,7 @@
           <p:cNvPr id="3" name="부제목 2">
             <a:extLst>
               <a:ext uri="{FF2B5EF4-FFF2-40B4-BE49-F238E27FC236}">
-                <a16:creationId xmlns:a16="http://schemas.microsoft.com/office/drawing/2014/main" id="{B1AB94BD-1550-9DDC-50D5-E95BAC322858}"/>
+                <a16:creationId xmlns:a16="http://schemas.microsoft.com/office/drawing/2014/main" id="{6E8F0240-08B1-23F7-2853-2AC244B2CD80}"/>
               </a:ext>
             </a:extLst>
           </p:cNvPr>
@@ -2204,7 +2204,7 @@
           <p:cNvPr id="4" name="날짜 개체 틀 3">
             <a:extLst>
               <a:ext uri="{FF2B5EF4-FFF2-40B4-BE49-F238E27FC236}">
-                <a16:creationId xmlns:a16="http://schemas.microsoft.com/office/drawing/2014/main" id="{43AA310B-7830-EE8A-9811-2D41B9AD457E}"/>
+                <a16:creationId xmlns:a16="http://schemas.microsoft.com/office/drawing/2014/main" id="{0AA38C1A-D6F8-9455-6CA6-4FB33A695226}"/>
               </a:ext>
             </a:extLst>
           </p:cNvPr>
@@ -2220,7 +2220,7 @@
           <a:bodyPr/>
           <a:lstStyle/>
           <a:p>
-            <a:fld id="{C8C06E2F-B4EF-437A-9E51-118F8D56CC4B}" type="datetimeFigureOut">
+            <a:fld id="{54D53126-3A36-4AFA-AA27-279399065AFC}" type="datetimeFigureOut">
               <a:rPr lang="ko-KR" altLang="en-US" smtClean="0"/>
               <a:t>2026-08-01</a:t>
             </a:fld>
@@ -2233,7 +2233,7 @@
           <p:cNvPr id="5" name="바닥글 개체 틀 4">
             <a:extLst>
               <a:ext uri="{FF2B5EF4-FFF2-40B4-BE49-F238E27FC236}">
-                <a16:creationId xmlns:a16="http://schemas.microsoft.com/office/drawing/2014/main" id="{E4A08B5C-A615-75F6-1D1C-2CF8FF701793}"/>
+                <a16:creationId xmlns:a16="http://schemas.microsoft.com/office/drawing/2014/main" id="{17AF93B4-2112-B48E-37A4-218A63CC93DD}"/>
               </a:ext>
             </a:extLst>
           </p:cNvPr>
@@ -2258,7 +2258,7 @@
           <p:cNvPr id="6" name="슬라이드 번호 개체 틀 5">
             <a:extLst>
               <a:ext uri="{FF2B5EF4-FFF2-40B4-BE49-F238E27FC236}">
-                <a16:creationId xmlns:a16="http://schemas.microsoft.com/office/drawing/2014/main" id="{6B7C902F-6F0C-BCD8-812E-50834F435F4A}"/>
+                <a16:creationId xmlns:a16="http://schemas.microsoft.com/office/drawing/2014/main" id="{AA39D8DF-5AAE-0E89-2EA7-2EED61F8159E}"/>
               </a:ext>
             </a:extLst>
           </p:cNvPr>
@@ -2274,7 +2274,7 @@
           <a:bodyPr/>
           <a:lstStyle/>
           <a:p>
-            <a:fld id="{D169EEB6-6CAE-4EEF-8261-C376FD6834EF}" type="slidenum">
+            <a:fld id="{E99C0584-527A-4E61-8758-483310FDB539}" type="slidenum">
               <a:rPr lang="ko-KR" altLang="en-US" smtClean="0"/>
               <a:t>‹#›</a:t>
             </a:fld>
@@ -2285,7 +2285,7 @@
     </p:spTree>
     <p:extLst>
       <p:ext uri="{BB962C8B-B14F-4D97-AF65-F5344CB8AC3E}">
-        <p14:creationId xmlns:p14="http://schemas.microsoft.com/office/powerpoint/2010/main" val="192191336"/>
+        <p14:creationId xmlns:p14="http://schemas.microsoft.com/office/powerpoint/2010/main" val="742047435"/>
       </p:ext>
     </p:extLst>
   </p:cSld>
@@ -2317,7 +2317,7 @@
           <p:cNvPr id="2" name="제목 1">
             <a:extLst>
               <a:ext uri="{FF2B5EF4-FFF2-40B4-BE49-F238E27FC236}">
-                <a16:creationId xmlns:a16="http://schemas.microsoft.com/office/drawing/2014/main" id="{7B0724F9-61DF-66F6-D003-2F6C7E49A392}"/>
+                <a16:creationId xmlns:a16="http://schemas.microsoft.com/office/drawing/2014/main" id="{C39F7E5C-BAA2-FDD6-CC15-C99B4EA01A30}"/>
               </a:ext>
             </a:extLst>
           </p:cNvPr>
@@ -2345,7 +2345,7 @@
           <p:cNvPr id="3" name="세로 텍스트 개체 틀 2">
             <a:extLst>
               <a:ext uri="{FF2B5EF4-FFF2-40B4-BE49-F238E27FC236}">
-                <a16:creationId xmlns:a16="http://schemas.microsoft.com/office/drawing/2014/main" id="{22C28D34-5365-8638-7290-531F468E354E}"/>
+                <a16:creationId xmlns:a16="http://schemas.microsoft.com/office/drawing/2014/main" id="{0F7BECE2-3343-B9B3-EE32-CDCEA83FD457}"/>
               </a:ext>
             </a:extLst>
           </p:cNvPr>
@@ -2402,7 +2402,7 @@
           <p:cNvPr id="4" name="날짜 개체 틀 3">
             <a:extLst>
               <a:ext uri="{FF2B5EF4-FFF2-40B4-BE49-F238E27FC236}">
-                <a16:creationId xmlns:a16="http://schemas.microsoft.com/office/drawing/2014/main" id="{8AE3E7A1-9C0E-8BFF-9AC4-FF46E88D364F}"/>
+                <a16:creationId xmlns:a16="http://schemas.microsoft.com/office/drawing/2014/main" id="{84338D98-64F7-AAB6-BA50-23B883E3BAA0}"/>
               </a:ext>
             </a:extLst>
           </p:cNvPr>
@@ -2418,7 +2418,7 @@
           <a:bodyPr/>
           <a:lstStyle/>
           <a:p>
-            <a:fld id="{C8C06E2F-B4EF-437A-9E51-118F8D56CC4B}" type="datetimeFigureOut">
+            <a:fld id="{54D53126-3A36-4AFA-AA27-279399065AFC}" type="datetimeFigureOut">
               <a:rPr lang="ko-KR" altLang="en-US" smtClean="0"/>
               <a:t>2026-08-01</a:t>
             </a:fld>
@@ -2431,7 +2431,7 @@
           <p:cNvPr id="5" name="바닥글 개체 틀 4">
             <a:extLst>
               <a:ext uri="{FF2B5EF4-FFF2-40B4-BE49-F238E27FC236}">
-                <a16:creationId xmlns:a16="http://schemas.microsoft.com/office/drawing/2014/main" id="{49A33D13-7133-D652-1DBF-289573A5FA24}"/>
+                <a16:creationId xmlns:a16="http://schemas.microsoft.com/office/drawing/2014/main" id="{011F5B2A-CD48-3F19-DA63-F784D239DFF0}"/>
               </a:ext>
             </a:extLst>
           </p:cNvPr>
@@ -2456,7 +2456,7 @@
           <p:cNvPr id="6" name="슬라이드 번호 개체 틀 5">
             <a:extLst>
               <a:ext uri="{FF2B5EF4-FFF2-40B4-BE49-F238E27FC236}">
-                <a16:creationId xmlns:a16="http://schemas.microsoft.com/office/drawing/2014/main" id="{2DA03B3F-A99C-812A-BF44-8A3EDFCF9768}"/>
+                <a16:creationId xmlns:a16="http://schemas.microsoft.com/office/drawing/2014/main" id="{AF61F388-93BD-D4F7-22FF-0CFB51909EE5}"/>
               </a:ext>
             </a:extLst>
           </p:cNvPr>
@@ -2472,7 +2472,7 @@
           <a:bodyPr/>
           <a:lstStyle/>
           <a:p>
-            <a:fld id="{D169EEB6-6CAE-4EEF-8261-C376FD6834EF}" type="slidenum">
+            <a:fld id="{E99C0584-527A-4E61-8758-483310FDB539}" type="slidenum">
               <a:rPr lang="ko-KR" altLang="en-US" smtClean="0"/>
               <a:t>‹#›</a:t>
             </a:fld>
@@ -2483,7 +2483,7 @@
     </p:spTree>
     <p:extLst>
       <p:ext uri="{BB962C8B-B14F-4D97-AF65-F5344CB8AC3E}">
-        <p14:creationId xmlns:p14="http://schemas.microsoft.com/office/powerpoint/2010/main" val="517839823"/>
+        <p14:creationId xmlns:p14="http://schemas.microsoft.com/office/powerpoint/2010/main" val="75617423"/>
       </p:ext>
     </p:extLst>
   </p:cSld>
@@ -2515,7 +2515,7 @@
           <p:cNvPr id="2" name="세로 제목 1">
             <a:extLst>
               <a:ext uri="{FF2B5EF4-FFF2-40B4-BE49-F238E27FC236}">
-                <a16:creationId xmlns:a16="http://schemas.microsoft.com/office/drawing/2014/main" id="{86B92BC6-878F-12FB-38B9-A1CB42104571}"/>
+                <a16:creationId xmlns:a16="http://schemas.microsoft.com/office/drawing/2014/main" id="{89A92203-0342-3445-CA8A-C235E37AAF1D}"/>
               </a:ext>
             </a:extLst>
           </p:cNvPr>
@@ -2548,7 +2548,7 @@
           <p:cNvPr id="3" name="세로 텍스트 개체 틀 2">
             <a:extLst>
               <a:ext uri="{FF2B5EF4-FFF2-40B4-BE49-F238E27FC236}">
-                <a16:creationId xmlns:a16="http://schemas.microsoft.com/office/drawing/2014/main" id="{ED43B8EA-D85B-A0CE-31A7-63CEEFE8661C}"/>
+                <a16:creationId xmlns:a16="http://schemas.microsoft.com/office/drawing/2014/main" id="{9BF03B99-1C15-2FE5-0236-81F3D390AB4C}"/>
               </a:ext>
             </a:extLst>
           </p:cNvPr>
@@ -2610,7 +2610,7 @@
           <p:cNvPr id="4" name="날짜 개체 틀 3">
             <a:extLst>
               <a:ext uri="{FF2B5EF4-FFF2-40B4-BE49-F238E27FC236}">
-                <a16:creationId xmlns:a16="http://schemas.microsoft.com/office/drawing/2014/main" id="{C913FA9B-7550-AB6C-66D8-9E933733C61A}"/>
+                <a16:creationId xmlns:a16="http://schemas.microsoft.com/office/drawing/2014/main" id="{80E2BC9F-34A3-AB93-0260-8AE0FAE587DA}"/>
               </a:ext>
             </a:extLst>
           </p:cNvPr>
@@ -2626,7 +2626,7 @@
           <a:bodyPr/>
           <a:lstStyle/>
           <a:p>
-            <a:fld id="{C8C06E2F-B4EF-437A-9E51-118F8D56CC4B}" type="datetimeFigureOut">
+            <a:fld id="{54D53126-3A36-4AFA-AA27-279399065AFC}" type="datetimeFigureOut">
               <a:rPr lang="ko-KR" altLang="en-US" smtClean="0"/>
               <a:t>2026-08-01</a:t>
             </a:fld>
@@ -2639,7 +2639,7 @@
           <p:cNvPr id="5" name="바닥글 개체 틀 4">
             <a:extLst>
               <a:ext uri="{FF2B5EF4-FFF2-40B4-BE49-F238E27FC236}">
-                <a16:creationId xmlns:a16="http://schemas.microsoft.com/office/drawing/2014/main" id="{906555C5-4FC2-E866-834E-7E82C1EF4D05}"/>
+                <a16:creationId xmlns:a16="http://schemas.microsoft.com/office/drawing/2014/main" id="{4BFEC69B-F69C-9607-29EA-F9AF69018ADB}"/>
               </a:ext>
             </a:extLst>
           </p:cNvPr>
@@ -2664,7 +2664,7 @@
           <p:cNvPr id="6" name="슬라이드 번호 개체 틀 5">
             <a:extLst>
               <a:ext uri="{FF2B5EF4-FFF2-40B4-BE49-F238E27FC236}">
-                <a16:creationId xmlns:a16="http://schemas.microsoft.com/office/drawing/2014/main" id="{A6532D41-2724-E1AF-1F46-EBAF20F7665F}"/>
+                <a16:creationId xmlns:a16="http://schemas.microsoft.com/office/drawing/2014/main" id="{B719ACFF-12F1-0229-993B-EFF61CDCC1ED}"/>
               </a:ext>
             </a:extLst>
           </p:cNvPr>
@@ -2680,7 +2680,7 @@
           <a:bodyPr/>
           <a:lstStyle/>
           <a:p>
-            <a:fld id="{D169EEB6-6CAE-4EEF-8261-C376FD6834EF}" type="slidenum">
+            <a:fld id="{E99C0584-527A-4E61-8758-483310FDB539}" type="slidenum">
               <a:rPr lang="ko-KR" altLang="en-US" smtClean="0"/>
               <a:t>‹#›</a:t>
             </a:fld>
@@ -2691,7 +2691,7 @@
     </p:spTree>
     <p:extLst>
       <p:ext uri="{BB962C8B-B14F-4D97-AF65-F5344CB8AC3E}">
-        <p14:creationId xmlns:p14="http://schemas.microsoft.com/office/powerpoint/2010/main" val="303808635"/>
+        <p14:creationId xmlns:p14="http://schemas.microsoft.com/office/powerpoint/2010/main" val="4115418251"/>
       </p:ext>
     </p:extLst>
   </p:cSld>
@@ -2723,7 +2723,7 @@
           <p:cNvPr id="2" name="제목 1">
             <a:extLst>
               <a:ext uri="{FF2B5EF4-FFF2-40B4-BE49-F238E27FC236}">
-                <a16:creationId xmlns:a16="http://schemas.microsoft.com/office/drawing/2014/main" id="{2E6827B1-9D46-D557-B673-C9198817C77B}"/>
+                <a16:creationId xmlns:a16="http://schemas.microsoft.com/office/drawing/2014/main" id="{EEFA602E-49D1-7E8C-747B-06C04A555166}"/>
               </a:ext>
             </a:extLst>
           </p:cNvPr>
@@ -2751,7 +2751,7 @@
           <p:cNvPr id="3" name="내용 개체 틀 2">
             <a:extLst>
               <a:ext uri="{FF2B5EF4-FFF2-40B4-BE49-F238E27FC236}">
-                <a16:creationId xmlns:a16="http://schemas.microsoft.com/office/drawing/2014/main" id="{78684AB9-7842-4C84-69A0-38CEFD353C18}"/>
+                <a16:creationId xmlns:a16="http://schemas.microsoft.com/office/drawing/2014/main" id="{1AD958AA-782B-2994-34EF-08D5F1A1AE8E}"/>
               </a:ext>
             </a:extLst>
           </p:cNvPr>
@@ -2808,7 +2808,7 @@
           <p:cNvPr id="4" name="날짜 개체 틀 3">
             <a:extLst>
               <a:ext uri="{FF2B5EF4-FFF2-40B4-BE49-F238E27FC236}">
-                <a16:creationId xmlns:a16="http://schemas.microsoft.com/office/drawing/2014/main" id="{B0D53DEB-810E-E19C-CF84-B8D2FB6B6711}"/>
+                <a16:creationId xmlns:a16="http://schemas.microsoft.com/office/drawing/2014/main" id="{CFA8F1BF-A486-5E96-FFE9-D5F836E89FC3}"/>
               </a:ext>
             </a:extLst>
           </p:cNvPr>
@@ -2824,7 +2824,7 @@
           <a:bodyPr/>
           <a:lstStyle/>
           <a:p>
-            <a:fld id="{C8C06E2F-B4EF-437A-9E51-118F8D56CC4B}" type="datetimeFigureOut">
+            <a:fld id="{54D53126-3A36-4AFA-AA27-279399065AFC}" type="datetimeFigureOut">
               <a:rPr lang="ko-KR" altLang="en-US" smtClean="0"/>
               <a:t>2026-08-01</a:t>
             </a:fld>
@@ -2837,7 +2837,7 @@
           <p:cNvPr id="5" name="바닥글 개체 틀 4">
             <a:extLst>
               <a:ext uri="{FF2B5EF4-FFF2-40B4-BE49-F238E27FC236}">
-                <a16:creationId xmlns:a16="http://schemas.microsoft.com/office/drawing/2014/main" id="{9D92BD6D-6F8D-12B0-E1CD-ADC06B446C2A}"/>
+                <a16:creationId xmlns:a16="http://schemas.microsoft.com/office/drawing/2014/main" id="{4FB837EB-18A9-8217-7B93-4CD9AEE761F8}"/>
               </a:ext>
             </a:extLst>
           </p:cNvPr>
@@ -2862,7 +2862,7 @@
           <p:cNvPr id="6" name="슬라이드 번호 개체 틀 5">
             <a:extLst>
               <a:ext uri="{FF2B5EF4-FFF2-40B4-BE49-F238E27FC236}">
-                <a16:creationId xmlns:a16="http://schemas.microsoft.com/office/drawing/2014/main" id="{548EDFB8-D752-49E0-4D9F-7FCE65A28A76}"/>
+                <a16:creationId xmlns:a16="http://schemas.microsoft.com/office/drawing/2014/main" id="{2B1B79D7-B527-511D-910C-7AA18862C28E}"/>
               </a:ext>
             </a:extLst>
           </p:cNvPr>
@@ -2878,7 +2878,7 @@
           <a:bodyPr/>
           <a:lstStyle/>
           <a:p>
-            <a:fld id="{D169EEB6-6CAE-4EEF-8261-C376FD6834EF}" type="slidenum">
+            <a:fld id="{E99C0584-527A-4E61-8758-483310FDB539}" type="slidenum">
               <a:rPr lang="ko-KR" altLang="en-US" smtClean="0"/>
               <a:t>‹#›</a:t>
             </a:fld>
@@ -2889,7 +2889,7 @@
     </p:spTree>
     <p:extLst>
       <p:ext uri="{BB962C8B-B14F-4D97-AF65-F5344CB8AC3E}">
-        <p14:creationId xmlns:p14="http://schemas.microsoft.com/office/powerpoint/2010/main" val="1217676349"/>
+        <p14:creationId xmlns:p14="http://schemas.microsoft.com/office/powerpoint/2010/main" val="1485659729"/>
       </p:ext>
     </p:extLst>
   </p:cSld>
@@ -2921,7 +2921,7 @@
           <p:cNvPr id="2" name="제목 1">
             <a:extLst>
               <a:ext uri="{FF2B5EF4-FFF2-40B4-BE49-F238E27FC236}">
-                <a16:creationId xmlns:a16="http://schemas.microsoft.com/office/drawing/2014/main" id="{5E01ACFC-C357-E44F-6DC1-80EBAB8C5A31}"/>
+                <a16:creationId xmlns:a16="http://schemas.microsoft.com/office/drawing/2014/main" id="{82CB67BE-EAAD-91C9-1C7F-A36E1EBD0ACA}"/>
               </a:ext>
             </a:extLst>
           </p:cNvPr>
@@ -2958,7 +2958,7 @@
           <p:cNvPr id="3" name="텍스트 개체 틀 2">
             <a:extLst>
               <a:ext uri="{FF2B5EF4-FFF2-40B4-BE49-F238E27FC236}">
-                <a16:creationId xmlns:a16="http://schemas.microsoft.com/office/drawing/2014/main" id="{F0AA4F2E-CEDD-3613-2429-A466B2B68DDF}"/>
+                <a16:creationId xmlns:a16="http://schemas.microsoft.com/office/drawing/2014/main" id="{CFE141D0-839E-62A4-D482-92A14E87C90E}"/>
               </a:ext>
             </a:extLst>
           </p:cNvPr>
@@ -3083,7 +3083,7 @@
           <p:cNvPr id="4" name="날짜 개체 틀 3">
             <a:extLst>
               <a:ext uri="{FF2B5EF4-FFF2-40B4-BE49-F238E27FC236}">
-                <a16:creationId xmlns:a16="http://schemas.microsoft.com/office/drawing/2014/main" id="{E8482861-8E3B-907F-7A0B-8F09CDB18F4B}"/>
+                <a16:creationId xmlns:a16="http://schemas.microsoft.com/office/drawing/2014/main" id="{3BF14D7D-0B39-811E-9114-91A31B8A52FC}"/>
               </a:ext>
             </a:extLst>
           </p:cNvPr>
@@ -3099,7 +3099,7 @@
           <a:bodyPr/>
           <a:lstStyle/>
           <a:p>
-            <a:fld id="{C8C06E2F-B4EF-437A-9E51-118F8D56CC4B}" type="datetimeFigureOut">
+            <a:fld id="{54D53126-3A36-4AFA-AA27-279399065AFC}" type="datetimeFigureOut">
               <a:rPr lang="ko-KR" altLang="en-US" smtClean="0"/>
               <a:t>2026-08-01</a:t>
             </a:fld>
@@ -3112,7 +3112,7 @@
           <p:cNvPr id="5" name="바닥글 개체 틀 4">
             <a:extLst>
               <a:ext uri="{FF2B5EF4-FFF2-40B4-BE49-F238E27FC236}">
-                <a16:creationId xmlns:a16="http://schemas.microsoft.com/office/drawing/2014/main" id="{01DC3C79-ED3D-695A-8B2B-D63384E0809F}"/>
+                <a16:creationId xmlns:a16="http://schemas.microsoft.com/office/drawing/2014/main" id="{B7A43D79-B2D2-3987-20E1-7CEE0B0D4741}"/>
               </a:ext>
             </a:extLst>
           </p:cNvPr>
@@ -3137,7 +3137,7 @@
           <p:cNvPr id="6" name="슬라이드 번호 개체 틀 5">
             <a:extLst>
               <a:ext uri="{FF2B5EF4-FFF2-40B4-BE49-F238E27FC236}">
-                <a16:creationId xmlns:a16="http://schemas.microsoft.com/office/drawing/2014/main" id="{380A0816-B56F-31E7-46D0-A71E3D94F1D4}"/>
+                <a16:creationId xmlns:a16="http://schemas.microsoft.com/office/drawing/2014/main" id="{E9C15EF3-D75C-3980-6035-747134D85EBE}"/>
               </a:ext>
             </a:extLst>
           </p:cNvPr>
@@ -3153,7 +3153,7 @@
           <a:bodyPr/>
           <a:lstStyle/>
           <a:p>
-            <a:fld id="{D169EEB6-6CAE-4EEF-8261-C376FD6834EF}" type="slidenum">
+            <a:fld id="{E99C0584-527A-4E61-8758-483310FDB539}" type="slidenum">
               <a:rPr lang="ko-KR" altLang="en-US" smtClean="0"/>
               <a:t>‹#›</a:t>
             </a:fld>
@@ -3164,7 +3164,7 @@
     </p:spTree>
     <p:extLst>
       <p:ext uri="{BB962C8B-B14F-4D97-AF65-F5344CB8AC3E}">
-        <p14:creationId xmlns:p14="http://schemas.microsoft.com/office/powerpoint/2010/main" val="2416922411"/>
+        <p14:creationId xmlns:p14="http://schemas.microsoft.com/office/powerpoint/2010/main" val="2382037558"/>
       </p:ext>
     </p:extLst>
   </p:cSld>
@@ -3196,7 +3196,7 @@
           <p:cNvPr id="2" name="제목 1">
             <a:extLst>
               <a:ext uri="{FF2B5EF4-FFF2-40B4-BE49-F238E27FC236}">
-                <a16:creationId xmlns:a16="http://schemas.microsoft.com/office/drawing/2014/main" id="{903B974B-8A40-3782-8B19-D02B42E75CEF}"/>
+                <a16:creationId xmlns:a16="http://schemas.microsoft.com/office/drawing/2014/main" id="{FB5DB2D2-87B1-3FE4-B414-41076FCD3EA1}"/>
               </a:ext>
             </a:extLst>
           </p:cNvPr>
@@ -3224,7 +3224,7 @@
           <p:cNvPr id="3" name="내용 개체 틀 2">
             <a:extLst>
               <a:ext uri="{FF2B5EF4-FFF2-40B4-BE49-F238E27FC236}">
-                <a16:creationId xmlns:a16="http://schemas.microsoft.com/office/drawing/2014/main" id="{6C9E2BB7-CE12-B93B-8378-61C9C5EF7EFB}"/>
+                <a16:creationId xmlns:a16="http://schemas.microsoft.com/office/drawing/2014/main" id="{E05F1F77-5692-7FCA-A3D7-5E953BAC82C0}"/>
               </a:ext>
             </a:extLst>
           </p:cNvPr>
@@ -3286,7 +3286,7 @@
           <p:cNvPr id="4" name="내용 개체 틀 3">
             <a:extLst>
               <a:ext uri="{FF2B5EF4-FFF2-40B4-BE49-F238E27FC236}">
-                <a16:creationId xmlns:a16="http://schemas.microsoft.com/office/drawing/2014/main" id="{1CE06E86-487A-BE10-9857-D195F7E7CB71}"/>
+                <a16:creationId xmlns:a16="http://schemas.microsoft.com/office/drawing/2014/main" id="{4DA047E0-49A2-AD23-5B8D-FF1A1BF95F10}"/>
               </a:ext>
             </a:extLst>
           </p:cNvPr>
@@ -3348,7 +3348,7 @@
           <p:cNvPr id="5" name="날짜 개체 틀 4">
             <a:extLst>
               <a:ext uri="{FF2B5EF4-FFF2-40B4-BE49-F238E27FC236}">
-                <a16:creationId xmlns:a16="http://schemas.microsoft.com/office/drawing/2014/main" id="{7C07072F-2E5C-0763-21FD-D05707641699}"/>
+                <a16:creationId xmlns:a16="http://schemas.microsoft.com/office/drawing/2014/main" id="{C765C5C9-A49F-8674-7662-B72D57FA8A63}"/>
               </a:ext>
             </a:extLst>
           </p:cNvPr>
@@ -3364,7 +3364,7 @@
           <a:bodyPr/>
           <a:lstStyle/>
           <a:p>
-            <a:fld id="{C8C06E2F-B4EF-437A-9E51-118F8D56CC4B}" type="datetimeFigureOut">
+            <a:fld id="{54D53126-3A36-4AFA-AA27-279399065AFC}" type="datetimeFigureOut">
               <a:rPr lang="ko-KR" altLang="en-US" smtClean="0"/>
               <a:t>2026-08-01</a:t>
             </a:fld>
@@ -3377,7 +3377,7 @@
           <p:cNvPr id="6" name="바닥글 개체 틀 5">
             <a:extLst>
               <a:ext uri="{FF2B5EF4-FFF2-40B4-BE49-F238E27FC236}">
-                <a16:creationId xmlns:a16="http://schemas.microsoft.com/office/drawing/2014/main" id="{85A4A4EC-1CB0-FE76-A917-664D12EB1D1F}"/>
+                <a16:creationId xmlns:a16="http://schemas.microsoft.com/office/drawing/2014/main" id="{FB524501-48D1-E0E8-D678-9ADE373ABC38}"/>
               </a:ext>
             </a:extLst>
           </p:cNvPr>
@@ -3402,7 +3402,7 @@
           <p:cNvPr id="7" name="슬라이드 번호 개체 틀 6">
             <a:extLst>
               <a:ext uri="{FF2B5EF4-FFF2-40B4-BE49-F238E27FC236}">
-                <a16:creationId xmlns:a16="http://schemas.microsoft.com/office/drawing/2014/main" id="{9B400F7C-4E21-1B7E-5250-4595A1AEA2B2}"/>
+                <a16:creationId xmlns:a16="http://schemas.microsoft.com/office/drawing/2014/main" id="{39E3AEDC-32AB-D3EE-7802-C828A7046995}"/>
               </a:ext>
             </a:extLst>
           </p:cNvPr>
@@ -3418,7 +3418,7 @@
           <a:bodyPr/>
           <a:lstStyle/>
           <a:p>
-            <a:fld id="{D169EEB6-6CAE-4EEF-8261-C376FD6834EF}" type="slidenum">
+            <a:fld id="{E99C0584-527A-4E61-8758-483310FDB539}" type="slidenum">
               <a:rPr lang="ko-KR" altLang="en-US" smtClean="0"/>
               <a:t>‹#›</a:t>
             </a:fld>
@@ -3429,7 +3429,7 @@
     </p:spTree>
     <p:extLst>
       <p:ext uri="{BB962C8B-B14F-4D97-AF65-F5344CB8AC3E}">
-        <p14:creationId xmlns:p14="http://schemas.microsoft.com/office/powerpoint/2010/main" val="2609580865"/>
+        <p14:creationId xmlns:p14="http://schemas.microsoft.com/office/powerpoint/2010/main" val="1573994992"/>
       </p:ext>
     </p:extLst>
   </p:cSld>
@@ -3461,7 +3461,7 @@
           <p:cNvPr id="2" name="제목 1">
             <a:extLst>
               <a:ext uri="{FF2B5EF4-FFF2-40B4-BE49-F238E27FC236}">
-                <a16:creationId xmlns:a16="http://schemas.microsoft.com/office/drawing/2014/main" id="{2C3B9F32-9D89-57BE-3A48-5AFFD440475D}"/>
+                <a16:creationId xmlns:a16="http://schemas.microsoft.com/office/drawing/2014/main" id="{D8703010-FE95-1E58-D603-466C50B0EE6B}"/>
               </a:ext>
             </a:extLst>
           </p:cNvPr>
@@ -3494,7 +3494,7 @@
           <p:cNvPr id="3" name="텍스트 개체 틀 2">
             <a:extLst>
               <a:ext uri="{FF2B5EF4-FFF2-40B4-BE49-F238E27FC236}">
-                <a16:creationId xmlns:a16="http://schemas.microsoft.com/office/drawing/2014/main" id="{9352CEA0-692A-2D58-FADB-7A7F6400DF79}"/>
+                <a16:creationId xmlns:a16="http://schemas.microsoft.com/office/drawing/2014/main" id="{7C249F12-9E0D-B461-F130-C3CDA8F9D3EC}"/>
               </a:ext>
             </a:extLst>
           </p:cNvPr>
@@ -3565,7 +3565,7 @@
           <p:cNvPr id="4" name="내용 개체 틀 3">
             <a:extLst>
               <a:ext uri="{FF2B5EF4-FFF2-40B4-BE49-F238E27FC236}">
-                <a16:creationId xmlns:a16="http://schemas.microsoft.com/office/drawing/2014/main" id="{D4D9673D-4835-7F35-4229-F849BDE4B587}"/>
+                <a16:creationId xmlns:a16="http://schemas.microsoft.com/office/drawing/2014/main" id="{BC0DF64B-AA97-3EF1-4E62-F436C2B5DEBF}"/>
               </a:ext>
             </a:extLst>
           </p:cNvPr>
@@ -3627,7 +3627,7 @@
           <p:cNvPr id="5" name="텍스트 개체 틀 4">
             <a:extLst>
               <a:ext uri="{FF2B5EF4-FFF2-40B4-BE49-F238E27FC236}">
-                <a16:creationId xmlns:a16="http://schemas.microsoft.com/office/drawing/2014/main" id="{C9551515-198A-A3FF-B44F-42557E80408C}"/>
+                <a16:creationId xmlns:a16="http://schemas.microsoft.com/office/drawing/2014/main" id="{5E802DD3-7806-7448-D4DA-E29F7ADB0140}"/>
               </a:ext>
             </a:extLst>
           </p:cNvPr>
@@ -3698,7 +3698,7 @@
           <p:cNvPr id="6" name="내용 개체 틀 5">
             <a:extLst>
               <a:ext uri="{FF2B5EF4-FFF2-40B4-BE49-F238E27FC236}">
-                <a16:creationId xmlns:a16="http://schemas.microsoft.com/office/drawing/2014/main" id="{7DE165B8-E5A8-0B60-4CB1-618F413B566F}"/>
+                <a16:creationId xmlns:a16="http://schemas.microsoft.com/office/drawing/2014/main" id="{06619D6B-1931-EA3E-7128-5A7592811CCB}"/>
               </a:ext>
             </a:extLst>
           </p:cNvPr>
@@ -3760,7 +3760,7 @@
           <p:cNvPr id="7" name="날짜 개체 틀 6">
             <a:extLst>
               <a:ext uri="{FF2B5EF4-FFF2-40B4-BE49-F238E27FC236}">
-                <a16:creationId xmlns:a16="http://schemas.microsoft.com/office/drawing/2014/main" id="{EC0FC9F0-32EC-5E0C-7534-56904E09AA62}"/>
+                <a16:creationId xmlns:a16="http://schemas.microsoft.com/office/drawing/2014/main" id="{BEABA815-AA2B-5725-15E0-F1C6222E9427}"/>
               </a:ext>
             </a:extLst>
           </p:cNvPr>
@@ -3776,7 +3776,7 @@
           <a:bodyPr/>
           <a:lstStyle/>
           <a:p>
-            <a:fld id="{C8C06E2F-B4EF-437A-9E51-118F8D56CC4B}" type="datetimeFigureOut">
+            <a:fld id="{54D53126-3A36-4AFA-AA27-279399065AFC}" type="datetimeFigureOut">
               <a:rPr lang="ko-KR" altLang="en-US" smtClean="0"/>
               <a:t>2026-08-01</a:t>
             </a:fld>
@@ -3789,7 +3789,7 @@
           <p:cNvPr id="8" name="바닥글 개체 틀 7">
             <a:extLst>
               <a:ext uri="{FF2B5EF4-FFF2-40B4-BE49-F238E27FC236}">
-                <a16:creationId xmlns:a16="http://schemas.microsoft.com/office/drawing/2014/main" id="{48C14123-4A62-1422-8F19-4DD2A5ABA282}"/>
+                <a16:creationId xmlns:a16="http://schemas.microsoft.com/office/drawing/2014/main" id="{C541AB5F-E374-2C76-ECCE-D9766A435A80}"/>
               </a:ext>
             </a:extLst>
           </p:cNvPr>
@@ -3814,7 +3814,7 @@
           <p:cNvPr id="9" name="슬라이드 번호 개체 틀 8">
             <a:extLst>
               <a:ext uri="{FF2B5EF4-FFF2-40B4-BE49-F238E27FC236}">
-                <a16:creationId xmlns:a16="http://schemas.microsoft.com/office/drawing/2014/main" id="{C9960C77-6256-E4EE-07FA-3EEF231C95CA}"/>
+                <a16:creationId xmlns:a16="http://schemas.microsoft.com/office/drawing/2014/main" id="{0761FEC8-8553-7452-7549-550D25E250F0}"/>
               </a:ext>
             </a:extLst>
           </p:cNvPr>
@@ -3830,7 +3830,7 @@
           <a:bodyPr/>
           <a:lstStyle/>
           <a:p>
-            <a:fld id="{D169EEB6-6CAE-4EEF-8261-C376FD6834EF}" type="slidenum">
+            <a:fld id="{E99C0584-527A-4E61-8758-483310FDB539}" type="slidenum">
               <a:rPr lang="ko-KR" altLang="en-US" smtClean="0"/>
               <a:t>‹#›</a:t>
             </a:fld>
@@ -3841,7 +3841,7 @@
     </p:spTree>
     <p:extLst>
       <p:ext uri="{BB962C8B-B14F-4D97-AF65-F5344CB8AC3E}">
-        <p14:creationId xmlns:p14="http://schemas.microsoft.com/office/powerpoint/2010/main" val="3362493971"/>
+        <p14:creationId xmlns:p14="http://schemas.microsoft.com/office/powerpoint/2010/main" val="2394818336"/>
       </p:ext>
     </p:extLst>
   </p:cSld>
@@ -3873,7 +3873,7 @@
           <p:cNvPr id="2" name="제목 1">
             <a:extLst>
               <a:ext uri="{FF2B5EF4-FFF2-40B4-BE49-F238E27FC236}">
-                <a16:creationId xmlns:a16="http://schemas.microsoft.com/office/drawing/2014/main" id="{A88B0A55-10BE-3697-FAA9-9DC7FC1D07E5}"/>
+                <a16:creationId xmlns:a16="http://schemas.microsoft.com/office/drawing/2014/main" id="{14FBFDF0-4E66-5360-D173-881F1CA185E7}"/>
               </a:ext>
             </a:extLst>
           </p:cNvPr>
@@ -3901,7 +3901,7 @@
           <p:cNvPr id="3" name="날짜 개체 틀 2">
             <a:extLst>
               <a:ext uri="{FF2B5EF4-FFF2-40B4-BE49-F238E27FC236}">
-                <a16:creationId xmlns:a16="http://schemas.microsoft.com/office/drawing/2014/main" id="{0B5B3562-F4FF-DD9C-6F65-663EA88E9960}"/>
+                <a16:creationId xmlns:a16="http://schemas.microsoft.com/office/drawing/2014/main" id="{FCE9872C-D04D-93B4-AE1C-BA9EB439170E}"/>
               </a:ext>
             </a:extLst>
           </p:cNvPr>
@@ -3917,7 +3917,7 @@
           <a:bodyPr/>
           <a:lstStyle/>
           <a:p>
-            <a:fld id="{C8C06E2F-B4EF-437A-9E51-118F8D56CC4B}" type="datetimeFigureOut">
+            <a:fld id="{54D53126-3A36-4AFA-AA27-279399065AFC}" type="datetimeFigureOut">
               <a:rPr lang="ko-KR" altLang="en-US" smtClean="0"/>
               <a:t>2026-08-01</a:t>
             </a:fld>
@@ -3930,7 +3930,7 @@
           <p:cNvPr id="4" name="바닥글 개체 틀 3">
             <a:extLst>
               <a:ext uri="{FF2B5EF4-FFF2-40B4-BE49-F238E27FC236}">
-                <a16:creationId xmlns:a16="http://schemas.microsoft.com/office/drawing/2014/main" id="{7DD8060B-56C1-B3D1-CE75-3174A5EF518A}"/>
+                <a16:creationId xmlns:a16="http://schemas.microsoft.com/office/drawing/2014/main" id="{4855A82A-E294-9402-E497-551EEA0BFED1}"/>
               </a:ext>
             </a:extLst>
           </p:cNvPr>
@@ -3955,7 +3955,7 @@
           <p:cNvPr id="5" name="슬라이드 번호 개체 틀 4">
             <a:extLst>
               <a:ext uri="{FF2B5EF4-FFF2-40B4-BE49-F238E27FC236}">
-                <a16:creationId xmlns:a16="http://schemas.microsoft.com/office/drawing/2014/main" id="{80FD1E47-56F3-9975-67AA-4DA9A0B52205}"/>
+                <a16:creationId xmlns:a16="http://schemas.microsoft.com/office/drawing/2014/main" id="{48AC77A8-D2BF-01D2-6E04-E6EF73ADF4BB}"/>
               </a:ext>
             </a:extLst>
           </p:cNvPr>
@@ -3971,7 +3971,7 @@
           <a:bodyPr/>
           <a:lstStyle/>
           <a:p>
-            <a:fld id="{D169EEB6-6CAE-4EEF-8261-C376FD6834EF}" type="slidenum">
+            <a:fld id="{E99C0584-527A-4E61-8758-483310FDB539}" type="slidenum">
               <a:rPr lang="ko-KR" altLang="en-US" smtClean="0"/>
               <a:t>‹#›</a:t>
             </a:fld>
@@ -3982,7 +3982,7 @@
     </p:spTree>
     <p:extLst>
       <p:ext uri="{BB962C8B-B14F-4D97-AF65-F5344CB8AC3E}">
-        <p14:creationId xmlns:p14="http://schemas.microsoft.com/office/powerpoint/2010/main" val="2701932124"/>
+        <p14:creationId xmlns:p14="http://schemas.microsoft.com/office/powerpoint/2010/main" val="2657571568"/>
       </p:ext>
     </p:extLst>
   </p:cSld>
@@ -4014,7 +4014,7 @@
           <p:cNvPr id="2" name="날짜 개체 틀 1">
             <a:extLst>
               <a:ext uri="{FF2B5EF4-FFF2-40B4-BE49-F238E27FC236}">
-                <a16:creationId xmlns:a16="http://schemas.microsoft.com/office/drawing/2014/main" id="{6C865148-CA45-101F-D60F-4EB8929D16DE}"/>
+                <a16:creationId xmlns:a16="http://schemas.microsoft.com/office/drawing/2014/main" id="{5F280644-3890-8071-1C6E-048DE167C72B}"/>
               </a:ext>
             </a:extLst>
           </p:cNvPr>
@@ -4030,7 +4030,7 @@
           <a:bodyPr/>
           <a:lstStyle/>
           <a:p>
-            <a:fld id="{C8C06E2F-B4EF-437A-9E51-118F8D56CC4B}" type="datetimeFigureOut">
+            <a:fld id="{54D53126-3A36-4AFA-AA27-279399065AFC}" type="datetimeFigureOut">
               <a:rPr lang="ko-KR" altLang="en-US" smtClean="0"/>
               <a:t>2026-08-01</a:t>
             </a:fld>
@@ -4043,7 +4043,7 @@
           <p:cNvPr id="3" name="바닥글 개체 틀 2">
             <a:extLst>
               <a:ext uri="{FF2B5EF4-FFF2-40B4-BE49-F238E27FC236}">
-                <a16:creationId xmlns:a16="http://schemas.microsoft.com/office/drawing/2014/main" id="{6EFC17B8-DF53-58CA-285A-55D1B39251B5}"/>
+                <a16:creationId xmlns:a16="http://schemas.microsoft.com/office/drawing/2014/main" id="{8D7F5E67-D1D0-5037-C49B-8C50C7B046AB}"/>
               </a:ext>
             </a:extLst>
           </p:cNvPr>
@@ -4068,7 +4068,7 @@
           <p:cNvPr id="4" name="슬라이드 번호 개체 틀 3">
             <a:extLst>
               <a:ext uri="{FF2B5EF4-FFF2-40B4-BE49-F238E27FC236}">
-                <a16:creationId xmlns:a16="http://schemas.microsoft.com/office/drawing/2014/main" id="{19F7005A-71BC-7980-A1A4-B56090EC542B}"/>
+                <a16:creationId xmlns:a16="http://schemas.microsoft.com/office/drawing/2014/main" id="{32D16F65-0009-867C-5618-B64110E57738}"/>
               </a:ext>
             </a:extLst>
           </p:cNvPr>
@@ -4084,7 +4084,7 @@
           <a:bodyPr/>
           <a:lstStyle/>
           <a:p>
-            <a:fld id="{D169EEB6-6CAE-4EEF-8261-C376FD6834EF}" type="slidenum">
+            <a:fld id="{E99C0584-527A-4E61-8758-483310FDB539}" type="slidenum">
               <a:rPr lang="ko-KR" altLang="en-US" smtClean="0"/>
               <a:t>‹#›</a:t>
             </a:fld>
@@ -4095,7 +4095,7 @@
     </p:spTree>
     <p:extLst>
       <p:ext uri="{BB962C8B-B14F-4D97-AF65-F5344CB8AC3E}">
-        <p14:creationId xmlns:p14="http://schemas.microsoft.com/office/powerpoint/2010/main" val="2005609657"/>
+        <p14:creationId xmlns:p14="http://schemas.microsoft.com/office/powerpoint/2010/main" val="4253494801"/>
       </p:ext>
     </p:extLst>
   </p:cSld>
@@ -4127,7 +4127,7 @@
           <p:cNvPr id="2" name="제목 1">
             <a:extLst>
               <a:ext uri="{FF2B5EF4-FFF2-40B4-BE49-F238E27FC236}">
-                <a16:creationId xmlns:a16="http://schemas.microsoft.com/office/drawing/2014/main" id="{366BAD77-45B8-AC96-0EA1-2E60C7B5BBA5}"/>
+                <a16:creationId xmlns:a16="http://schemas.microsoft.com/office/drawing/2014/main" id="{0B1F2E18-6022-AD80-BCE3-53AC8FEA44EE}"/>
               </a:ext>
             </a:extLst>
           </p:cNvPr>
@@ -4164,7 +4164,7 @@
           <p:cNvPr id="3" name="내용 개체 틀 2">
             <a:extLst>
               <a:ext uri="{FF2B5EF4-FFF2-40B4-BE49-F238E27FC236}">
-                <a16:creationId xmlns:a16="http://schemas.microsoft.com/office/drawing/2014/main" id="{6B61BD9F-6BB9-C305-B381-DF8AF02C3FF9}"/>
+                <a16:creationId xmlns:a16="http://schemas.microsoft.com/office/drawing/2014/main" id="{EF66D560-063A-FE6C-E440-9887732AB2D1}"/>
               </a:ext>
             </a:extLst>
           </p:cNvPr>
@@ -4254,7 +4254,7 @@
           <p:cNvPr id="4" name="텍스트 개체 틀 3">
             <a:extLst>
               <a:ext uri="{FF2B5EF4-FFF2-40B4-BE49-F238E27FC236}">
-                <a16:creationId xmlns:a16="http://schemas.microsoft.com/office/drawing/2014/main" id="{0F9CAB7C-64F1-16A8-25A7-63133FA9F6C9}"/>
+                <a16:creationId xmlns:a16="http://schemas.microsoft.com/office/drawing/2014/main" id="{59D0017B-407E-B094-2D2E-AC8AF2E54360}"/>
               </a:ext>
             </a:extLst>
           </p:cNvPr>
@@ -4325,7 +4325,7 @@
           <p:cNvPr id="5" name="날짜 개체 틀 4">
             <a:extLst>
               <a:ext uri="{FF2B5EF4-FFF2-40B4-BE49-F238E27FC236}">
-                <a16:creationId xmlns:a16="http://schemas.microsoft.com/office/drawing/2014/main" id="{1A474888-CE21-0452-E602-8E6C60B4F277}"/>
+                <a16:creationId xmlns:a16="http://schemas.microsoft.com/office/drawing/2014/main" id="{109D4DE6-CD50-FF34-D72E-5A520D532015}"/>
               </a:ext>
             </a:extLst>
           </p:cNvPr>
@@ -4341,7 +4341,7 @@
           <a:bodyPr/>
           <a:lstStyle/>
           <a:p>
-            <a:fld id="{C8C06E2F-B4EF-437A-9E51-118F8D56CC4B}" type="datetimeFigureOut">
+            <a:fld id="{54D53126-3A36-4AFA-AA27-279399065AFC}" type="datetimeFigureOut">
               <a:rPr lang="ko-KR" altLang="en-US" smtClean="0"/>
               <a:t>2026-08-01</a:t>
             </a:fld>
@@ -4354,7 +4354,7 @@
           <p:cNvPr id="6" name="바닥글 개체 틀 5">
             <a:extLst>
               <a:ext uri="{FF2B5EF4-FFF2-40B4-BE49-F238E27FC236}">
-                <a16:creationId xmlns:a16="http://schemas.microsoft.com/office/drawing/2014/main" id="{FB156D34-3363-20C5-806D-8004C4FBBD2D}"/>
+                <a16:creationId xmlns:a16="http://schemas.microsoft.com/office/drawing/2014/main" id="{01B1D592-EE7E-7DC6-0AEB-AA239C87C09A}"/>
               </a:ext>
             </a:extLst>
           </p:cNvPr>
@@ -4379,7 +4379,7 @@
           <p:cNvPr id="7" name="슬라이드 번호 개체 틀 6">
             <a:extLst>
               <a:ext uri="{FF2B5EF4-FFF2-40B4-BE49-F238E27FC236}">
-                <a16:creationId xmlns:a16="http://schemas.microsoft.com/office/drawing/2014/main" id="{4BD288AB-5C9D-4D58-880D-6355C14EE212}"/>
+                <a16:creationId xmlns:a16="http://schemas.microsoft.com/office/drawing/2014/main" id="{C32FA210-4A46-7743-581C-C60179125BA3}"/>
               </a:ext>
             </a:extLst>
           </p:cNvPr>
@@ -4395,7 +4395,7 @@
           <a:bodyPr/>
           <a:lstStyle/>
           <a:p>
-            <a:fld id="{D169EEB6-6CAE-4EEF-8261-C376FD6834EF}" type="slidenum">
+            <a:fld id="{E99C0584-527A-4E61-8758-483310FDB539}" type="slidenum">
               <a:rPr lang="ko-KR" altLang="en-US" smtClean="0"/>
               <a:t>‹#›</a:t>
             </a:fld>
@@ -4406,7 +4406,7 @@
     </p:spTree>
     <p:extLst>
       <p:ext uri="{BB962C8B-B14F-4D97-AF65-F5344CB8AC3E}">
-        <p14:creationId xmlns:p14="http://schemas.microsoft.com/office/powerpoint/2010/main" val="2951562036"/>
+        <p14:creationId xmlns:p14="http://schemas.microsoft.com/office/powerpoint/2010/main" val="34373840"/>
       </p:ext>
     </p:extLst>
   </p:cSld>
@@ -4438,7 +4438,7 @@
           <p:cNvPr id="2" name="제목 1">
             <a:extLst>
               <a:ext uri="{FF2B5EF4-FFF2-40B4-BE49-F238E27FC236}">
-                <a16:creationId xmlns:a16="http://schemas.microsoft.com/office/drawing/2014/main" id="{1E37E66C-A4CF-6C25-A207-384828FB8010}"/>
+                <a16:creationId xmlns:a16="http://schemas.microsoft.com/office/drawing/2014/main" id="{B5D4799D-3ADC-9809-AD2F-4BA40313DE39}"/>
               </a:ext>
             </a:extLst>
           </p:cNvPr>
@@ -4475,7 +4475,7 @@
           <p:cNvPr id="3" name="그림 개체 틀 2">
             <a:extLst>
               <a:ext uri="{FF2B5EF4-FFF2-40B4-BE49-F238E27FC236}">
-                <a16:creationId xmlns:a16="http://schemas.microsoft.com/office/drawing/2014/main" id="{A122E380-88C5-BF24-4CEB-F18E418A44AA}"/>
+                <a16:creationId xmlns:a16="http://schemas.microsoft.com/office/drawing/2014/main" id="{2A2EE86A-F541-0189-39A9-25B3F60A420F}"/>
               </a:ext>
             </a:extLst>
           </p:cNvPr>
@@ -4542,7 +4542,7 @@
           <p:cNvPr id="4" name="텍스트 개체 틀 3">
             <a:extLst>
               <a:ext uri="{FF2B5EF4-FFF2-40B4-BE49-F238E27FC236}">
-                <a16:creationId xmlns:a16="http://schemas.microsoft.com/office/drawing/2014/main" id="{0A883835-87B8-5869-D635-3362B3B346CD}"/>
+                <a16:creationId xmlns:a16="http://schemas.microsoft.com/office/drawing/2014/main" id="{DE65EEB4-0EC8-05EC-EA88-B270DBD9417F}"/>
               </a:ext>
             </a:extLst>
           </p:cNvPr>
@@ -4613,7 +4613,7 @@
           <p:cNvPr id="5" name="날짜 개체 틀 4">
             <a:extLst>
               <a:ext uri="{FF2B5EF4-FFF2-40B4-BE49-F238E27FC236}">
-                <a16:creationId xmlns:a16="http://schemas.microsoft.com/office/drawing/2014/main" id="{3EF6C72C-6AD9-DBB8-985D-C0FEAED31DEB}"/>
+                <a16:creationId xmlns:a16="http://schemas.microsoft.com/office/drawing/2014/main" id="{73899533-CD70-05CF-12EF-287C45B48445}"/>
               </a:ext>
             </a:extLst>
           </p:cNvPr>
@@ -4629,7 +4629,7 @@
           <a:bodyPr/>
           <a:lstStyle/>
           <a:p>
-            <a:fld id="{C8C06E2F-B4EF-437A-9E51-118F8D56CC4B}" type="datetimeFigureOut">
+            <a:fld id="{54D53126-3A36-4AFA-AA27-279399065AFC}" type="datetimeFigureOut">
               <a:rPr lang="ko-KR" altLang="en-US" smtClean="0"/>
               <a:t>2026-08-01</a:t>
             </a:fld>
@@ -4642,7 +4642,7 @@
           <p:cNvPr id="6" name="바닥글 개체 틀 5">
             <a:extLst>
               <a:ext uri="{FF2B5EF4-FFF2-40B4-BE49-F238E27FC236}">
-                <a16:creationId xmlns:a16="http://schemas.microsoft.com/office/drawing/2014/main" id="{CEABDEB5-6405-F4DD-3457-70BF4A619337}"/>
+                <a16:creationId xmlns:a16="http://schemas.microsoft.com/office/drawing/2014/main" id="{E224EE9D-EB1F-6476-5EF9-A175BEC39B99}"/>
               </a:ext>
             </a:extLst>
           </p:cNvPr>
@@ -4667,7 +4667,7 @@
           <p:cNvPr id="7" name="슬라이드 번호 개체 틀 6">
             <a:extLst>
               <a:ext uri="{FF2B5EF4-FFF2-40B4-BE49-F238E27FC236}">
-                <a16:creationId xmlns:a16="http://schemas.microsoft.com/office/drawing/2014/main" id="{EE103DC1-A571-4FE9-5A2D-9EFA859812EE}"/>
+                <a16:creationId xmlns:a16="http://schemas.microsoft.com/office/drawing/2014/main" id="{8A3524EB-A387-B120-F686-D5CAB9A4F0E5}"/>
               </a:ext>
             </a:extLst>
           </p:cNvPr>
@@ -4683,7 +4683,7 @@
           <a:bodyPr/>
           <a:lstStyle/>
           <a:p>
-            <a:fld id="{D169EEB6-6CAE-4EEF-8261-C376FD6834EF}" type="slidenum">
+            <a:fld id="{E99C0584-527A-4E61-8758-483310FDB539}" type="slidenum">
               <a:rPr lang="ko-KR" altLang="en-US" smtClean="0"/>
               <a:t>‹#›</a:t>
             </a:fld>
@@ -4694,7 +4694,7 @@
     </p:spTree>
     <p:extLst>
       <p:ext uri="{BB962C8B-B14F-4D97-AF65-F5344CB8AC3E}">
-        <p14:creationId xmlns:p14="http://schemas.microsoft.com/office/powerpoint/2010/main" val="3177676608"/>
+        <p14:creationId xmlns:p14="http://schemas.microsoft.com/office/powerpoint/2010/main" val="4187440006"/>
       </p:ext>
     </p:extLst>
   </p:cSld>
@@ -4731,7 +4731,7 @@
           <p:cNvPr id="2" name="제목 개체 틀 1">
             <a:extLst>
               <a:ext uri="{FF2B5EF4-FFF2-40B4-BE49-F238E27FC236}">
-                <a16:creationId xmlns:a16="http://schemas.microsoft.com/office/drawing/2014/main" id="{0D287F27-D889-ADD1-1499-82B7B5DA07E4}"/>
+                <a16:creationId xmlns:a16="http://schemas.microsoft.com/office/drawing/2014/main" id="{09330BF4-1D5E-14A0-A68C-6E90046C65F0}"/>
               </a:ext>
             </a:extLst>
           </p:cNvPr>
@@ -4769,7 +4769,7 @@
           <p:cNvPr id="3" name="텍스트 개체 틀 2">
             <a:extLst>
               <a:ext uri="{FF2B5EF4-FFF2-40B4-BE49-F238E27FC236}">
-                <a16:creationId xmlns:a16="http://schemas.microsoft.com/office/drawing/2014/main" id="{E9620F8B-1D33-C6F7-944C-5FFC315B4728}"/>
+                <a16:creationId xmlns:a16="http://schemas.microsoft.com/office/drawing/2014/main" id="{CBF81DF8-344B-B908-3828-E930DE82EB0D}"/>
               </a:ext>
             </a:extLst>
           </p:cNvPr>
@@ -4836,7 +4836,7 @@
           <p:cNvPr id="4" name="날짜 개체 틀 3">
             <a:extLst>
               <a:ext uri="{FF2B5EF4-FFF2-40B4-BE49-F238E27FC236}">
-                <a16:creationId xmlns:a16="http://schemas.microsoft.com/office/drawing/2014/main" id="{2B1565CD-F492-78EB-65C1-B58412EED15B}"/>
+                <a16:creationId xmlns:a16="http://schemas.microsoft.com/office/drawing/2014/main" id="{DF49755D-828E-6023-1E40-C93098BD71B6}"/>
               </a:ext>
             </a:extLst>
           </p:cNvPr>
@@ -4870,7 +4870,7 @@
             </a:lvl1pPr>
           </a:lstStyle>
           <a:p>
-            <a:fld id="{C8C06E2F-B4EF-437A-9E51-118F8D56CC4B}" type="datetimeFigureOut">
+            <a:fld id="{54D53126-3A36-4AFA-AA27-279399065AFC}" type="datetimeFigureOut">
               <a:rPr lang="ko-KR" altLang="en-US" smtClean="0"/>
               <a:t>2026-08-01</a:t>
             </a:fld>
@@ -4883,7 +4883,7 @@
           <p:cNvPr id="5" name="바닥글 개체 틀 4">
             <a:extLst>
               <a:ext uri="{FF2B5EF4-FFF2-40B4-BE49-F238E27FC236}">
-                <a16:creationId xmlns:a16="http://schemas.microsoft.com/office/drawing/2014/main" id="{4F6CA89F-8BD5-C777-9500-0F27DAC10705}"/>
+                <a16:creationId xmlns:a16="http://schemas.microsoft.com/office/drawing/2014/main" id="{5E3CFE3E-002D-2EA7-DF9A-D2151A15EE84}"/>
               </a:ext>
             </a:extLst>
           </p:cNvPr>
@@ -4926,7 +4926,7 @@
           <p:cNvPr id="6" name="슬라이드 번호 개체 틀 5">
             <a:extLst>
               <a:ext uri="{FF2B5EF4-FFF2-40B4-BE49-F238E27FC236}">
-                <a16:creationId xmlns:a16="http://schemas.microsoft.com/office/drawing/2014/main" id="{7ABAE187-8D44-D993-6CCD-74E93DC65610}"/>
+                <a16:creationId xmlns:a16="http://schemas.microsoft.com/office/drawing/2014/main" id="{EB8D1EE6-2292-B135-161F-5EDFEE238E9D}"/>
               </a:ext>
             </a:extLst>
           </p:cNvPr>
@@ -4960,7 +4960,7 @@
             </a:lvl1pPr>
           </a:lstStyle>
           <a:p>
-            <a:fld id="{D169EEB6-6CAE-4EEF-8261-C376FD6834EF}" type="slidenum">
+            <a:fld id="{E99C0584-527A-4E61-8758-483310FDB539}" type="slidenum">
               <a:rPr lang="ko-KR" altLang="en-US" smtClean="0"/>
               <a:t>‹#›</a:t>
             </a:fld>
@@ -4971,7 +4971,7 @@
     </p:spTree>
     <p:extLst>
       <p:ext uri="{BB962C8B-B14F-4D97-AF65-F5344CB8AC3E}">
-        <p14:creationId xmlns:p14="http://schemas.microsoft.com/office/powerpoint/2010/main" val="1453963098"/>
+        <p14:creationId xmlns:p14="http://schemas.microsoft.com/office/powerpoint/2010/main" val="1002056339"/>
       </p:ext>
     </p:extLst>
   </p:cSld>
@@ -5302,7 +5302,7 @@
           <p:cNvPr id="2" name="직사각형 1">
             <a:extLst>
               <a:ext uri="{FF2B5EF4-FFF2-40B4-BE49-F238E27FC236}">
-                <a16:creationId xmlns:a16="http://schemas.microsoft.com/office/drawing/2014/main" id="{5BAD3F39-A0CA-DD95-939F-546E2C56A88E}"/>
+                <a16:creationId xmlns:a16="http://schemas.microsoft.com/office/drawing/2014/main" id="{148EDE32-35A5-54D8-56FB-0BF9EC88485C}"/>
               </a:ext>
             </a:extLst>
           </p:cNvPr>
@@ -5370,7 +5370,7 @@
           <p:cNvPr id="3" name="TextBox 2">
             <a:extLst>
               <a:ext uri="{FF2B5EF4-FFF2-40B4-BE49-F238E27FC236}">
-                <a16:creationId xmlns:a16="http://schemas.microsoft.com/office/drawing/2014/main" id="{8FB8D117-66F7-D7AA-43D0-0DC52BDBA621}"/>
+                <a16:creationId xmlns:a16="http://schemas.microsoft.com/office/drawing/2014/main" id="{2BB08343-A5DF-4656-1B41-9EA32C62B3CE}"/>
               </a:ext>
             </a:extLst>
           </p:cNvPr>
@@ -5419,7 +5419,7 @@
           <p:cNvPr id="4" name="TextBox 3">
             <a:extLst>
               <a:ext uri="{FF2B5EF4-FFF2-40B4-BE49-F238E27FC236}">
-                <a16:creationId xmlns:a16="http://schemas.microsoft.com/office/drawing/2014/main" id="{E81CC95B-194F-FB43-5D55-C9BD5ECB74CB}"/>
+                <a16:creationId xmlns:a16="http://schemas.microsoft.com/office/drawing/2014/main" id="{8299A25B-8487-23A9-692E-F4E27548A618}"/>
               </a:ext>
             </a:extLst>
           </p:cNvPr>
@@ -5497,7 +5497,7 @@
           <p:cNvPr id="5" name="TextBox 4">
             <a:extLst>
               <a:ext uri="{FF2B5EF4-FFF2-40B4-BE49-F238E27FC236}">
-                <a16:creationId xmlns:a16="http://schemas.microsoft.com/office/drawing/2014/main" id="{79A000E9-3BB8-C184-7799-926E4976A0F8}"/>
+                <a16:creationId xmlns:a16="http://schemas.microsoft.com/office/drawing/2014/main" id="{F48E9ADF-ACB5-D798-7229-41304D9F92C2}"/>
               </a:ext>
             </a:extLst>
           </p:cNvPr>
@@ -5591,7 +5591,7 @@
           <p:cNvPr id="6" name="직선 연결선 5">
             <a:extLst>
               <a:ext uri="{FF2B5EF4-FFF2-40B4-BE49-F238E27FC236}">
-                <a16:creationId xmlns:a16="http://schemas.microsoft.com/office/drawing/2014/main" id="{B059A17C-0233-0C76-47FB-5938638CFBB0}"/>
+                <a16:creationId xmlns:a16="http://schemas.microsoft.com/office/drawing/2014/main" id="{34FEA248-DE80-1EF8-3B78-19FBA83052E5}"/>
               </a:ext>
             </a:extLst>
           </p:cNvPr>
@@ -5633,7 +5633,7 @@
           <p:cNvPr id="7" name="사각형: 둥근 모서리 6">
             <a:extLst>
               <a:ext uri="{FF2B5EF4-FFF2-40B4-BE49-F238E27FC236}">
-                <a16:creationId xmlns:a16="http://schemas.microsoft.com/office/drawing/2014/main" id="{0332950D-C80E-3D28-F881-EFF154EFAC6A}"/>
+                <a16:creationId xmlns:a16="http://schemas.microsoft.com/office/drawing/2014/main" id="{E8B561FE-59DF-E503-1E36-15134B19535C}"/>
               </a:ext>
             </a:extLst>
           </p:cNvPr>
@@ -5701,7 +5701,7 @@
           <p:cNvPr id="8" name="TextBox 7">
             <a:extLst>
               <a:ext uri="{FF2B5EF4-FFF2-40B4-BE49-F238E27FC236}">
-                <a16:creationId xmlns:a16="http://schemas.microsoft.com/office/drawing/2014/main" id="{85C90256-DB4D-44B7-F21C-E2ABAFCD7929}"/>
+                <a16:creationId xmlns:a16="http://schemas.microsoft.com/office/drawing/2014/main" id="{ED6010F7-4A51-E92A-D28E-CE978A74598B}"/>
               </a:ext>
             </a:extLst>
           </p:cNvPr>
@@ -5757,7 +5757,7 @@
           <p:cNvPr id="9" name="직선 연결선 8">
             <a:extLst>
               <a:ext uri="{FF2B5EF4-FFF2-40B4-BE49-F238E27FC236}">
-                <a16:creationId xmlns:a16="http://schemas.microsoft.com/office/drawing/2014/main" id="{4A47D2F9-FB58-08AD-2FF2-39A87D976779}"/>
+                <a16:creationId xmlns:a16="http://schemas.microsoft.com/office/drawing/2014/main" id="{ADFC639A-E580-ED21-8717-EF4A4554FF03}"/>
               </a:ext>
             </a:extLst>
           </p:cNvPr>
@@ -5799,7 +5799,7 @@
           <p:cNvPr id="10" name="사각형: 둥근 모서리 9">
             <a:extLst>
               <a:ext uri="{FF2B5EF4-FFF2-40B4-BE49-F238E27FC236}">
-                <a16:creationId xmlns:a16="http://schemas.microsoft.com/office/drawing/2014/main" id="{40A7017B-2BCE-FABC-8092-CB9B6EB5F961}"/>
+                <a16:creationId xmlns:a16="http://schemas.microsoft.com/office/drawing/2014/main" id="{8C1D7C83-5FF5-AF7B-B990-877CFF3122B0}"/>
               </a:ext>
             </a:extLst>
           </p:cNvPr>
@@ -5867,7 +5867,7 @@
           <p:cNvPr id="11" name="TextBox 10">
             <a:extLst>
               <a:ext uri="{FF2B5EF4-FFF2-40B4-BE49-F238E27FC236}">
-                <a16:creationId xmlns:a16="http://schemas.microsoft.com/office/drawing/2014/main" id="{B8ADD14A-5EF8-B9A6-C453-690AD63E5A38}"/>
+                <a16:creationId xmlns:a16="http://schemas.microsoft.com/office/drawing/2014/main" id="{262FA546-3C60-4EEA-1F53-63FBBEA5A41C}"/>
               </a:ext>
             </a:extLst>
           </p:cNvPr>
@@ -5908,7 +5908,7 @@
           <p:cNvPr id="12" name="직선 연결선 11">
             <a:extLst>
               <a:ext uri="{FF2B5EF4-FFF2-40B4-BE49-F238E27FC236}">
-                <a16:creationId xmlns:a16="http://schemas.microsoft.com/office/drawing/2014/main" id="{3348394A-23FE-2275-50B3-4A302859FAC0}"/>
+                <a16:creationId xmlns:a16="http://schemas.microsoft.com/office/drawing/2014/main" id="{B0FDA0C8-0F63-C107-68E7-832E6F3AF824}"/>
               </a:ext>
             </a:extLst>
           </p:cNvPr>
@@ -5950,7 +5950,7 @@
           <p:cNvPr id="13" name="사각형: 둥근 모서리 12">
             <a:extLst>
               <a:ext uri="{FF2B5EF4-FFF2-40B4-BE49-F238E27FC236}">
-                <a16:creationId xmlns:a16="http://schemas.microsoft.com/office/drawing/2014/main" id="{652C03F7-490F-F7B8-85B9-6781BE2B4FE9}"/>
+                <a16:creationId xmlns:a16="http://schemas.microsoft.com/office/drawing/2014/main" id="{59EA468B-1EF7-4E67-D806-219D5D44B56F}"/>
               </a:ext>
             </a:extLst>
           </p:cNvPr>
@@ -6018,7 +6018,7 @@
           <p:cNvPr id="14" name="TextBox 13">
             <a:extLst>
               <a:ext uri="{FF2B5EF4-FFF2-40B4-BE49-F238E27FC236}">
-                <a16:creationId xmlns:a16="http://schemas.microsoft.com/office/drawing/2014/main" id="{5852A5E7-182C-2FE8-5F55-3E30A5619909}"/>
+                <a16:creationId xmlns:a16="http://schemas.microsoft.com/office/drawing/2014/main" id="{8B6B0C93-C84F-ABF9-606D-264164503004}"/>
               </a:ext>
             </a:extLst>
           </p:cNvPr>
@@ -6065,7 +6065,7 @@
           <p:cNvPr id="15" name="사각형: 둥근 모서리 14">
             <a:extLst>
               <a:ext uri="{FF2B5EF4-FFF2-40B4-BE49-F238E27FC236}">
-                <a16:creationId xmlns:a16="http://schemas.microsoft.com/office/drawing/2014/main" id="{BB03A70F-C1C7-5230-9324-4A9B0A100314}"/>
+                <a16:creationId xmlns:a16="http://schemas.microsoft.com/office/drawing/2014/main" id="{EE20C8E5-FE94-FE16-CCC9-6E3E64E82224}"/>
               </a:ext>
             </a:extLst>
           </p:cNvPr>
@@ -6133,7 +6133,7 @@
           <p:cNvPr id="16" name="TextBox 15">
             <a:extLst>
               <a:ext uri="{FF2B5EF4-FFF2-40B4-BE49-F238E27FC236}">
-                <a16:creationId xmlns:a16="http://schemas.microsoft.com/office/drawing/2014/main" id="{0438E4C3-23AD-F115-CFE7-DEC16332A93B}"/>
+                <a16:creationId xmlns:a16="http://schemas.microsoft.com/office/drawing/2014/main" id="{671E1227-66F3-2F1C-CEB0-E7D5E07B1C1C}"/>
               </a:ext>
             </a:extLst>
           </p:cNvPr>
@@ -6174,7 +6174,7 @@
           <p:cNvPr id="17" name="TextBox 16">
             <a:extLst>
               <a:ext uri="{FF2B5EF4-FFF2-40B4-BE49-F238E27FC236}">
-                <a16:creationId xmlns:a16="http://schemas.microsoft.com/office/drawing/2014/main" id="{FE09C92C-161F-A92B-57D7-E760960688A7}"/>
+                <a16:creationId xmlns:a16="http://schemas.microsoft.com/office/drawing/2014/main" id="{E5B6C94D-DFDD-192A-11CD-CDA8194C2D61}"/>
               </a:ext>
             </a:extLst>
           </p:cNvPr>
@@ -6283,7 +6283,7 @@
           <p:cNvPr id="18" name="TextBox 17">
             <a:extLst>
               <a:ext uri="{FF2B5EF4-FFF2-40B4-BE49-F238E27FC236}">
-                <a16:creationId xmlns:a16="http://schemas.microsoft.com/office/drawing/2014/main" id="{D1A96580-85A5-519D-51F9-AB18E5C72D33}"/>
+                <a16:creationId xmlns:a16="http://schemas.microsoft.com/office/drawing/2014/main" id="{5E39F52B-72B8-C68C-DE36-6DDF26BCD1DF}"/>
               </a:ext>
             </a:extLst>
           </p:cNvPr>
@@ -6354,7 +6354,7 @@
     </p:spTree>
     <p:extLst>
       <p:ext uri="{BB962C8B-B14F-4D97-AF65-F5344CB8AC3E}">
-        <p14:creationId xmlns:p14="http://schemas.microsoft.com/office/powerpoint/2010/main" val="3754480441"/>
+        <p14:creationId xmlns:p14="http://schemas.microsoft.com/office/powerpoint/2010/main" val="3867740366"/>
       </p:ext>
     </p:extLst>
   </p:cSld>
@@ -6386,7 +6386,7 @@
           <p:cNvPr id="2" name="TextBox 1">
             <a:extLst>
               <a:ext uri="{FF2B5EF4-FFF2-40B4-BE49-F238E27FC236}">
-                <a16:creationId xmlns:a16="http://schemas.microsoft.com/office/drawing/2014/main" id="{4CC6207A-7810-A4D5-0F9E-EA2328AE4B95}"/>
+                <a16:creationId xmlns:a16="http://schemas.microsoft.com/office/drawing/2014/main" id="{E4613EC3-41BB-32A6-7F51-A525A4BDAFD2}"/>
               </a:ext>
             </a:extLst>
           </p:cNvPr>
@@ -6435,7 +6435,7 @@
           <p:cNvPr id="3" name="TextBox 2">
             <a:extLst>
               <a:ext uri="{FF2B5EF4-FFF2-40B4-BE49-F238E27FC236}">
-                <a16:creationId xmlns:a16="http://schemas.microsoft.com/office/drawing/2014/main" id="{872A1C01-41CD-FCE7-C29B-4A6ED4E1C84F}"/>
+                <a16:creationId xmlns:a16="http://schemas.microsoft.com/office/drawing/2014/main" id="{8E435D40-048E-7B0E-0347-56588BA9424A}"/>
               </a:ext>
             </a:extLst>
           </p:cNvPr>
@@ -6475,7 +6475,7 @@
           <p:cNvPr id="4" name="직사각형 3">
             <a:extLst>
               <a:ext uri="{FF2B5EF4-FFF2-40B4-BE49-F238E27FC236}">
-                <a16:creationId xmlns:a16="http://schemas.microsoft.com/office/drawing/2014/main" id="{52E9EE6E-5031-14F7-098D-ED777D7882FC}"/>
+                <a16:creationId xmlns:a16="http://schemas.microsoft.com/office/drawing/2014/main" id="{180866E7-96D0-8C7D-ED38-57DB1A1132F0}"/>
               </a:ext>
             </a:extLst>
           </p:cNvPr>
@@ -6543,7 +6543,7 @@
           <p:cNvPr id="5" name="사각형: 둥근 모서리 4">
             <a:extLst>
               <a:ext uri="{FF2B5EF4-FFF2-40B4-BE49-F238E27FC236}">
-                <a16:creationId xmlns:a16="http://schemas.microsoft.com/office/drawing/2014/main" id="{3794A015-4861-5E51-E76C-8A86667BB221}"/>
+                <a16:creationId xmlns:a16="http://schemas.microsoft.com/office/drawing/2014/main" id="{AFB66A04-24D6-B1DA-6AC0-E20B30AC366C}"/>
               </a:ext>
             </a:extLst>
           </p:cNvPr>
@@ -6597,7 +6597,7 @@
           <p:cNvPr id="6" name="직사각형 5">
             <a:extLst>
               <a:ext uri="{FF2B5EF4-FFF2-40B4-BE49-F238E27FC236}">
-                <a16:creationId xmlns:a16="http://schemas.microsoft.com/office/drawing/2014/main" id="{F1653E4A-0E33-3DB1-38DA-2A265C03F31E}"/>
+                <a16:creationId xmlns:a16="http://schemas.microsoft.com/office/drawing/2014/main" id="{7E36EE38-C4BA-A6A5-C2FC-47863323DF2C}"/>
               </a:ext>
             </a:extLst>
           </p:cNvPr>
@@ -6665,7 +6665,7 @@
           <p:cNvPr id="7" name="TextBox 6">
             <a:extLst>
               <a:ext uri="{FF2B5EF4-FFF2-40B4-BE49-F238E27FC236}">
-                <a16:creationId xmlns:a16="http://schemas.microsoft.com/office/drawing/2014/main" id="{29197AB9-87C4-4535-F323-0A37787EE08A}"/>
+                <a16:creationId xmlns:a16="http://schemas.microsoft.com/office/drawing/2014/main" id="{6F3C569B-47EC-261C-19C8-427817A293C7}"/>
               </a:ext>
             </a:extLst>
           </p:cNvPr>
@@ -6711,7 +6711,7 @@
           <p:cNvPr id="8" name="TextBox 7">
             <a:extLst>
               <a:ext uri="{FF2B5EF4-FFF2-40B4-BE49-F238E27FC236}">
-                <a16:creationId xmlns:a16="http://schemas.microsoft.com/office/drawing/2014/main" id="{E593B2EF-5BB5-399B-888B-3AB2B93E64F8}"/>
+                <a16:creationId xmlns:a16="http://schemas.microsoft.com/office/drawing/2014/main" id="{5863B19E-BE97-A2F1-E35B-F84FD9CF2B92}"/>
               </a:ext>
             </a:extLst>
           </p:cNvPr>
@@ -6780,7 +6780,7 @@
           <p:cNvPr id="9" name="사각형: 둥근 모서리 8">
             <a:extLst>
               <a:ext uri="{FF2B5EF4-FFF2-40B4-BE49-F238E27FC236}">
-                <a16:creationId xmlns:a16="http://schemas.microsoft.com/office/drawing/2014/main" id="{ABAFC79B-2846-8F00-7581-767C0E411980}"/>
+                <a16:creationId xmlns:a16="http://schemas.microsoft.com/office/drawing/2014/main" id="{910C84F7-EB88-E832-F77D-3208E51AC520}"/>
               </a:ext>
             </a:extLst>
           </p:cNvPr>
@@ -6848,7 +6848,7 @@
           <p:cNvPr id="10" name="TextBox 9">
             <a:extLst>
               <a:ext uri="{FF2B5EF4-FFF2-40B4-BE49-F238E27FC236}">
-                <a16:creationId xmlns:a16="http://schemas.microsoft.com/office/drawing/2014/main" id="{3CC03A37-7242-58F9-8854-7560CA707ADA}"/>
+                <a16:creationId xmlns:a16="http://schemas.microsoft.com/office/drawing/2014/main" id="{7FBCBC36-E2F5-3DC2-8EC2-8D8D58483A49}"/>
               </a:ext>
             </a:extLst>
           </p:cNvPr>
@@ -6889,7 +6889,7 @@
           <p:cNvPr id="11" name="사각형: 둥근 모서리 10">
             <a:extLst>
               <a:ext uri="{FF2B5EF4-FFF2-40B4-BE49-F238E27FC236}">
-                <a16:creationId xmlns:a16="http://schemas.microsoft.com/office/drawing/2014/main" id="{B09849B9-488C-C3F9-DC53-BED3EF98288F}"/>
+                <a16:creationId xmlns:a16="http://schemas.microsoft.com/office/drawing/2014/main" id="{D9D348AA-27AD-F40F-FA8C-44F0F2DC2C6D}"/>
               </a:ext>
             </a:extLst>
           </p:cNvPr>
@@ -6943,7 +6943,7 @@
           <p:cNvPr id="12" name="직사각형 11">
             <a:extLst>
               <a:ext uri="{FF2B5EF4-FFF2-40B4-BE49-F238E27FC236}">
-                <a16:creationId xmlns:a16="http://schemas.microsoft.com/office/drawing/2014/main" id="{A5F95841-519D-75AD-7C42-7186165A0959}"/>
+                <a16:creationId xmlns:a16="http://schemas.microsoft.com/office/drawing/2014/main" id="{F7E3F1CA-FD3D-EB20-D871-03BAC30746E5}"/>
               </a:ext>
             </a:extLst>
           </p:cNvPr>
@@ -7011,7 +7011,7 @@
           <p:cNvPr id="13" name="TextBox 12">
             <a:extLst>
               <a:ext uri="{FF2B5EF4-FFF2-40B4-BE49-F238E27FC236}">
-                <a16:creationId xmlns:a16="http://schemas.microsoft.com/office/drawing/2014/main" id="{1C42F035-A693-3821-6629-6609415EAFEC}"/>
+                <a16:creationId xmlns:a16="http://schemas.microsoft.com/office/drawing/2014/main" id="{7FB3A3BD-5E0D-50DC-7F4E-BB2A60388BDF}"/>
               </a:ext>
             </a:extLst>
           </p:cNvPr>
@@ -7051,7 +7051,7 @@
           <p:cNvPr id="14" name="TextBox 13">
             <a:extLst>
               <a:ext uri="{FF2B5EF4-FFF2-40B4-BE49-F238E27FC236}">
-                <a16:creationId xmlns:a16="http://schemas.microsoft.com/office/drawing/2014/main" id="{4A828D40-D4E8-8602-E6C4-CAEA6F6F0501}"/>
+                <a16:creationId xmlns:a16="http://schemas.microsoft.com/office/drawing/2014/main" id="{166EB416-8566-FB8A-4DB2-1E82D189F423}"/>
               </a:ext>
             </a:extLst>
           </p:cNvPr>
@@ -7120,7 +7120,7 @@
           <p:cNvPr id="15" name="사각형: 둥근 모서리 14">
             <a:extLst>
               <a:ext uri="{FF2B5EF4-FFF2-40B4-BE49-F238E27FC236}">
-                <a16:creationId xmlns:a16="http://schemas.microsoft.com/office/drawing/2014/main" id="{7540C7C2-6DFC-DAF4-6CD7-6E064F0EE0E4}"/>
+                <a16:creationId xmlns:a16="http://schemas.microsoft.com/office/drawing/2014/main" id="{D2ADABFE-FD69-CA40-58AD-B9BB8BCCBA3E}"/>
               </a:ext>
             </a:extLst>
           </p:cNvPr>
@@ -7188,7 +7188,7 @@
           <p:cNvPr id="16" name="TextBox 15">
             <a:extLst>
               <a:ext uri="{FF2B5EF4-FFF2-40B4-BE49-F238E27FC236}">
-                <a16:creationId xmlns:a16="http://schemas.microsoft.com/office/drawing/2014/main" id="{AA4959D0-B890-02F9-1E13-D5CFAE05DB9C}"/>
+                <a16:creationId xmlns:a16="http://schemas.microsoft.com/office/drawing/2014/main" id="{A67158D9-12BF-E1DC-718E-79259E2386DC}"/>
               </a:ext>
             </a:extLst>
           </p:cNvPr>
@@ -7229,7 +7229,7 @@
           <p:cNvPr id="17" name="사각형: 둥근 모서리 16">
             <a:extLst>
               <a:ext uri="{FF2B5EF4-FFF2-40B4-BE49-F238E27FC236}">
-                <a16:creationId xmlns:a16="http://schemas.microsoft.com/office/drawing/2014/main" id="{330C3064-73B5-A4A3-4EC3-8545AEF62D9F}"/>
+                <a16:creationId xmlns:a16="http://schemas.microsoft.com/office/drawing/2014/main" id="{0F97102E-CEA2-D794-0832-8712506A8C1D}"/>
               </a:ext>
             </a:extLst>
           </p:cNvPr>
@@ -7283,7 +7283,7 @@
           <p:cNvPr id="18" name="직사각형 17">
             <a:extLst>
               <a:ext uri="{FF2B5EF4-FFF2-40B4-BE49-F238E27FC236}">
-                <a16:creationId xmlns:a16="http://schemas.microsoft.com/office/drawing/2014/main" id="{8CA53C5B-68EB-9C5E-30B1-16BD79F28F55}"/>
+                <a16:creationId xmlns:a16="http://schemas.microsoft.com/office/drawing/2014/main" id="{469B3D92-34AD-B499-2884-D974B01CA120}"/>
               </a:ext>
             </a:extLst>
           </p:cNvPr>
@@ -7351,7 +7351,7 @@
           <p:cNvPr id="19" name="TextBox 18">
             <a:extLst>
               <a:ext uri="{FF2B5EF4-FFF2-40B4-BE49-F238E27FC236}">
-                <a16:creationId xmlns:a16="http://schemas.microsoft.com/office/drawing/2014/main" id="{CC14D19B-B5C1-3F16-6139-2CC6D794130D}"/>
+                <a16:creationId xmlns:a16="http://schemas.microsoft.com/office/drawing/2014/main" id="{A35E07A2-6602-7A18-702F-B60C4658BE09}"/>
               </a:ext>
             </a:extLst>
           </p:cNvPr>
@@ -7397,7 +7397,7 @@
           <p:cNvPr id="20" name="TextBox 19">
             <a:extLst>
               <a:ext uri="{FF2B5EF4-FFF2-40B4-BE49-F238E27FC236}">
-                <a16:creationId xmlns:a16="http://schemas.microsoft.com/office/drawing/2014/main" id="{4AC61E1A-4225-2C4B-7E55-36A0EA3189F7}"/>
+                <a16:creationId xmlns:a16="http://schemas.microsoft.com/office/drawing/2014/main" id="{26CB604B-AB94-93F3-BBEC-2103C740ACE3}"/>
               </a:ext>
             </a:extLst>
           </p:cNvPr>
@@ -7466,7 +7466,7 @@
           <p:cNvPr id="21" name="사각형: 둥근 모서리 20">
             <a:extLst>
               <a:ext uri="{FF2B5EF4-FFF2-40B4-BE49-F238E27FC236}">
-                <a16:creationId xmlns:a16="http://schemas.microsoft.com/office/drawing/2014/main" id="{D877E2E6-73EC-CBA3-3BAB-1DC4484124A7}"/>
+                <a16:creationId xmlns:a16="http://schemas.microsoft.com/office/drawing/2014/main" id="{05EDE740-B461-B186-5EA7-F7041E7899F6}"/>
               </a:ext>
             </a:extLst>
           </p:cNvPr>
@@ -7534,7 +7534,7 @@
           <p:cNvPr id="22" name="TextBox 21">
             <a:extLst>
               <a:ext uri="{FF2B5EF4-FFF2-40B4-BE49-F238E27FC236}">
-                <a16:creationId xmlns:a16="http://schemas.microsoft.com/office/drawing/2014/main" id="{8010F678-4611-629D-724A-702F479382B2}"/>
+                <a16:creationId xmlns:a16="http://schemas.microsoft.com/office/drawing/2014/main" id="{96C6EBB2-5E45-E884-C1FA-2F0958C494DC}"/>
               </a:ext>
             </a:extLst>
           </p:cNvPr>
@@ -7575,7 +7575,7 @@
           <p:cNvPr id="23" name="사각형: 둥근 모서리 22">
             <a:extLst>
               <a:ext uri="{FF2B5EF4-FFF2-40B4-BE49-F238E27FC236}">
-                <a16:creationId xmlns:a16="http://schemas.microsoft.com/office/drawing/2014/main" id="{A5A6E917-4FF6-EF26-0211-605F1C8B6937}"/>
+                <a16:creationId xmlns:a16="http://schemas.microsoft.com/office/drawing/2014/main" id="{E766B37F-34D6-34D9-123C-0FCFAD113325}"/>
               </a:ext>
             </a:extLst>
           </p:cNvPr>
@@ -7643,7 +7643,7 @@
           <p:cNvPr id="24" name="TextBox 23">
             <a:extLst>
               <a:ext uri="{FF2B5EF4-FFF2-40B4-BE49-F238E27FC236}">
-                <a16:creationId xmlns:a16="http://schemas.microsoft.com/office/drawing/2014/main" id="{58ABA72F-C7E9-F10B-9377-26DBB7A7D91E}"/>
+                <a16:creationId xmlns:a16="http://schemas.microsoft.com/office/drawing/2014/main" id="{C2ED71FB-3C7F-C59E-E6CF-A6316B3DF836}"/>
               </a:ext>
             </a:extLst>
           </p:cNvPr>
@@ -7698,7 +7698,7 @@
           <p:cNvPr id="25" name="TextBox 24">
             <a:extLst>
               <a:ext uri="{FF2B5EF4-FFF2-40B4-BE49-F238E27FC236}">
-                <a16:creationId xmlns:a16="http://schemas.microsoft.com/office/drawing/2014/main" id="{2B850E4A-03FC-CED3-225C-0403EFBE3B36}"/>
+                <a16:creationId xmlns:a16="http://schemas.microsoft.com/office/drawing/2014/main" id="{6AE607B6-665D-06D3-C2E8-AB53AF552C40}"/>
               </a:ext>
             </a:extLst>
           </p:cNvPr>
@@ -7783,7 +7783,7 @@
           <p:cNvPr id="26" name="직선 연결선 25">
             <a:extLst>
               <a:ext uri="{FF2B5EF4-FFF2-40B4-BE49-F238E27FC236}">
-                <a16:creationId xmlns:a16="http://schemas.microsoft.com/office/drawing/2014/main" id="{F790002F-B6F4-3209-6193-00AB31E56996}"/>
+                <a16:creationId xmlns:a16="http://schemas.microsoft.com/office/drawing/2014/main" id="{6BEF05E9-9915-9C4E-0204-88D15359E092}"/>
               </a:ext>
             </a:extLst>
           </p:cNvPr>
@@ -7824,7 +7824,7 @@
           <p:cNvPr id="27" name="TextBox 26">
             <a:extLst>
               <a:ext uri="{FF2B5EF4-FFF2-40B4-BE49-F238E27FC236}">
-                <a16:creationId xmlns:a16="http://schemas.microsoft.com/office/drawing/2014/main" id="{0687109B-D55A-B504-78EC-C48ED0B320EC}"/>
+                <a16:creationId xmlns:a16="http://schemas.microsoft.com/office/drawing/2014/main" id="{2E960E32-2DAE-9766-18E5-29C33A7FD5CF}"/>
               </a:ext>
             </a:extLst>
           </p:cNvPr>
@@ -7909,7 +7909,7 @@
           <p:cNvPr id="28" name="TextBox 27">
             <a:extLst>
               <a:ext uri="{FF2B5EF4-FFF2-40B4-BE49-F238E27FC236}">
-                <a16:creationId xmlns:a16="http://schemas.microsoft.com/office/drawing/2014/main" id="{FCC03D8E-6028-6C0F-882C-61911B372C9C}"/>
+                <a16:creationId xmlns:a16="http://schemas.microsoft.com/office/drawing/2014/main" id="{111F3BFA-710D-6FAE-972B-C5BA5C383C99}"/>
               </a:ext>
             </a:extLst>
           </p:cNvPr>
@@ -7954,7 +7954,7 @@
     </p:spTree>
     <p:extLst>
       <p:ext uri="{BB962C8B-B14F-4D97-AF65-F5344CB8AC3E}">
-        <p14:creationId xmlns:p14="http://schemas.microsoft.com/office/powerpoint/2010/main" val="1638033542"/>
+        <p14:creationId xmlns:p14="http://schemas.microsoft.com/office/powerpoint/2010/main" val="567179940"/>
       </p:ext>
     </p:extLst>
   </p:cSld>
@@ -7986,7 +7986,7 @@
           <p:cNvPr id="2" name="TextBox 1">
             <a:extLst>
               <a:ext uri="{FF2B5EF4-FFF2-40B4-BE49-F238E27FC236}">
-                <a16:creationId xmlns:a16="http://schemas.microsoft.com/office/drawing/2014/main" id="{AA2140B5-7D57-1823-ED22-E1557BA6E560}"/>
+                <a16:creationId xmlns:a16="http://schemas.microsoft.com/office/drawing/2014/main" id="{3577198D-7F21-478B-B985-83AB7B0BF78C}"/>
               </a:ext>
             </a:extLst>
           </p:cNvPr>
@@ -8035,7 +8035,7 @@
           <p:cNvPr id="3" name="TextBox 2">
             <a:extLst>
               <a:ext uri="{FF2B5EF4-FFF2-40B4-BE49-F238E27FC236}">
-                <a16:creationId xmlns:a16="http://schemas.microsoft.com/office/drawing/2014/main" id="{808B374C-42E4-4AA1-6790-C50F40ED222A}"/>
+                <a16:creationId xmlns:a16="http://schemas.microsoft.com/office/drawing/2014/main" id="{0C3BB02E-FA9E-B1D2-593A-81F9D90F6CB7}"/>
               </a:ext>
             </a:extLst>
           </p:cNvPr>
@@ -8093,7 +8093,7 @@
           <p:cNvPr id="4" name="직사각형 3">
             <a:extLst>
               <a:ext uri="{FF2B5EF4-FFF2-40B4-BE49-F238E27FC236}">
-                <a16:creationId xmlns:a16="http://schemas.microsoft.com/office/drawing/2014/main" id="{5AFC7C95-DC3C-024B-785B-104B03FB46DD}"/>
+                <a16:creationId xmlns:a16="http://schemas.microsoft.com/office/drawing/2014/main" id="{AB4E2641-0EA7-B65C-3A9C-D3AD9FB57ED8}"/>
               </a:ext>
             </a:extLst>
           </p:cNvPr>
@@ -8161,7 +8161,7 @@
           <p:cNvPr id="5" name="TextBox 4">
             <a:extLst>
               <a:ext uri="{FF2B5EF4-FFF2-40B4-BE49-F238E27FC236}">
-                <a16:creationId xmlns:a16="http://schemas.microsoft.com/office/drawing/2014/main" id="{5059151A-C650-DC22-E594-54851B9BCDEF}"/>
+                <a16:creationId xmlns:a16="http://schemas.microsoft.com/office/drawing/2014/main" id="{FED3EDBC-31B2-98C3-AFC8-9383B8F19CF7}"/>
               </a:ext>
             </a:extLst>
           </p:cNvPr>
@@ -8201,7 +8201,7 @@
           <p:cNvPr id="6" name="TextBox 5">
             <a:extLst>
               <a:ext uri="{FF2B5EF4-FFF2-40B4-BE49-F238E27FC236}">
-                <a16:creationId xmlns:a16="http://schemas.microsoft.com/office/drawing/2014/main" id="{93A1277D-5D91-A381-F7E9-8B50D3357400}"/>
+                <a16:creationId xmlns:a16="http://schemas.microsoft.com/office/drawing/2014/main" id="{05CF9C47-2064-C1F1-2CD7-CC40414DBA27}"/>
               </a:ext>
             </a:extLst>
           </p:cNvPr>
@@ -8331,7 +8331,7 @@
           <p:cNvPr id="7" name="직선 연결선 6">
             <a:extLst>
               <a:ext uri="{FF2B5EF4-FFF2-40B4-BE49-F238E27FC236}">
-                <a16:creationId xmlns:a16="http://schemas.microsoft.com/office/drawing/2014/main" id="{F5B5B233-3D94-161C-D606-B92140422532}"/>
+                <a16:creationId xmlns:a16="http://schemas.microsoft.com/office/drawing/2014/main" id="{26428EE5-74BB-4CBA-C142-E94A8B8A86B7}"/>
               </a:ext>
             </a:extLst>
           </p:cNvPr>
@@ -8372,7 +8372,7 @@
           <p:cNvPr id="8" name="TextBox 7">
             <a:extLst>
               <a:ext uri="{FF2B5EF4-FFF2-40B4-BE49-F238E27FC236}">
-                <a16:creationId xmlns:a16="http://schemas.microsoft.com/office/drawing/2014/main" id="{01EAF25E-935E-B123-7949-5EB80DE9AD4C}"/>
+                <a16:creationId xmlns:a16="http://schemas.microsoft.com/office/drawing/2014/main" id="{27FF03EB-6BF9-8054-BDA3-D7026C93DB5A}"/>
               </a:ext>
             </a:extLst>
           </p:cNvPr>
@@ -8418,7 +8418,7 @@
           <p:cNvPr id="9" name="TextBox 8">
             <a:extLst>
               <a:ext uri="{FF2B5EF4-FFF2-40B4-BE49-F238E27FC236}">
-                <a16:creationId xmlns:a16="http://schemas.microsoft.com/office/drawing/2014/main" id="{E14913F5-A376-E2FD-B4B5-EBF10FA065A5}"/>
+                <a16:creationId xmlns:a16="http://schemas.microsoft.com/office/drawing/2014/main" id="{9ABD6D39-DCBF-3A98-37AE-BBB2CFBBA1F8}"/>
               </a:ext>
             </a:extLst>
           </p:cNvPr>
@@ -8458,7 +8458,7 @@
           <p:cNvPr id="10" name="TextBox 9">
             <a:extLst>
               <a:ext uri="{FF2B5EF4-FFF2-40B4-BE49-F238E27FC236}">
-                <a16:creationId xmlns:a16="http://schemas.microsoft.com/office/drawing/2014/main" id="{7A4A4AE7-7480-BFAD-EDDB-AAF5EED6516C}"/>
+                <a16:creationId xmlns:a16="http://schemas.microsoft.com/office/drawing/2014/main" id="{95EDA357-790D-7CD6-AED5-25C2FB05F3E5}"/>
               </a:ext>
             </a:extLst>
           </p:cNvPr>
@@ -8516,7 +8516,7 @@
           <p:cNvPr id="11" name="TextBox 10">
             <a:extLst>
               <a:ext uri="{FF2B5EF4-FFF2-40B4-BE49-F238E27FC236}">
-                <a16:creationId xmlns:a16="http://schemas.microsoft.com/office/drawing/2014/main" id="{60B6C0A4-FDBB-067F-1BA7-2F0473E8430C}"/>
+                <a16:creationId xmlns:a16="http://schemas.microsoft.com/office/drawing/2014/main" id="{727EDDA5-4136-9234-8808-D2C6BFC9B260}"/>
               </a:ext>
             </a:extLst>
           </p:cNvPr>
@@ -8562,7 +8562,7 @@
           <p:cNvPr id="12" name="TextBox 11">
             <a:extLst>
               <a:ext uri="{FF2B5EF4-FFF2-40B4-BE49-F238E27FC236}">
-                <a16:creationId xmlns:a16="http://schemas.microsoft.com/office/drawing/2014/main" id="{1CCBBDB4-7B5F-1BA3-3077-5198FCDF2A50}"/>
+                <a16:creationId xmlns:a16="http://schemas.microsoft.com/office/drawing/2014/main" id="{F400C0CB-9566-4FE1-8E7E-17F3C79DAFCE}"/>
               </a:ext>
             </a:extLst>
           </p:cNvPr>
@@ -8602,7 +8602,7 @@
           <p:cNvPr id="13" name="TextBox 12">
             <a:extLst>
               <a:ext uri="{FF2B5EF4-FFF2-40B4-BE49-F238E27FC236}">
-                <a16:creationId xmlns:a16="http://schemas.microsoft.com/office/drawing/2014/main" id="{7E7E3518-30F2-A304-B91A-FC0127E40438}"/>
+                <a16:creationId xmlns:a16="http://schemas.microsoft.com/office/drawing/2014/main" id="{D0D88283-AB77-E5EE-2C0B-86D22CD99DF8}"/>
               </a:ext>
             </a:extLst>
           </p:cNvPr>
@@ -8660,7 +8660,7 @@
           <p:cNvPr id="14" name="TextBox 13">
             <a:extLst>
               <a:ext uri="{FF2B5EF4-FFF2-40B4-BE49-F238E27FC236}">
-                <a16:creationId xmlns:a16="http://schemas.microsoft.com/office/drawing/2014/main" id="{64F5F440-119E-6AA7-4CCE-5567372BD623}"/>
+                <a16:creationId xmlns:a16="http://schemas.microsoft.com/office/drawing/2014/main" id="{D6A060FF-C249-44F3-BC4E-B23E6314B686}"/>
               </a:ext>
             </a:extLst>
           </p:cNvPr>
@@ -8706,7 +8706,7 @@
           <p:cNvPr id="15" name="TextBox 14">
             <a:extLst>
               <a:ext uri="{FF2B5EF4-FFF2-40B4-BE49-F238E27FC236}">
-                <a16:creationId xmlns:a16="http://schemas.microsoft.com/office/drawing/2014/main" id="{043339AC-AAA1-59EA-1D1F-8091AD511AD8}"/>
+                <a16:creationId xmlns:a16="http://schemas.microsoft.com/office/drawing/2014/main" id="{EE7126FB-A05D-B84A-6F9A-AA0CADA13C54}"/>
               </a:ext>
             </a:extLst>
           </p:cNvPr>
@@ -8746,7 +8746,7 @@
           <p:cNvPr id="16" name="TextBox 15">
             <a:extLst>
               <a:ext uri="{FF2B5EF4-FFF2-40B4-BE49-F238E27FC236}">
-                <a16:creationId xmlns:a16="http://schemas.microsoft.com/office/drawing/2014/main" id="{45180540-81DE-5EF2-88CE-36A02600E73F}"/>
+                <a16:creationId xmlns:a16="http://schemas.microsoft.com/office/drawing/2014/main" id="{DBD461AD-7186-96A5-427E-7E047311267E}"/>
               </a:ext>
             </a:extLst>
           </p:cNvPr>
@@ -8804,7 +8804,7 @@
           <p:cNvPr id="17" name="TextBox 16">
             <a:extLst>
               <a:ext uri="{FF2B5EF4-FFF2-40B4-BE49-F238E27FC236}">
-                <a16:creationId xmlns:a16="http://schemas.microsoft.com/office/drawing/2014/main" id="{FC0BEDF5-6EE5-BBAD-43BE-5BF9578BAB23}"/>
+                <a16:creationId xmlns:a16="http://schemas.microsoft.com/office/drawing/2014/main" id="{C59E9F84-7C95-1115-DC94-C8E563B7E9C8}"/>
               </a:ext>
             </a:extLst>
           </p:cNvPr>
@@ -8850,7 +8850,7 @@
           <p:cNvPr id="18" name="TextBox 17">
             <a:extLst>
               <a:ext uri="{FF2B5EF4-FFF2-40B4-BE49-F238E27FC236}">
-                <a16:creationId xmlns:a16="http://schemas.microsoft.com/office/drawing/2014/main" id="{0B6D07B5-B4BE-5E59-657D-401B21838AB1}"/>
+                <a16:creationId xmlns:a16="http://schemas.microsoft.com/office/drawing/2014/main" id="{261CF465-4322-0165-9B87-090F970510DE}"/>
               </a:ext>
             </a:extLst>
           </p:cNvPr>
@@ -8890,7 +8890,7 @@
           <p:cNvPr id="19" name="TextBox 18">
             <a:extLst>
               <a:ext uri="{FF2B5EF4-FFF2-40B4-BE49-F238E27FC236}">
-                <a16:creationId xmlns:a16="http://schemas.microsoft.com/office/drawing/2014/main" id="{F3CD743A-17D0-4F9F-CDAC-E4BE533EDE59}"/>
+                <a16:creationId xmlns:a16="http://schemas.microsoft.com/office/drawing/2014/main" id="{3B15A990-8F5F-03A7-E0CD-EB64130D675E}"/>
               </a:ext>
             </a:extLst>
           </p:cNvPr>
@@ -8966,7 +8966,7 @@
           <p:cNvPr id="20" name="TextBox 19">
             <a:extLst>
               <a:ext uri="{FF2B5EF4-FFF2-40B4-BE49-F238E27FC236}">
-                <a16:creationId xmlns:a16="http://schemas.microsoft.com/office/drawing/2014/main" id="{7CCD9A04-2261-AEC5-8DA5-C80D156BE851}"/>
+                <a16:creationId xmlns:a16="http://schemas.microsoft.com/office/drawing/2014/main" id="{EB4BBC09-1C1B-394F-A613-A2EA48D264EA}"/>
               </a:ext>
             </a:extLst>
           </p:cNvPr>
@@ -9040,7 +9040,7 @@
           <p:cNvPr id="21" name="직선 연결선 20">
             <a:extLst>
               <a:ext uri="{FF2B5EF4-FFF2-40B4-BE49-F238E27FC236}">
-                <a16:creationId xmlns:a16="http://schemas.microsoft.com/office/drawing/2014/main" id="{EDB87837-218A-5BAF-4BA0-8B5E9FE5B062}"/>
+                <a16:creationId xmlns:a16="http://schemas.microsoft.com/office/drawing/2014/main" id="{3ECF2724-55A9-5FE4-EB27-8A199B24CBCE}"/>
               </a:ext>
             </a:extLst>
           </p:cNvPr>
@@ -9081,7 +9081,7 @@
           <p:cNvPr id="22" name="TextBox 21">
             <a:extLst>
               <a:ext uri="{FF2B5EF4-FFF2-40B4-BE49-F238E27FC236}">
-                <a16:creationId xmlns:a16="http://schemas.microsoft.com/office/drawing/2014/main" id="{9BDE4B27-DDAD-4DDC-CE05-49C8E7DEC61B}"/>
+                <a16:creationId xmlns:a16="http://schemas.microsoft.com/office/drawing/2014/main" id="{54B5E6D2-3F16-66A8-6EEE-0AC7AF550090}"/>
               </a:ext>
             </a:extLst>
           </p:cNvPr>
@@ -9166,7 +9166,7 @@
           <p:cNvPr id="23" name="TextBox 22">
             <a:extLst>
               <a:ext uri="{FF2B5EF4-FFF2-40B4-BE49-F238E27FC236}">
-                <a16:creationId xmlns:a16="http://schemas.microsoft.com/office/drawing/2014/main" id="{C8B2FBBF-26A0-77F2-87F8-66A539FDCB07}"/>
+                <a16:creationId xmlns:a16="http://schemas.microsoft.com/office/drawing/2014/main" id="{4B78F22C-ECD1-3803-93D3-16BC9C2AFA8C}"/>
               </a:ext>
             </a:extLst>
           </p:cNvPr>
@@ -9211,7 +9211,7 @@
     </p:spTree>
     <p:extLst>
       <p:ext uri="{BB962C8B-B14F-4D97-AF65-F5344CB8AC3E}">
-        <p14:creationId xmlns:p14="http://schemas.microsoft.com/office/powerpoint/2010/main" val="966414222"/>
+        <p14:creationId xmlns:p14="http://schemas.microsoft.com/office/powerpoint/2010/main" val="1312995670"/>
       </p:ext>
     </p:extLst>
   </p:cSld>
@@ -9243,7 +9243,7 @@
           <p:cNvPr id="2" name="TextBox 1">
             <a:extLst>
               <a:ext uri="{FF2B5EF4-FFF2-40B4-BE49-F238E27FC236}">
-                <a16:creationId xmlns:a16="http://schemas.microsoft.com/office/drawing/2014/main" id="{D225F05F-81C0-EE4E-AC88-0A3F29D3110C}"/>
+                <a16:creationId xmlns:a16="http://schemas.microsoft.com/office/drawing/2014/main" id="{3D3C0AAC-B06D-B883-C7F6-BDFC977686A0}"/>
               </a:ext>
             </a:extLst>
           </p:cNvPr>
@@ -9292,7 +9292,7 @@
           <p:cNvPr id="3" name="TextBox 2">
             <a:extLst>
               <a:ext uri="{FF2B5EF4-FFF2-40B4-BE49-F238E27FC236}">
-                <a16:creationId xmlns:a16="http://schemas.microsoft.com/office/drawing/2014/main" id="{EBA34847-209F-746D-86A0-2C6D60686BE7}"/>
+                <a16:creationId xmlns:a16="http://schemas.microsoft.com/office/drawing/2014/main" id="{BD06B112-E302-BCC9-FC5C-20FB440E9EA0}"/>
               </a:ext>
             </a:extLst>
           </p:cNvPr>
@@ -9368,7 +9368,7 @@
           <p:cNvPr id="4" name="직사각형 3">
             <a:extLst>
               <a:ext uri="{FF2B5EF4-FFF2-40B4-BE49-F238E27FC236}">
-                <a16:creationId xmlns:a16="http://schemas.microsoft.com/office/drawing/2014/main" id="{ECCBE036-41AF-5002-C32A-358302993367}"/>
+                <a16:creationId xmlns:a16="http://schemas.microsoft.com/office/drawing/2014/main" id="{52947C09-0A82-8F41-CC08-4A43D51CF65E}"/>
               </a:ext>
             </a:extLst>
           </p:cNvPr>
@@ -9436,7 +9436,7 @@
           <p:cNvPr id="5" name="직선 연결선 4">
             <a:extLst>
               <a:ext uri="{FF2B5EF4-FFF2-40B4-BE49-F238E27FC236}">
-                <a16:creationId xmlns:a16="http://schemas.microsoft.com/office/drawing/2014/main" id="{0FF387E3-80FF-743F-E6C6-56510C959371}"/>
+                <a16:creationId xmlns:a16="http://schemas.microsoft.com/office/drawing/2014/main" id="{6D40A1E3-0AAE-5EFC-D001-F286CB1B52CD}"/>
               </a:ext>
             </a:extLst>
           </p:cNvPr>
@@ -9478,7 +9478,7 @@
           <p:cNvPr id="6" name="사각형: 둥근 모서리 5">
             <a:extLst>
               <a:ext uri="{FF2B5EF4-FFF2-40B4-BE49-F238E27FC236}">
-                <a16:creationId xmlns:a16="http://schemas.microsoft.com/office/drawing/2014/main" id="{7C84061A-EF1E-DC73-0A7B-B0316B31A624}"/>
+                <a16:creationId xmlns:a16="http://schemas.microsoft.com/office/drawing/2014/main" id="{8BEBA8E4-9FFE-1F16-E24F-6FD8C0B1EC0C}"/>
               </a:ext>
             </a:extLst>
           </p:cNvPr>
@@ -9546,7 +9546,7 @@
           <p:cNvPr id="7" name="사각형: 둥근 모서리 6">
             <a:extLst>
               <a:ext uri="{FF2B5EF4-FFF2-40B4-BE49-F238E27FC236}">
-                <a16:creationId xmlns:a16="http://schemas.microsoft.com/office/drawing/2014/main" id="{0D0C5AE4-AC99-ED05-5795-F1C22F7D3096}"/>
+                <a16:creationId xmlns:a16="http://schemas.microsoft.com/office/drawing/2014/main" id="{225BAC9C-F202-B7AC-8740-C36C08979D63}"/>
               </a:ext>
             </a:extLst>
           </p:cNvPr>
@@ -9614,7 +9614,7 @@
           <p:cNvPr id="8" name="TextBox 7">
             <a:extLst>
               <a:ext uri="{FF2B5EF4-FFF2-40B4-BE49-F238E27FC236}">
-                <a16:creationId xmlns:a16="http://schemas.microsoft.com/office/drawing/2014/main" id="{670E854F-1811-DDF4-7573-F4022D6BF77D}"/>
+                <a16:creationId xmlns:a16="http://schemas.microsoft.com/office/drawing/2014/main" id="{07CCECE1-91D8-65AA-CDD7-B01C59B0EF56}"/>
               </a:ext>
             </a:extLst>
           </p:cNvPr>
@@ -9661,7 +9661,7 @@
           <p:cNvPr id="9" name="TextBox 8">
             <a:extLst>
               <a:ext uri="{FF2B5EF4-FFF2-40B4-BE49-F238E27FC236}">
-                <a16:creationId xmlns:a16="http://schemas.microsoft.com/office/drawing/2014/main" id="{28803BE5-87B7-3B81-5AD3-FD183AB7BE93}"/>
+                <a16:creationId xmlns:a16="http://schemas.microsoft.com/office/drawing/2014/main" id="{9F5119E1-C9B5-4525-B01F-02E303FBA840}"/>
               </a:ext>
             </a:extLst>
           </p:cNvPr>
@@ -9702,7 +9702,7 @@
           <p:cNvPr id="10" name="TextBox 9">
             <a:extLst>
               <a:ext uri="{FF2B5EF4-FFF2-40B4-BE49-F238E27FC236}">
-                <a16:creationId xmlns:a16="http://schemas.microsoft.com/office/drawing/2014/main" id="{F5A4722F-6112-BE6F-CAE0-8936AAFAFA65}"/>
+                <a16:creationId xmlns:a16="http://schemas.microsoft.com/office/drawing/2014/main" id="{F5E98536-17F9-4CD7-7694-421D4D9808CE}"/>
               </a:ext>
             </a:extLst>
           </p:cNvPr>
@@ -9764,7 +9764,7 @@
           <p:cNvPr id="11" name="직선 연결선 10">
             <a:extLst>
               <a:ext uri="{FF2B5EF4-FFF2-40B4-BE49-F238E27FC236}">
-                <a16:creationId xmlns:a16="http://schemas.microsoft.com/office/drawing/2014/main" id="{CDF25DF6-9619-4C22-68D1-915F0E271EAC}"/>
+                <a16:creationId xmlns:a16="http://schemas.microsoft.com/office/drawing/2014/main" id="{1A1B34C8-C60A-082C-23CB-A657CD3CD0AC}"/>
               </a:ext>
             </a:extLst>
           </p:cNvPr>
@@ -9806,7 +9806,7 @@
           <p:cNvPr id="12" name="사각형: 둥근 모서리 11">
             <a:extLst>
               <a:ext uri="{FF2B5EF4-FFF2-40B4-BE49-F238E27FC236}">
-                <a16:creationId xmlns:a16="http://schemas.microsoft.com/office/drawing/2014/main" id="{E2572828-8AF4-75BF-EE77-BEF2A6D4B505}"/>
+                <a16:creationId xmlns:a16="http://schemas.microsoft.com/office/drawing/2014/main" id="{DAEB4323-3082-E9B4-653A-25374F96280A}"/>
               </a:ext>
             </a:extLst>
           </p:cNvPr>
@@ -9874,7 +9874,7 @@
           <p:cNvPr id="13" name="사각형: 둥근 모서리 12">
             <a:extLst>
               <a:ext uri="{FF2B5EF4-FFF2-40B4-BE49-F238E27FC236}">
-                <a16:creationId xmlns:a16="http://schemas.microsoft.com/office/drawing/2014/main" id="{C4DDC714-0BB1-B1B3-82B4-AF8CFFB2D9E8}"/>
+                <a16:creationId xmlns:a16="http://schemas.microsoft.com/office/drawing/2014/main" id="{CC968971-7635-FD03-7647-7FCE5F0BE5B8}"/>
               </a:ext>
             </a:extLst>
           </p:cNvPr>
@@ -9942,7 +9942,7 @@
           <p:cNvPr id="14" name="TextBox 13">
             <a:extLst>
               <a:ext uri="{FF2B5EF4-FFF2-40B4-BE49-F238E27FC236}">
-                <a16:creationId xmlns:a16="http://schemas.microsoft.com/office/drawing/2014/main" id="{748F264C-9973-7A4C-38B2-0E514FB4B4E5}"/>
+                <a16:creationId xmlns:a16="http://schemas.microsoft.com/office/drawing/2014/main" id="{0FA691F1-F4AE-80D9-5956-F99E675E1771}"/>
               </a:ext>
             </a:extLst>
           </p:cNvPr>
@@ -9989,7 +9989,7 @@
           <p:cNvPr id="15" name="TextBox 14">
             <a:extLst>
               <a:ext uri="{FF2B5EF4-FFF2-40B4-BE49-F238E27FC236}">
-                <a16:creationId xmlns:a16="http://schemas.microsoft.com/office/drawing/2014/main" id="{3F325419-C3DF-68F9-12D8-773508E57409}"/>
+                <a16:creationId xmlns:a16="http://schemas.microsoft.com/office/drawing/2014/main" id="{36A9733F-3754-1C45-FAFA-282855C9F2E5}"/>
               </a:ext>
             </a:extLst>
           </p:cNvPr>
@@ -10036,7 +10036,7 @@
           <p:cNvPr id="16" name="TextBox 15">
             <a:extLst>
               <a:ext uri="{FF2B5EF4-FFF2-40B4-BE49-F238E27FC236}">
-                <a16:creationId xmlns:a16="http://schemas.microsoft.com/office/drawing/2014/main" id="{97735449-92B0-D755-EC03-9F18B18E21F0}"/>
+                <a16:creationId xmlns:a16="http://schemas.microsoft.com/office/drawing/2014/main" id="{601487A4-1CAB-A641-2EB0-8B2E490C6B59}"/>
               </a:ext>
             </a:extLst>
           </p:cNvPr>
@@ -10098,7 +10098,7 @@
           <p:cNvPr id="17" name="직선 연결선 16">
             <a:extLst>
               <a:ext uri="{FF2B5EF4-FFF2-40B4-BE49-F238E27FC236}">
-                <a16:creationId xmlns:a16="http://schemas.microsoft.com/office/drawing/2014/main" id="{FBBF62F8-B7AE-17A8-E65B-1D3B99C08527}"/>
+                <a16:creationId xmlns:a16="http://schemas.microsoft.com/office/drawing/2014/main" id="{72A2BA5E-53F1-87F5-6580-19F36599C8A7}"/>
               </a:ext>
             </a:extLst>
           </p:cNvPr>
@@ -10140,7 +10140,7 @@
           <p:cNvPr id="18" name="사각형: 둥근 모서리 17">
             <a:extLst>
               <a:ext uri="{FF2B5EF4-FFF2-40B4-BE49-F238E27FC236}">
-                <a16:creationId xmlns:a16="http://schemas.microsoft.com/office/drawing/2014/main" id="{AF183534-8DCA-0EF6-93C2-0592E7B9D8BD}"/>
+                <a16:creationId xmlns:a16="http://schemas.microsoft.com/office/drawing/2014/main" id="{1628AB6D-8070-6FEB-8668-DBB87A84C5D8}"/>
               </a:ext>
             </a:extLst>
           </p:cNvPr>
@@ -10208,7 +10208,7 @@
           <p:cNvPr id="19" name="사각형: 둥근 모서리 18">
             <a:extLst>
               <a:ext uri="{FF2B5EF4-FFF2-40B4-BE49-F238E27FC236}">
-                <a16:creationId xmlns:a16="http://schemas.microsoft.com/office/drawing/2014/main" id="{BA96432D-6C17-AF2A-F9D7-EB3D62C3ECF4}"/>
+                <a16:creationId xmlns:a16="http://schemas.microsoft.com/office/drawing/2014/main" id="{E609EAF3-2D26-D1A5-6525-883A1E50A1A3}"/>
               </a:ext>
             </a:extLst>
           </p:cNvPr>
@@ -10276,7 +10276,7 @@
           <p:cNvPr id="20" name="TextBox 19">
             <a:extLst>
               <a:ext uri="{FF2B5EF4-FFF2-40B4-BE49-F238E27FC236}">
-                <a16:creationId xmlns:a16="http://schemas.microsoft.com/office/drawing/2014/main" id="{3F4D268E-D222-D9A2-6852-BF1659EECD96}"/>
+                <a16:creationId xmlns:a16="http://schemas.microsoft.com/office/drawing/2014/main" id="{589ABE41-6348-B4D6-903A-E00B39EAC5AC}"/>
               </a:ext>
             </a:extLst>
           </p:cNvPr>
@@ -10323,7 +10323,7 @@
           <p:cNvPr id="21" name="TextBox 20">
             <a:extLst>
               <a:ext uri="{FF2B5EF4-FFF2-40B4-BE49-F238E27FC236}">
-                <a16:creationId xmlns:a16="http://schemas.microsoft.com/office/drawing/2014/main" id="{0AADEC96-8970-A241-5453-97E6C1C25C3C}"/>
+                <a16:creationId xmlns:a16="http://schemas.microsoft.com/office/drawing/2014/main" id="{521D4A27-02DF-B74A-B25C-2E0E84336E9B}"/>
               </a:ext>
             </a:extLst>
           </p:cNvPr>
@@ -10370,7 +10370,7 @@
           <p:cNvPr id="22" name="TextBox 21">
             <a:extLst>
               <a:ext uri="{FF2B5EF4-FFF2-40B4-BE49-F238E27FC236}">
-                <a16:creationId xmlns:a16="http://schemas.microsoft.com/office/drawing/2014/main" id="{0B5FAC37-46BD-1870-0603-DBE88778615B}"/>
+                <a16:creationId xmlns:a16="http://schemas.microsoft.com/office/drawing/2014/main" id="{37FA2A33-BD48-DC1B-498A-02B843657AF5}"/>
               </a:ext>
             </a:extLst>
           </p:cNvPr>
@@ -10423,7 +10423,7 @@
           <p:cNvPr id="23" name="직선 연결선 22">
             <a:extLst>
               <a:ext uri="{FF2B5EF4-FFF2-40B4-BE49-F238E27FC236}">
-                <a16:creationId xmlns:a16="http://schemas.microsoft.com/office/drawing/2014/main" id="{68DE97F7-8224-7CCA-E693-AC0C635B75BC}"/>
+                <a16:creationId xmlns:a16="http://schemas.microsoft.com/office/drawing/2014/main" id="{900CEBAC-348D-70CD-5D54-FD737D7CE59D}"/>
               </a:ext>
             </a:extLst>
           </p:cNvPr>
@@ -10465,7 +10465,7 @@
           <p:cNvPr id="24" name="사각형: 둥근 모서리 23">
             <a:extLst>
               <a:ext uri="{FF2B5EF4-FFF2-40B4-BE49-F238E27FC236}">
-                <a16:creationId xmlns:a16="http://schemas.microsoft.com/office/drawing/2014/main" id="{D9CF3502-738C-C718-AA28-88B25D7595E5}"/>
+                <a16:creationId xmlns:a16="http://schemas.microsoft.com/office/drawing/2014/main" id="{95E032BD-5B4B-6F7F-37F3-63597F268C6C}"/>
               </a:ext>
             </a:extLst>
           </p:cNvPr>
@@ -10533,7 +10533,7 @@
           <p:cNvPr id="25" name="사각형: 둥근 모서리 24">
             <a:extLst>
               <a:ext uri="{FF2B5EF4-FFF2-40B4-BE49-F238E27FC236}">
-                <a16:creationId xmlns:a16="http://schemas.microsoft.com/office/drawing/2014/main" id="{6E28D8B4-DBAA-CC43-9522-3005230FE5A0}"/>
+                <a16:creationId xmlns:a16="http://schemas.microsoft.com/office/drawing/2014/main" id="{9D8554E9-0A96-536F-5DB3-6296689E7525}"/>
               </a:ext>
             </a:extLst>
           </p:cNvPr>
@@ -10601,7 +10601,7 @@
           <p:cNvPr id="26" name="TextBox 25">
             <a:extLst>
               <a:ext uri="{FF2B5EF4-FFF2-40B4-BE49-F238E27FC236}">
-                <a16:creationId xmlns:a16="http://schemas.microsoft.com/office/drawing/2014/main" id="{D14C2088-A7BD-9FCE-43F3-7AF40D79631D}"/>
+                <a16:creationId xmlns:a16="http://schemas.microsoft.com/office/drawing/2014/main" id="{10CB47E7-1C3A-6390-493E-C2C70FC9092D}"/>
               </a:ext>
             </a:extLst>
           </p:cNvPr>
@@ -10648,7 +10648,7 @@
           <p:cNvPr id="27" name="TextBox 26">
             <a:extLst>
               <a:ext uri="{FF2B5EF4-FFF2-40B4-BE49-F238E27FC236}">
-                <a16:creationId xmlns:a16="http://schemas.microsoft.com/office/drawing/2014/main" id="{FCFFA964-0708-F822-D5B2-A55C704D7F40}"/>
+                <a16:creationId xmlns:a16="http://schemas.microsoft.com/office/drawing/2014/main" id="{7BC34BF6-A13A-6D05-79DF-67FAE2EC67DD}"/>
               </a:ext>
             </a:extLst>
           </p:cNvPr>
@@ -10698,7 +10698,7 @@
           <p:cNvPr id="28" name="TextBox 27">
             <a:extLst>
               <a:ext uri="{FF2B5EF4-FFF2-40B4-BE49-F238E27FC236}">
-                <a16:creationId xmlns:a16="http://schemas.microsoft.com/office/drawing/2014/main" id="{AE901EF0-6495-47C0-13F3-38700A8DB069}"/>
+                <a16:creationId xmlns:a16="http://schemas.microsoft.com/office/drawing/2014/main" id="{8F0FC55C-307D-7728-EDB0-D9D68637137F}"/>
               </a:ext>
             </a:extLst>
           </p:cNvPr>
@@ -10769,7 +10769,7 @@
           <p:cNvPr id="29" name="사각형: 둥근 모서리 28">
             <a:extLst>
               <a:ext uri="{FF2B5EF4-FFF2-40B4-BE49-F238E27FC236}">
-                <a16:creationId xmlns:a16="http://schemas.microsoft.com/office/drawing/2014/main" id="{048ED39A-B5DB-D89C-F780-BFC7D84D3A63}"/>
+                <a16:creationId xmlns:a16="http://schemas.microsoft.com/office/drawing/2014/main" id="{B2B54C74-FA80-31B6-8B61-EC2CB5E3813F}"/>
               </a:ext>
             </a:extLst>
           </p:cNvPr>
@@ -10837,7 +10837,7 @@
           <p:cNvPr id="30" name="사각형: 둥근 모서리 29">
             <a:extLst>
               <a:ext uri="{FF2B5EF4-FFF2-40B4-BE49-F238E27FC236}">
-                <a16:creationId xmlns:a16="http://schemas.microsoft.com/office/drawing/2014/main" id="{0A2A8499-2D09-8BFD-B072-940460776721}"/>
+                <a16:creationId xmlns:a16="http://schemas.microsoft.com/office/drawing/2014/main" id="{F03ADEC6-F948-FC93-3401-7C5FCFA71B9C}"/>
               </a:ext>
             </a:extLst>
           </p:cNvPr>
@@ -10905,7 +10905,7 @@
           <p:cNvPr id="31" name="TextBox 30">
             <a:extLst>
               <a:ext uri="{FF2B5EF4-FFF2-40B4-BE49-F238E27FC236}">
-                <a16:creationId xmlns:a16="http://schemas.microsoft.com/office/drawing/2014/main" id="{E0667611-0B24-E8D1-CB93-229085A78F18}"/>
+                <a16:creationId xmlns:a16="http://schemas.microsoft.com/office/drawing/2014/main" id="{EC20B3B2-7DBF-1116-DE93-F077334A5042}"/>
               </a:ext>
             </a:extLst>
           </p:cNvPr>
@@ -10952,7 +10952,7 @@
           <p:cNvPr id="32" name="TextBox 31">
             <a:extLst>
               <a:ext uri="{FF2B5EF4-FFF2-40B4-BE49-F238E27FC236}">
-                <a16:creationId xmlns:a16="http://schemas.microsoft.com/office/drawing/2014/main" id="{638DF96A-1935-7202-6998-FF85405E7B1F}"/>
+                <a16:creationId xmlns:a16="http://schemas.microsoft.com/office/drawing/2014/main" id="{688A0849-F5C8-AB62-1680-44BF37AE8646}"/>
               </a:ext>
             </a:extLst>
           </p:cNvPr>
@@ -11008,7 +11008,7 @@
           <p:cNvPr id="33" name="TextBox 32">
             <a:extLst>
               <a:ext uri="{FF2B5EF4-FFF2-40B4-BE49-F238E27FC236}">
-                <a16:creationId xmlns:a16="http://schemas.microsoft.com/office/drawing/2014/main" id="{081E3D01-3BE2-E9AE-1BBB-D021A20A957B}"/>
+                <a16:creationId xmlns:a16="http://schemas.microsoft.com/office/drawing/2014/main" id="{8F6F84A6-4D68-2C32-F283-5D6F34A41148}"/>
               </a:ext>
             </a:extLst>
           </p:cNvPr>
@@ -11079,7 +11079,7 @@
           <p:cNvPr id="34" name="사각형: 둥근 모서리 33">
             <a:extLst>
               <a:ext uri="{FF2B5EF4-FFF2-40B4-BE49-F238E27FC236}">
-                <a16:creationId xmlns:a16="http://schemas.microsoft.com/office/drawing/2014/main" id="{9042E2BA-90BD-D561-6F0D-0636C69840A0}"/>
+                <a16:creationId xmlns:a16="http://schemas.microsoft.com/office/drawing/2014/main" id="{3C667665-0C66-0392-9033-8D767B44ED4E}"/>
               </a:ext>
             </a:extLst>
           </p:cNvPr>
@@ -11147,7 +11147,7 @@
           <p:cNvPr id="35" name="TextBox 34">
             <a:extLst>
               <a:ext uri="{FF2B5EF4-FFF2-40B4-BE49-F238E27FC236}">
-                <a16:creationId xmlns:a16="http://schemas.microsoft.com/office/drawing/2014/main" id="{6054BE81-EEBF-DEB5-A3A8-DA3B3843E35D}"/>
+                <a16:creationId xmlns:a16="http://schemas.microsoft.com/office/drawing/2014/main" id="{ED4DE715-757C-5281-24B2-DD1E16A7EED7}"/>
               </a:ext>
             </a:extLst>
           </p:cNvPr>
@@ -11187,7 +11187,7 @@
           <p:cNvPr id="36" name="TextBox 35">
             <a:extLst>
               <a:ext uri="{FF2B5EF4-FFF2-40B4-BE49-F238E27FC236}">
-                <a16:creationId xmlns:a16="http://schemas.microsoft.com/office/drawing/2014/main" id="{DDA0E4B0-8B5B-6E6C-5596-6725030E6AA0}"/>
+                <a16:creationId xmlns:a16="http://schemas.microsoft.com/office/drawing/2014/main" id="{0B0A1F78-F696-5393-41C2-FC4DFCCC4D9E}"/>
               </a:ext>
             </a:extLst>
           </p:cNvPr>
@@ -11323,7 +11323,7 @@
           <p:cNvPr id="37" name="직선 연결선 36">
             <a:extLst>
               <a:ext uri="{FF2B5EF4-FFF2-40B4-BE49-F238E27FC236}">
-                <a16:creationId xmlns:a16="http://schemas.microsoft.com/office/drawing/2014/main" id="{22EA9275-D886-7964-8C50-BE6FBB13D12E}"/>
+                <a16:creationId xmlns:a16="http://schemas.microsoft.com/office/drawing/2014/main" id="{88DC28B5-02A6-0FCB-EBA3-D2A78CBAA6A6}"/>
               </a:ext>
             </a:extLst>
           </p:cNvPr>
@@ -11364,7 +11364,7 @@
           <p:cNvPr id="38" name="TextBox 37">
             <a:extLst>
               <a:ext uri="{FF2B5EF4-FFF2-40B4-BE49-F238E27FC236}">
-                <a16:creationId xmlns:a16="http://schemas.microsoft.com/office/drawing/2014/main" id="{90E6C712-C1C7-77F4-C2F6-72D1826F02D0}"/>
+                <a16:creationId xmlns:a16="http://schemas.microsoft.com/office/drawing/2014/main" id="{6BAC3B86-6330-09B5-D86F-D07F09EEFB00}"/>
               </a:ext>
             </a:extLst>
           </p:cNvPr>
@@ -11449,7 +11449,7 @@
           <p:cNvPr id="39" name="TextBox 38">
             <a:extLst>
               <a:ext uri="{FF2B5EF4-FFF2-40B4-BE49-F238E27FC236}">
-                <a16:creationId xmlns:a16="http://schemas.microsoft.com/office/drawing/2014/main" id="{189FC27E-96DA-1125-01ED-AC525DE88AA0}"/>
+                <a16:creationId xmlns:a16="http://schemas.microsoft.com/office/drawing/2014/main" id="{56FBD06A-C41E-AB1D-18D0-D85A97E3B8AD}"/>
               </a:ext>
             </a:extLst>
           </p:cNvPr>
@@ -11494,7 +11494,7 @@
     </p:spTree>
     <p:extLst>
       <p:ext uri="{BB962C8B-B14F-4D97-AF65-F5344CB8AC3E}">
-        <p14:creationId xmlns:p14="http://schemas.microsoft.com/office/powerpoint/2010/main" val="3951770635"/>
+        <p14:creationId xmlns:p14="http://schemas.microsoft.com/office/powerpoint/2010/main" val="19205033"/>
       </p:ext>
     </p:extLst>
   </p:cSld>
@@ -11526,7 +11526,7 @@
           <p:cNvPr id="2" name="TextBox 1">
             <a:extLst>
               <a:ext uri="{FF2B5EF4-FFF2-40B4-BE49-F238E27FC236}">
-                <a16:creationId xmlns:a16="http://schemas.microsoft.com/office/drawing/2014/main" id="{0D1ED6B8-F9B3-DB3E-7FC5-73473CE870EC}"/>
+                <a16:creationId xmlns:a16="http://schemas.microsoft.com/office/drawing/2014/main" id="{437B1105-DFE1-0D03-AE6F-3473ABE39EE1}"/>
               </a:ext>
             </a:extLst>
           </p:cNvPr>
@@ -11575,7 +11575,7 @@
           <p:cNvPr id="3" name="TextBox 2">
             <a:extLst>
               <a:ext uri="{FF2B5EF4-FFF2-40B4-BE49-F238E27FC236}">
-                <a16:creationId xmlns:a16="http://schemas.microsoft.com/office/drawing/2014/main" id="{7743EA3C-77AD-FF51-AAE3-A239D9B2B0AF}"/>
+                <a16:creationId xmlns:a16="http://schemas.microsoft.com/office/drawing/2014/main" id="{E38D951B-72C9-32AA-7E4C-96FD0EBF032E}"/>
               </a:ext>
             </a:extLst>
           </p:cNvPr>
@@ -11642,7 +11642,7 @@
           <p:cNvPr id="4" name="직사각형 3">
             <a:extLst>
               <a:ext uri="{FF2B5EF4-FFF2-40B4-BE49-F238E27FC236}">
-                <a16:creationId xmlns:a16="http://schemas.microsoft.com/office/drawing/2014/main" id="{F34E4614-E745-2D12-7795-EA6E4F710A81}"/>
+                <a16:creationId xmlns:a16="http://schemas.microsoft.com/office/drawing/2014/main" id="{FA8916E5-0A38-E159-EC0C-B16119A7234E}"/>
               </a:ext>
             </a:extLst>
           </p:cNvPr>
@@ -11710,7 +11710,7 @@
           <p:cNvPr id="5" name="사각형: 둥근 모서리 4">
             <a:extLst>
               <a:ext uri="{FF2B5EF4-FFF2-40B4-BE49-F238E27FC236}">
-                <a16:creationId xmlns:a16="http://schemas.microsoft.com/office/drawing/2014/main" id="{5E169B2A-0803-FA4B-3CED-E05BFF453A44}"/>
+                <a16:creationId xmlns:a16="http://schemas.microsoft.com/office/drawing/2014/main" id="{1611191B-12A6-F333-7038-AAD9A85DF5E5}"/>
               </a:ext>
             </a:extLst>
           </p:cNvPr>
@@ -11778,7 +11778,7 @@
           <p:cNvPr id="6" name="TextBox 5">
             <a:extLst>
               <a:ext uri="{FF2B5EF4-FFF2-40B4-BE49-F238E27FC236}">
-                <a16:creationId xmlns:a16="http://schemas.microsoft.com/office/drawing/2014/main" id="{B109121B-89FF-AC1E-F9E4-8AF263481DF5}"/>
+                <a16:creationId xmlns:a16="http://schemas.microsoft.com/office/drawing/2014/main" id="{35E2AEC6-5AFD-244A-2A1E-FC2550C43D5D}"/>
               </a:ext>
             </a:extLst>
           </p:cNvPr>
@@ -11825,7 +11825,7 @@
           <p:cNvPr id="7" name="TextBox 6">
             <a:extLst>
               <a:ext uri="{FF2B5EF4-FFF2-40B4-BE49-F238E27FC236}">
-                <a16:creationId xmlns:a16="http://schemas.microsoft.com/office/drawing/2014/main" id="{69B1196A-A131-786A-A431-CA6BE55BC42D}"/>
+                <a16:creationId xmlns:a16="http://schemas.microsoft.com/office/drawing/2014/main" id="{9E88895A-8B03-04C0-2D2E-7606C593E04E}"/>
               </a:ext>
             </a:extLst>
           </p:cNvPr>
@@ -11865,7 +11865,7 @@
           <p:cNvPr id="8" name="TextBox 7">
             <a:extLst>
               <a:ext uri="{FF2B5EF4-FFF2-40B4-BE49-F238E27FC236}">
-                <a16:creationId xmlns:a16="http://schemas.microsoft.com/office/drawing/2014/main" id="{4741807B-0C0C-CC79-D562-A179CCF743B2}"/>
+                <a16:creationId xmlns:a16="http://schemas.microsoft.com/office/drawing/2014/main" id="{480BEADA-13B7-8AEB-E7E5-E6ACD9EFCDB9}"/>
               </a:ext>
             </a:extLst>
           </p:cNvPr>
@@ -11905,7 +11905,7 @@
           <p:cNvPr id="9" name="TextBox 8">
             <a:extLst>
               <a:ext uri="{FF2B5EF4-FFF2-40B4-BE49-F238E27FC236}">
-                <a16:creationId xmlns:a16="http://schemas.microsoft.com/office/drawing/2014/main" id="{6D5E0F34-D323-C3AB-D262-F08948E4D304}"/>
+                <a16:creationId xmlns:a16="http://schemas.microsoft.com/office/drawing/2014/main" id="{4B431339-3DEE-CD75-DA57-DF4A43913768}"/>
               </a:ext>
             </a:extLst>
           </p:cNvPr>
@@ -11945,7 +11945,7 @@
           <p:cNvPr id="10" name="TextBox 9">
             <a:extLst>
               <a:ext uri="{FF2B5EF4-FFF2-40B4-BE49-F238E27FC236}">
-                <a16:creationId xmlns:a16="http://schemas.microsoft.com/office/drawing/2014/main" id="{5E9E52D1-9ED2-1E00-FDFE-B28C5D608E58}"/>
+                <a16:creationId xmlns:a16="http://schemas.microsoft.com/office/drawing/2014/main" id="{CE1C3CE9-EB7E-7072-0374-21F8D5CFA8A8}"/>
               </a:ext>
             </a:extLst>
           </p:cNvPr>
@@ -12021,7 +12021,7 @@
           <p:cNvPr id="11" name="TextBox 10">
             <a:extLst>
               <a:ext uri="{FF2B5EF4-FFF2-40B4-BE49-F238E27FC236}">
-                <a16:creationId xmlns:a16="http://schemas.microsoft.com/office/drawing/2014/main" id="{4A6D8B9F-D470-DA63-3E48-B1816A8AF311}"/>
+                <a16:creationId xmlns:a16="http://schemas.microsoft.com/office/drawing/2014/main" id="{005CF393-8BAA-DA5F-C447-5B84ABA9D5AF}"/>
               </a:ext>
             </a:extLst>
           </p:cNvPr>
@@ -12061,7 +12061,7 @@
           <p:cNvPr id="12" name="TextBox 11">
             <a:extLst>
               <a:ext uri="{FF2B5EF4-FFF2-40B4-BE49-F238E27FC236}">
-                <a16:creationId xmlns:a16="http://schemas.microsoft.com/office/drawing/2014/main" id="{5B918F07-A7F8-0458-64D7-5E6A6571A81F}"/>
+                <a16:creationId xmlns:a16="http://schemas.microsoft.com/office/drawing/2014/main" id="{D43A85BE-8EFC-FEC0-8B6C-E3E745BB2F80}"/>
               </a:ext>
             </a:extLst>
           </p:cNvPr>
@@ -12110,7 +12110,7 @@
           <p:cNvPr id="13" name="TextBox 12">
             <a:extLst>
               <a:ext uri="{FF2B5EF4-FFF2-40B4-BE49-F238E27FC236}">
-                <a16:creationId xmlns:a16="http://schemas.microsoft.com/office/drawing/2014/main" id="{11992B00-F9A1-8BA0-DF97-DB84199ABF75}"/>
+                <a16:creationId xmlns:a16="http://schemas.microsoft.com/office/drawing/2014/main" id="{8222C497-8A32-A3A3-6F47-980378527E65}"/>
               </a:ext>
             </a:extLst>
           </p:cNvPr>
@@ -12150,7 +12150,7 @@
           <p:cNvPr id="14" name="TextBox 13">
             <a:extLst>
               <a:ext uri="{FF2B5EF4-FFF2-40B4-BE49-F238E27FC236}">
-                <a16:creationId xmlns:a16="http://schemas.microsoft.com/office/drawing/2014/main" id="{CF9ED674-DCE8-EABD-F417-ABD1F657290F}"/>
+                <a16:creationId xmlns:a16="http://schemas.microsoft.com/office/drawing/2014/main" id="{91F56CF4-3FF0-58B4-2557-8B6896A45C31}"/>
               </a:ext>
             </a:extLst>
           </p:cNvPr>
@@ -12217,7 +12217,7 @@
           <p:cNvPr id="15" name="TextBox 14">
             <a:extLst>
               <a:ext uri="{FF2B5EF4-FFF2-40B4-BE49-F238E27FC236}">
-                <a16:creationId xmlns:a16="http://schemas.microsoft.com/office/drawing/2014/main" id="{C9E813C1-7C37-A708-D055-9DD06A8A3B7F}"/>
+                <a16:creationId xmlns:a16="http://schemas.microsoft.com/office/drawing/2014/main" id="{5B17DCE6-7B70-0782-99BC-AD4EC18B4D1E}"/>
               </a:ext>
             </a:extLst>
           </p:cNvPr>
@@ -12257,7 +12257,7 @@
           <p:cNvPr id="16" name="TextBox 15">
             <a:extLst>
               <a:ext uri="{FF2B5EF4-FFF2-40B4-BE49-F238E27FC236}">
-                <a16:creationId xmlns:a16="http://schemas.microsoft.com/office/drawing/2014/main" id="{511C759D-DEC1-32D2-E581-CF706543FFE2}"/>
+                <a16:creationId xmlns:a16="http://schemas.microsoft.com/office/drawing/2014/main" id="{CD3EF332-9172-626A-A1B5-15CDDF18C544}"/>
               </a:ext>
             </a:extLst>
           </p:cNvPr>
@@ -12303,7 +12303,7 @@
           <p:cNvPr id="17" name="TextBox 16">
             <a:extLst>
               <a:ext uri="{FF2B5EF4-FFF2-40B4-BE49-F238E27FC236}">
-                <a16:creationId xmlns:a16="http://schemas.microsoft.com/office/drawing/2014/main" id="{E0C7E907-CAC2-4C53-B9B8-0DE2F2382C43}"/>
+                <a16:creationId xmlns:a16="http://schemas.microsoft.com/office/drawing/2014/main" id="{C6BFA1CF-4087-F70C-F168-9CA46BB3B3DF}"/>
               </a:ext>
             </a:extLst>
           </p:cNvPr>
@@ -12343,7 +12343,7 @@
           <p:cNvPr id="18" name="TextBox 17">
             <a:extLst>
               <a:ext uri="{FF2B5EF4-FFF2-40B4-BE49-F238E27FC236}">
-                <a16:creationId xmlns:a16="http://schemas.microsoft.com/office/drawing/2014/main" id="{747864AF-3D94-4C99-A50C-4F0E8E3EFEBC}"/>
+                <a16:creationId xmlns:a16="http://schemas.microsoft.com/office/drawing/2014/main" id="{ABBD5DCF-83C8-2473-36C4-EE9FA04B7263}"/>
               </a:ext>
             </a:extLst>
           </p:cNvPr>
@@ -12392,7 +12392,7 @@
           <p:cNvPr id="19" name="직선 연결선 18">
             <a:extLst>
               <a:ext uri="{FF2B5EF4-FFF2-40B4-BE49-F238E27FC236}">
-                <a16:creationId xmlns:a16="http://schemas.microsoft.com/office/drawing/2014/main" id="{36CB822F-AFA9-5EB5-A4C9-0FFE06E1CFDB}"/>
+                <a16:creationId xmlns:a16="http://schemas.microsoft.com/office/drawing/2014/main" id="{942D1221-4E01-EBD6-E128-3CBDB682B7F2}"/>
               </a:ext>
             </a:extLst>
           </p:cNvPr>
@@ -12433,7 +12433,7 @@
           <p:cNvPr id="20" name="TextBox 19">
             <a:extLst>
               <a:ext uri="{FF2B5EF4-FFF2-40B4-BE49-F238E27FC236}">
-                <a16:creationId xmlns:a16="http://schemas.microsoft.com/office/drawing/2014/main" id="{961F4C37-0236-4A06-6EED-1D6D2DE801C9}"/>
+                <a16:creationId xmlns:a16="http://schemas.microsoft.com/office/drawing/2014/main" id="{D0436874-732F-63C6-0E49-F5D2B31688D3}"/>
               </a:ext>
             </a:extLst>
           </p:cNvPr>
@@ -12473,7 +12473,7 @@
           <p:cNvPr id="21" name="TextBox 20">
             <a:extLst>
               <a:ext uri="{FF2B5EF4-FFF2-40B4-BE49-F238E27FC236}">
-                <a16:creationId xmlns:a16="http://schemas.microsoft.com/office/drawing/2014/main" id="{FC3913B2-BE88-B950-1207-103D2A048C97}"/>
+                <a16:creationId xmlns:a16="http://schemas.microsoft.com/office/drawing/2014/main" id="{A041C464-733A-40BC-7797-46959D6E74F2}"/>
               </a:ext>
             </a:extLst>
           </p:cNvPr>
@@ -12574,7 +12574,7 @@
           <p:cNvPr id="22" name="TextBox 21">
             <a:extLst>
               <a:ext uri="{FF2B5EF4-FFF2-40B4-BE49-F238E27FC236}">
-                <a16:creationId xmlns:a16="http://schemas.microsoft.com/office/drawing/2014/main" id="{4B762A00-45FB-F4B9-1738-20F0BCD45F81}"/>
+                <a16:creationId xmlns:a16="http://schemas.microsoft.com/office/drawing/2014/main" id="{961B5EB3-ADFD-B1E7-7D51-8F4D554C29B5}"/>
               </a:ext>
             </a:extLst>
           </p:cNvPr>
@@ -12647,7 +12647,7 @@
           <p:cNvPr id="23" name="직선 연결선 22">
             <a:extLst>
               <a:ext uri="{FF2B5EF4-FFF2-40B4-BE49-F238E27FC236}">
-                <a16:creationId xmlns:a16="http://schemas.microsoft.com/office/drawing/2014/main" id="{F2B11F72-D44D-0564-9F38-B825BB7053C2}"/>
+                <a16:creationId xmlns:a16="http://schemas.microsoft.com/office/drawing/2014/main" id="{4A4B7E14-E6F5-CEA7-A0F8-0B9248C2F787}"/>
               </a:ext>
             </a:extLst>
           </p:cNvPr>
@@ -12688,7 +12688,7 @@
           <p:cNvPr id="24" name="TextBox 23">
             <a:extLst>
               <a:ext uri="{FF2B5EF4-FFF2-40B4-BE49-F238E27FC236}">
-                <a16:creationId xmlns:a16="http://schemas.microsoft.com/office/drawing/2014/main" id="{30F006A3-4395-3234-2C16-07D14E4E5C09}"/>
+                <a16:creationId xmlns:a16="http://schemas.microsoft.com/office/drawing/2014/main" id="{EDC66DD1-3520-F50D-03D5-394A38027389}"/>
               </a:ext>
             </a:extLst>
           </p:cNvPr>
@@ -12773,7 +12773,7 @@
           <p:cNvPr id="25" name="TextBox 24">
             <a:extLst>
               <a:ext uri="{FF2B5EF4-FFF2-40B4-BE49-F238E27FC236}">
-                <a16:creationId xmlns:a16="http://schemas.microsoft.com/office/drawing/2014/main" id="{140C5144-179F-7C46-487C-37DAD832E052}"/>
+                <a16:creationId xmlns:a16="http://schemas.microsoft.com/office/drawing/2014/main" id="{8F4BF41C-79FF-52EA-377A-C6FD397FB10A}"/>
               </a:ext>
             </a:extLst>
           </p:cNvPr>
@@ -12818,7 +12818,7 @@
     </p:spTree>
     <p:extLst>
       <p:ext uri="{BB962C8B-B14F-4D97-AF65-F5344CB8AC3E}">
-        <p14:creationId xmlns:p14="http://schemas.microsoft.com/office/powerpoint/2010/main" val="1442912021"/>
+        <p14:creationId xmlns:p14="http://schemas.microsoft.com/office/powerpoint/2010/main" val="452953370"/>
       </p:ext>
     </p:extLst>
   </p:cSld>
@@ -12850,7 +12850,7 @@
           <p:cNvPr id="2" name="TextBox 1">
             <a:extLst>
               <a:ext uri="{FF2B5EF4-FFF2-40B4-BE49-F238E27FC236}">
-                <a16:creationId xmlns:a16="http://schemas.microsoft.com/office/drawing/2014/main" id="{D5E9CE1D-367D-4C12-03DC-68AE05B938F4}"/>
+                <a16:creationId xmlns:a16="http://schemas.microsoft.com/office/drawing/2014/main" id="{8C204D68-D8B2-8460-E482-B5E191AF2268}"/>
               </a:ext>
             </a:extLst>
           </p:cNvPr>
@@ -12899,7 +12899,7 @@
           <p:cNvPr id="3" name="TextBox 2">
             <a:extLst>
               <a:ext uri="{FF2B5EF4-FFF2-40B4-BE49-F238E27FC236}">
-                <a16:creationId xmlns:a16="http://schemas.microsoft.com/office/drawing/2014/main" id="{FD95E5DF-9B49-A1B2-CCD1-2EA2A045DFF3}"/>
+                <a16:creationId xmlns:a16="http://schemas.microsoft.com/office/drawing/2014/main" id="{C4FB128D-0969-D2B1-C642-25D537C9CFFC}"/>
               </a:ext>
             </a:extLst>
           </p:cNvPr>
@@ -12957,7 +12957,7 @@
           <p:cNvPr id="4" name="직사각형 3">
             <a:extLst>
               <a:ext uri="{FF2B5EF4-FFF2-40B4-BE49-F238E27FC236}">
-                <a16:creationId xmlns:a16="http://schemas.microsoft.com/office/drawing/2014/main" id="{3C3A8E31-415F-B5A7-CE02-129FD86965A7}"/>
+                <a16:creationId xmlns:a16="http://schemas.microsoft.com/office/drawing/2014/main" id="{6A4BFBDC-E734-C09B-5333-F8FCC89C695E}"/>
               </a:ext>
             </a:extLst>
           </p:cNvPr>
@@ -13025,7 +13025,7 @@
           <p:cNvPr id="5" name="사각형: 둥근 모서리 4">
             <a:extLst>
               <a:ext uri="{FF2B5EF4-FFF2-40B4-BE49-F238E27FC236}">
-                <a16:creationId xmlns:a16="http://schemas.microsoft.com/office/drawing/2014/main" id="{951974D2-852E-9763-634E-EB76EDDC40EC}"/>
+                <a16:creationId xmlns:a16="http://schemas.microsoft.com/office/drawing/2014/main" id="{DBBB8854-E924-5BED-CBA7-5A0CBD68E2BB}"/>
               </a:ext>
             </a:extLst>
           </p:cNvPr>
@@ -13093,7 +13093,7 @@
           <p:cNvPr id="6" name="TextBox 5">
             <a:extLst>
               <a:ext uri="{FF2B5EF4-FFF2-40B4-BE49-F238E27FC236}">
-                <a16:creationId xmlns:a16="http://schemas.microsoft.com/office/drawing/2014/main" id="{2F001833-69C4-51EC-5FE8-A622145392FE}"/>
+                <a16:creationId xmlns:a16="http://schemas.microsoft.com/office/drawing/2014/main" id="{EE0DE8C0-8F77-0EC6-8885-C897A8C68008}"/>
               </a:ext>
             </a:extLst>
           </p:cNvPr>
@@ -13140,7 +13140,7 @@
           <p:cNvPr id="7" name="TextBox 6">
             <a:extLst>
               <a:ext uri="{FF2B5EF4-FFF2-40B4-BE49-F238E27FC236}">
-                <a16:creationId xmlns:a16="http://schemas.microsoft.com/office/drawing/2014/main" id="{25976F52-446A-8878-AE34-47E359593957}"/>
+                <a16:creationId xmlns:a16="http://schemas.microsoft.com/office/drawing/2014/main" id="{FBA06ACC-1EE6-CCB6-5C56-274B9EF3CE12}"/>
               </a:ext>
             </a:extLst>
           </p:cNvPr>
@@ -13215,7 +13215,7 @@
           <p:cNvPr id="8" name="사각형: 둥근 모서리 7">
             <a:extLst>
               <a:ext uri="{FF2B5EF4-FFF2-40B4-BE49-F238E27FC236}">
-                <a16:creationId xmlns:a16="http://schemas.microsoft.com/office/drawing/2014/main" id="{7D423FA9-CA57-21AE-5F87-5034DFF9D2AD}"/>
+                <a16:creationId xmlns:a16="http://schemas.microsoft.com/office/drawing/2014/main" id="{F7B2AB41-D5EF-30A6-1FED-CBA4E64E4CC3}"/>
               </a:ext>
             </a:extLst>
           </p:cNvPr>
@@ -13283,7 +13283,7 @@
           <p:cNvPr id="9" name="TextBox 8">
             <a:extLst>
               <a:ext uri="{FF2B5EF4-FFF2-40B4-BE49-F238E27FC236}">
-                <a16:creationId xmlns:a16="http://schemas.microsoft.com/office/drawing/2014/main" id="{AA944A6C-5655-B084-C4E4-0C7D06122308}"/>
+                <a16:creationId xmlns:a16="http://schemas.microsoft.com/office/drawing/2014/main" id="{80E1A942-4A64-83D4-E0E6-F747C325A814}"/>
               </a:ext>
             </a:extLst>
           </p:cNvPr>
@@ -13330,7 +13330,7 @@
           <p:cNvPr id="10" name="TextBox 9">
             <a:extLst>
               <a:ext uri="{FF2B5EF4-FFF2-40B4-BE49-F238E27FC236}">
-                <a16:creationId xmlns:a16="http://schemas.microsoft.com/office/drawing/2014/main" id="{7574B6CC-17A6-30BD-5B61-2879EA616C3A}"/>
+                <a16:creationId xmlns:a16="http://schemas.microsoft.com/office/drawing/2014/main" id="{22BCDC84-239A-6CAC-A52B-7DB7574E23BA}"/>
               </a:ext>
             </a:extLst>
           </p:cNvPr>
@@ -13399,7 +13399,7 @@
           <p:cNvPr id="11" name="사각형: 둥근 모서리 10">
             <a:extLst>
               <a:ext uri="{FF2B5EF4-FFF2-40B4-BE49-F238E27FC236}">
-                <a16:creationId xmlns:a16="http://schemas.microsoft.com/office/drawing/2014/main" id="{8799FCA3-6901-39B9-4E80-B3C44976CF71}"/>
+                <a16:creationId xmlns:a16="http://schemas.microsoft.com/office/drawing/2014/main" id="{FACDA057-DD46-5E2D-7AE3-BF3F3E826D86}"/>
               </a:ext>
             </a:extLst>
           </p:cNvPr>
@@ -13467,7 +13467,7 @@
           <p:cNvPr id="12" name="TextBox 11">
             <a:extLst>
               <a:ext uri="{FF2B5EF4-FFF2-40B4-BE49-F238E27FC236}">
-                <a16:creationId xmlns:a16="http://schemas.microsoft.com/office/drawing/2014/main" id="{215B530E-07DB-ACF7-3D8C-F6C12480C3E6}"/>
+                <a16:creationId xmlns:a16="http://schemas.microsoft.com/office/drawing/2014/main" id="{CACFE09F-DFE3-931D-62FF-5FCBB150A647}"/>
               </a:ext>
             </a:extLst>
           </p:cNvPr>
@@ -13514,7 +13514,7 @@
           <p:cNvPr id="13" name="TextBox 12">
             <a:extLst>
               <a:ext uri="{FF2B5EF4-FFF2-40B4-BE49-F238E27FC236}">
-                <a16:creationId xmlns:a16="http://schemas.microsoft.com/office/drawing/2014/main" id="{0640A305-F6C0-EDFC-027F-B76FCEFC0151}"/>
+                <a16:creationId xmlns:a16="http://schemas.microsoft.com/office/drawing/2014/main" id="{F0B7C0F6-60B5-CF01-3547-8287FCE23B7B}"/>
               </a:ext>
             </a:extLst>
           </p:cNvPr>
@@ -13583,7 +13583,7 @@
           <p:cNvPr id="14" name="사각형: 둥근 모서리 13">
             <a:extLst>
               <a:ext uri="{FF2B5EF4-FFF2-40B4-BE49-F238E27FC236}">
-                <a16:creationId xmlns:a16="http://schemas.microsoft.com/office/drawing/2014/main" id="{BE6EFD3E-191C-BDA4-1DF5-ADE12BB437D0}"/>
+                <a16:creationId xmlns:a16="http://schemas.microsoft.com/office/drawing/2014/main" id="{1793260D-B2A5-CB68-8988-F6B5474F61EB}"/>
               </a:ext>
             </a:extLst>
           </p:cNvPr>
@@ -13651,7 +13651,7 @@
           <p:cNvPr id="15" name="TextBox 14">
             <a:extLst>
               <a:ext uri="{FF2B5EF4-FFF2-40B4-BE49-F238E27FC236}">
-                <a16:creationId xmlns:a16="http://schemas.microsoft.com/office/drawing/2014/main" id="{C99355E8-D762-5520-59F2-4BEB8630AA79}"/>
+                <a16:creationId xmlns:a16="http://schemas.microsoft.com/office/drawing/2014/main" id="{0F7CE0AE-68C6-9949-79C9-FCDECB66180D}"/>
               </a:ext>
             </a:extLst>
           </p:cNvPr>
@@ -13698,7 +13698,7 @@
           <p:cNvPr id="16" name="TextBox 15">
             <a:extLst>
               <a:ext uri="{FF2B5EF4-FFF2-40B4-BE49-F238E27FC236}">
-                <a16:creationId xmlns:a16="http://schemas.microsoft.com/office/drawing/2014/main" id="{B88E4DAB-F4C3-271D-2EB1-8FC84020D2E6}"/>
+                <a16:creationId xmlns:a16="http://schemas.microsoft.com/office/drawing/2014/main" id="{2B4C88DC-64E5-F3FF-AEC9-7FB6E68F415F}"/>
               </a:ext>
             </a:extLst>
           </p:cNvPr>
@@ -13749,7 +13749,7 @@
           <p:cNvPr id="17" name="TextBox 16">
             <a:extLst>
               <a:ext uri="{FF2B5EF4-FFF2-40B4-BE49-F238E27FC236}">
-                <a16:creationId xmlns:a16="http://schemas.microsoft.com/office/drawing/2014/main" id="{BDFE407F-FB78-B538-944B-E75D812CF1BB}"/>
+                <a16:creationId xmlns:a16="http://schemas.microsoft.com/office/drawing/2014/main" id="{0C21537B-2FE6-1B34-1076-DB2744C1F66A}"/>
               </a:ext>
             </a:extLst>
           </p:cNvPr>
@@ -13789,7 +13789,7 @@
           <p:cNvPr id="18" name="사각형: 둥근 모서리 17">
             <a:extLst>
               <a:ext uri="{FF2B5EF4-FFF2-40B4-BE49-F238E27FC236}">
-                <a16:creationId xmlns:a16="http://schemas.microsoft.com/office/drawing/2014/main" id="{E3CEA2E9-AC44-D566-39CB-4A970037E1CF}"/>
+                <a16:creationId xmlns:a16="http://schemas.microsoft.com/office/drawing/2014/main" id="{2D6E5892-CB5F-D24D-89ED-3F463416A4A6}"/>
               </a:ext>
             </a:extLst>
           </p:cNvPr>
@@ -13799,7 +13799,7 @@
         <p:spPr>
           <a:xfrm>
             <a:off x="685800" y="3505200"/>
-            <a:ext cx="10820400" cy="914400"/>
+            <a:ext cx="10820400" cy="609600"/>
           </a:xfrm>
           <a:prstGeom prst="roundRect">
             <a:avLst/>
@@ -13857,7 +13857,7 @@
           <p:cNvPr id="19" name="TextBox 18">
             <a:extLst>
               <a:ext uri="{FF2B5EF4-FFF2-40B4-BE49-F238E27FC236}">
-                <a16:creationId xmlns:a16="http://schemas.microsoft.com/office/drawing/2014/main" id="{09EF83D8-2E5D-F66F-24FD-763ED4309BA7}"/>
+                <a16:creationId xmlns:a16="http://schemas.microsoft.com/office/drawing/2014/main" id="{18BA0F0E-8F8D-5699-445E-9C22D55AC94B}"/>
               </a:ext>
             </a:extLst>
           </p:cNvPr>
@@ -13866,8 +13866,8 @@
         </p:nvSpPr>
         <p:spPr>
           <a:xfrm>
-            <a:off x="889000" y="3657600"/>
-            <a:ext cx="10414000" cy="609600"/>
+            <a:off x="889000" y="3644900"/>
+            <a:ext cx="10414000" cy="304800"/>
           </a:xfrm>
           <a:prstGeom prst="rect">
             <a:avLst/>
@@ -13881,15 +13881,15 @@
           <a:lstStyle/>
           <a:p>
             <a:r>
-              <a:rPr lang="en-US" altLang="ko-KR" sz="1000">
+              <a:rPr lang="en-US" altLang="ko-KR" sz="1400">
                 <a:solidFill>
                   <a:srgbClr val="DEEBE9"/>
                 </a:solidFill>
                 <a:latin typeface="Consolas" panose="020B0609020204030204" pitchFamily="49" charset="0"/>
               </a:rPr>
-              <a:t>&amp; .\scripts\run_mfa_year_queue_safe.ps1 -CommonPronManifest "D:\mfa_common_pron\releases\common_pron_mfa_r2_20260728\00_contract\release_manifest.json" -CommonPronAdoptionContract "D:\mfa_common_pron\releases\common_pron_mfa_r2_20260728\00_contract\adoption_contract.json" -PrepareMissingReviews</a:t>
-            </a:r>
-            <a:endParaRPr lang="ko-KR" altLang="en-US" sz="1000">
+              <a:t>&amp; ".\scripts\prepare_full_mfa_approval_reviews.ps1"</a:t>
+            </a:r>
+            <a:endParaRPr lang="ko-KR" altLang="en-US" sz="1400">
               <a:solidFill>
                 <a:srgbClr val="DEEBE9"/>
               </a:solidFill>
@@ -13903,7 +13903,7 @@
           <p:cNvPr id="20" name="TextBox 19">
             <a:extLst>
               <a:ext uri="{FF2B5EF4-FFF2-40B4-BE49-F238E27FC236}">
-                <a16:creationId xmlns:a16="http://schemas.microsoft.com/office/drawing/2014/main" id="{67D34F4B-B561-B50A-8D18-24E52A86F5DA}"/>
+                <a16:creationId xmlns:a16="http://schemas.microsoft.com/office/drawing/2014/main" id="{45B565E0-C92B-CE3A-618D-BDDEFEC1FE59}"/>
               </a:ext>
             </a:extLst>
           </p:cNvPr>
@@ -13912,7 +13912,7 @@
         </p:nvSpPr>
         <p:spPr>
           <a:xfrm>
-            <a:off x="685800" y="4737100"/>
+            <a:off x="685800" y="4381500"/>
             <a:ext cx="10820400" cy="317500"/>
           </a:xfrm>
           <a:prstGeom prst="rect">
@@ -13927,49 +13927,49 @@
           <a:lstStyle/>
           <a:p>
             <a:r>
-              <a:rPr lang="ko-KR" altLang="en-US" sz="1600" b="1">
+              <a:rPr lang="ko-KR" altLang="en-US" sz="1500" b="1">
                 <a:solidFill>
                   <a:srgbClr val="1B324D"/>
                 </a:solidFill>
                 <a:latin typeface="Malgun Gothic" panose="020B0503020000020004" pitchFamily="50" charset="-127"/>
               </a:rPr>
-              <a:t>② 연구자 승인 뒤 같은 계약으로 </a:t>
-            </a:r>
-            <a:r>
-              <a:rPr lang="en-US" altLang="ko-KR" sz="1600" b="1">
+              <a:t>② 후보 확인 뒤</a:t>
+            </a:r>
+            <a:r>
+              <a:rPr lang="en-US" altLang="ko-KR" sz="1500" b="1">
                 <a:solidFill>
                   <a:srgbClr val="1B324D"/>
                 </a:solidFill>
                 <a:latin typeface="Malgun Gothic" panose="020B0503020000020004" pitchFamily="50" charset="-127"/>
               </a:rPr>
-              <a:t>preflight </a:t>
-            </a:r>
-            <a:r>
-              <a:rPr lang="ko-KR" altLang="en-US" sz="1600" b="1">
+              <a:t>: </a:t>
+            </a:r>
+            <a:r>
+              <a:rPr lang="ko-KR" altLang="en-US" sz="1500" b="1">
                 <a:solidFill>
                   <a:srgbClr val="1B324D"/>
                 </a:solidFill>
                 <a:latin typeface="Malgun Gothic" panose="020B0503020000020004" pitchFamily="50" charset="-127"/>
               </a:rPr>
-              <a:t>재실행 → </a:t>
-            </a:r>
-            <a:r>
-              <a:rPr lang="en-US" altLang="ko-KR" sz="1600" b="1">
+              <a:t>승인 계약 → 전체 </a:t>
+            </a:r>
+            <a:r>
+              <a:rPr lang="en-US" altLang="ko-KR" sz="1500" b="1">
                 <a:solidFill>
                   <a:srgbClr val="1B324D"/>
                 </a:solidFill>
                 <a:latin typeface="Malgun Gothic" panose="020B0503020000020004" pitchFamily="50" charset="-127"/>
               </a:rPr>
-              <a:t>JSON status=GO</a:t>
-            </a:r>
-            <a:r>
-              <a:rPr lang="ko-KR" altLang="en-US" sz="1600" b="1">
+              <a:t>preflight → GO</a:t>
+            </a:r>
+            <a:r>
+              <a:rPr lang="ko-KR" altLang="en-US" sz="1500" b="1">
                 <a:solidFill>
                   <a:srgbClr val="1B324D"/>
                 </a:solidFill>
                 <a:latin typeface="Malgun Gothic" panose="020B0503020000020004" pitchFamily="50" charset="-127"/>
               </a:rPr>
-              <a:t>일 때만 큐 재실행</a:t>
+              <a:t>일 때만 연도 큐</a:t>
             </a:r>
           </a:p>
         </p:txBody>
@@ -13979,7 +13979,7 @@
           <p:cNvPr id="21" name="사각형: 둥근 모서리 20">
             <a:extLst>
               <a:ext uri="{FF2B5EF4-FFF2-40B4-BE49-F238E27FC236}">
-                <a16:creationId xmlns:a16="http://schemas.microsoft.com/office/drawing/2014/main" id="{612D84DC-A7B3-73F7-3097-AAD60CA30818}"/>
+                <a16:creationId xmlns:a16="http://schemas.microsoft.com/office/drawing/2014/main" id="{EB752B71-CCEC-6B05-C75B-0C46774E3D5E}"/>
               </a:ext>
             </a:extLst>
           </p:cNvPr>
@@ -13988,8 +13988,122 @@
         </p:nvSpPr>
         <p:spPr>
           <a:xfrm>
-            <a:off x="685800" y="5257800"/>
-            <a:ext cx="10820400" cy="673100"/>
+            <a:off x="685800" y="4787900"/>
+            <a:ext cx="10820400" cy="609600"/>
+          </a:xfrm>
+          <a:prstGeom prst="roundRect">
+            <a:avLst/>
+          </a:prstGeom>
+          <a:solidFill>
+            <a:srgbClr val="12171C"/>
+          </a:solidFill>
+          <a:ln w="19050" cap="flat" cmpd="sng" algn="ctr">
+            <a:noFill/>
+            <a:prstDash val="solid"/>
+            <a:miter lim="800000"/>
+          </a:ln>
+          <a:effectLst/>
+          <a:extLst>
+            <a:ext uri="{91240B29-F687-4F45-9708-019B960494DF}">
+              <a14:hiddenLine xmlns:a14="http://schemas.microsoft.com/office/drawing/2010/main" w="19050" cap="flat" cmpd="sng" algn="ctr">
+                <a:solidFill>
+                  <a:schemeClr val="accent1">
+                    <a:shade val="15000"/>
+                  </a:schemeClr>
+                </a:solidFill>
+                <a:prstDash val="solid"/>
+                <a:miter lim="800000"/>
+              </a14:hiddenLine>
+            </a:ext>
+          </a:extLst>
+        </p:spPr>
+        <p:style>
+          <a:lnRef idx="2">
+            <a:schemeClr val="accent1">
+              <a:shade val="15000"/>
+            </a:schemeClr>
+          </a:lnRef>
+          <a:fillRef idx="1">
+            <a:schemeClr val="accent1"/>
+          </a:fillRef>
+          <a:effectRef idx="0">
+            <a:schemeClr val="accent1"/>
+          </a:effectRef>
+          <a:fontRef idx="minor">
+            <a:schemeClr val="lt1"/>
+          </a:fontRef>
+        </p:style>
+        <p:txBody>
+          <a:bodyPr rtlCol="0" anchor="ctr"/>
+          <a:lstStyle/>
+          <a:p>
+            <a:pPr algn="ctr"/>
+            <a:endParaRPr lang="ko-KR" altLang="en-US"/>
+          </a:p>
+        </p:txBody>
+      </p:sp>
+      <p:sp>
+        <p:nvSpPr>
+          <p:cNvPr id="22" name="TextBox 21">
+            <a:extLst>
+              <a:ext uri="{FF2B5EF4-FFF2-40B4-BE49-F238E27FC236}">
+                <a16:creationId xmlns:a16="http://schemas.microsoft.com/office/drawing/2014/main" id="{61DA89C2-345E-D974-2A8C-7CE2FD568DE5}"/>
+              </a:ext>
+            </a:extLst>
+          </p:cNvPr>
+          <p:cNvSpPr txBox="1"/>
+          <p:nvPr/>
+        </p:nvSpPr>
+        <p:spPr>
+          <a:xfrm>
+            <a:off x="889000" y="4927600"/>
+            <a:ext cx="10414000" cy="304800"/>
+          </a:xfrm>
+          <a:prstGeom prst="rect">
+            <a:avLst/>
+          </a:prstGeom>
+          <a:noFill/>
+        </p:spPr>
+        <p:txBody>
+          <a:bodyPr vert="horz" wrap="square" lIns="0" tIns="0" rIns="0" bIns="0" rtlCol="0" anchor="t">
+            <a:noAutofit/>
+          </a:bodyPr>
+          <a:lstStyle/>
+          <a:p>
+            <a:r>
+              <a:rPr lang="en-US" altLang="ko-KR" sz="1400">
+                <a:solidFill>
+                  <a:srgbClr val="DEEBE9"/>
+                </a:solidFill>
+                <a:latin typeface="Consolas" panose="020B0609020204030204" pitchFamily="49" charset="0"/>
+              </a:rPr>
+              <a:t>&amp; ".\scripts\start_full_mfa_after_review.ps1" -ApprovedBy "ari30"</a:t>
+            </a:r>
+            <a:endParaRPr lang="ko-KR" altLang="en-US" sz="1400">
+              <a:solidFill>
+                <a:srgbClr val="DEEBE9"/>
+              </a:solidFill>
+              <a:latin typeface="Consolas" panose="020B0609020204030204" pitchFamily="49" charset="0"/>
+            </a:endParaRPr>
+          </a:p>
+        </p:txBody>
+      </p:sp>
+      <p:sp>
+        <p:nvSpPr>
+          <p:cNvPr id="23" name="사각형: 둥근 모서리 22">
+            <a:extLst>
+              <a:ext uri="{FF2B5EF4-FFF2-40B4-BE49-F238E27FC236}">
+                <a16:creationId xmlns:a16="http://schemas.microsoft.com/office/drawing/2014/main" id="{3FAB3FCE-73F5-F1AC-8055-841CDF1004B1}"/>
+              </a:ext>
+            </a:extLst>
+          </p:cNvPr>
+          <p:cNvSpPr/>
+          <p:nvPr/>
+        </p:nvSpPr>
+        <p:spPr>
+          <a:xfrm>
+            <a:off x="685800" y="5651500"/>
+            <a:ext cx="10820400" cy="495300"/>
           </a:xfrm>
           <a:prstGeom prst="roundRect">
             <a:avLst/>
@@ -14044,10 +14158,10 @@
       </p:sp>
       <p:sp>
         <p:nvSpPr>
-          <p:cNvPr id="22" name="TextBox 21">
-            <a:extLst>
-              <a:ext uri="{FF2B5EF4-FFF2-40B4-BE49-F238E27FC236}">
-                <a16:creationId xmlns:a16="http://schemas.microsoft.com/office/drawing/2014/main" id="{4E230E2D-A4EB-77FE-C23B-E86C2DFDBD0B}"/>
+          <p:cNvPr id="24" name="TextBox 23">
+            <a:extLst>
+              <a:ext uri="{FF2B5EF4-FFF2-40B4-BE49-F238E27FC236}">
+                <a16:creationId xmlns:a16="http://schemas.microsoft.com/office/drawing/2014/main" id="{9A137C0D-AC0A-A2FA-1DA4-741F0927877D}"/>
               </a:ext>
             </a:extLst>
           </p:cNvPr>
@@ -14056,8 +14170,8 @@
         </p:nvSpPr>
         <p:spPr>
           <a:xfrm>
-            <a:off x="889000" y="5461000"/>
-            <a:ext cx="10414000" cy="304800"/>
+            <a:off x="889000" y="5765800"/>
+            <a:ext cx="10414000" cy="266700"/>
           </a:xfrm>
           <a:prstGeom prst="rect">
             <a:avLst/>
@@ -14071,114 +14185,87 @@
           <a:lstStyle/>
           <a:p>
             <a:r>
-              <a:rPr lang="ko-KR" altLang="en-US" sz="1400" b="1">
+              <a:rPr lang="en-US" altLang="ko-KR" sz="1300" b="1">
                 <a:solidFill>
                   <a:srgbClr val="CD5C46"/>
                 </a:solidFill>
                 <a:latin typeface="Malgun Gothic" panose="020B0503020000020004" pitchFamily="50" charset="-127"/>
               </a:rPr>
-              <a:t>오늘 전수 </a:t>
-            </a:r>
-            <a:r>
-              <a:rPr lang="en-US" altLang="ko-KR" sz="1400" b="1">
+              <a:t>1</a:t>
+            </a:r>
+            <a:r>
+              <a:rPr lang="ko-KR" altLang="en-US" sz="1300" b="1">
                 <a:solidFill>
                   <a:srgbClr val="CD5C46"/>
                 </a:solidFill>
                 <a:latin typeface="Malgun Gothic" panose="020B0503020000020004" pitchFamily="50" charset="-127"/>
               </a:rPr>
-              <a:t>MFA</a:t>
-            </a:r>
-            <a:r>
-              <a:rPr lang="ko-KR" altLang="en-US" sz="1400" b="1">
+              <a:t>단계는 </a:t>
+            </a:r>
+            <a:r>
+              <a:rPr lang="en-US" altLang="ko-KR" sz="1300" b="1">
                 <a:solidFill>
                   <a:srgbClr val="CD5C46"/>
                 </a:solidFill>
                 <a:latin typeface="Malgun Gothic" panose="020B0503020000020004" pitchFamily="50" charset="-127"/>
               </a:rPr>
-              <a:t>를 바로 걸지 않는다</a:t>
-            </a:r>
-            <a:r>
-              <a:rPr lang="en-US" altLang="ko-KR" sz="1400" b="1">
+              <a:t>MFA·WAV </a:t>
+            </a:r>
+            <a:r>
+              <a:rPr lang="ko-KR" altLang="en-US" sz="1300" b="1">
                 <a:solidFill>
                   <a:srgbClr val="CD5C46"/>
                 </a:solidFill>
                 <a:latin typeface="Malgun Gothic" panose="020B0503020000020004" pitchFamily="50" charset="-127"/>
               </a:rPr>
-              <a:t>. </a:t>
-            </a:r>
-            <a:r>
-              <a:rPr lang="ko-KR" altLang="en-US" sz="1400" b="1">
+              <a:t>이동</a:t>
+            </a:r>
+            <a:r>
+              <a:rPr lang="en-US" altLang="ko-KR" sz="1300" b="1">
                 <a:solidFill>
                   <a:srgbClr val="CD5C46"/>
                 </a:solidFill>
                 <a:latin typeface="Malgun Gothic" panose="020B0503020000020004" pitchFamily="50" charset="-127"/>
               </a:rPr>
-              <a:t>승인자료 생성은 안전하며 </a:t>
-            </a:r>
-            <a:r>
-              <a:rPr lang="en-US" altLang="ko-KR" sz="1400" b="1">
+              <a:t>·</a:t>
+            </a:r>
+            <a:r>
+              <a:rPr lang="ko-KR" altLang="en-US" sz="1300" b="1">
                 <a:solidFill>
                   <a:srgbClr val="CD5C46"/>
                 </a:solidFill>
                 <a:latin typeface="Malgun Gothic" panose="020B0503020000020004" pitchFamily="50" charset="-127"/>
               </a:rPr>
-              <a:t>WAV </a:t>
-            </a:r>
-            <a:r>
-              <a:rPr lang="ko-KR" altLang="en-US" sz="1400" b="1">
+              <a:t>자동 승인</a:t>
+            </a:r>
+            <a:r>
+              <a:rPr lang="en-US" altLang="ko-KR" sz="1300" b="1">
                 <a:solidFill>
                   <a:srgbClr val="CD5C46"/>
                 </a:solidFill>
                 <a:latin typeface="Malgun Gothic" panose="020B0503020000020004" pitchFamily="50" charset="-127"/>
               </a:rPr>
-              <a:t>이동</a:t>
-            </a:r>
-            <a:r>
-              <a:rPr lang="en-US" altLang="ko-KR" sz="1400" b="1">
+              <a:t>·</a:t>
+            </a:r>
+            <a:r>
+              <a:rPr lang="ko-KR" altLang="en-US" sz="1300" b="1">
                 <a:solidFill>
                   <a:srgbClr val="CD5C46"/>
                 </a:solidFill>
                 <a:latin typeface="Malgun Gothic" panose="020B0503020000020004" pitchFamily="50" charset="-127"/>
               </a:rPr>
-              <a:t>·</a:t>
-            </a:r>
-            <a:r>
-              <a:rPr lang="ko-KR" altLang="en-US" sz="1400" b="1">
+              <a:t>정본 승격을 하지 않는다</a:t>
+            </a:r>
+            <a:r>
+              <a:rPr lang="en-US" altLang="ko-KR" sz="1300" b="1">
                 <a:solidFill>
                   <a:srgbClr val="CD5C46"/>
                 </a:solidFill>
                 <a:latin typeface="Malgun Gothic" panose="020B0503020000020004" pitchFamily="50" charset="-127"/>
               </a:rPr>
-              <a:t>정렬</a:t>
-            </a:r>
-            <a:r>
-              <a:rPr lang="en-US" altLang="ko-KR" sz="1400" b="1">
-                <a:solidFill>
-                  <a:srgbClr val="CD5C46"/>
-                </a:solidFill>
-                <a:latin typeface="Malgun Gothic" panose="020B0503020000020004" pitchFamily="50" charset="-127"/>
-              </a:rPr>
-              <a:t>·</a:t>
-            </a:r>
-            <a:r>
-              <a:rPr lang="ko-KR" altLang="en-US" sz="1400" b="1">
-                <a:solidFill>
-                  <a:srgbClr val="CD5C46"/>
-                </a:solidFill>
-                <a:latin typeface="Malgun Gothic" panose="020B0503020000020004" pitchFamily="50" charset="-127"/>
-              </a:rPr>
-              <a:t>정본 승격을 하지 않는다</a:t>
-            </a:r>
-            <a:r>
-              <a:rPr lang="en-US" altLang="ko-KR" sz="1400" b="1">
-                <a:solidFill>
-                  <a:srgbClr val="CD5C46"/>
-                </a:solidFill>
-                <a:latin typeface="Malgun Gothic" panose="020B0503020000020004" pitchFamily="50" charset="-127"/>
-              </a:rPr>
               <a:t>.</a:t>
             </a:r>
-            <a:endParaRPr lang="ko-KR" altLang="en-US" sz="1400" b="1">
+            <a:endParaRPr lang="ko-KR" altLang="en-US" sz="1300" b="1">
               <a:solidFill>
                 <a:srgbClr val="CD5C46"/>
               </a:solidFill>
@@ -14189,10 +14276,10 @@
       </p:sp>
       <p:cxnSp>
         <p:nvCxnSpPr>
-          <p:cNvPr id="23" name="직선 연결선 22">
-            <a:extLst>
-              <a:ext uri="{FF2B5EF4-FFF2-40B4-BE49-F238E27FC236}">
-                <a16:creationId xmlns:a16="http://schemas.microsoft.com/office/drawing/2014/main" id="{EB6471EB-4AF7-8045-AFCD-869DE8CE4798}"/>
+          <p:cNvPr id="25" name="직선 연결선 24">
+            <a:extLst>
+              <a:ext uri="{FF2B5EF4-FFF2-40B4-BE49-F238E27FC236}">
+                <a16:creationId xmlns:a16="http://schemas.microsoft.com/office/drawing/2014/main" id="{CF1AF281-44FE-92A4-C419-0BC03DD0335C}"/>
               </a:ext>
             </a:extLst>
           </p:cNvPr>
@@ -14230,10 +14317,10 @@
       </p:cxnSp>
       <p:sp>
         <p:nvSpPr>
-          <p:cNvPr id="24" name="TextBox 23">
-            <a:extLst>
-              <a:ext uri="{FF2B5EF4-FFF2-40B4-BE49-F238E27FC236}">
-                <a16:creationId xmlns:a16="http://schemas.microsoft.com/office/drawing/2014/main" id="{A76DC5F3-FD93-AC86-ABE8-604E90401370}"/>
+          <p:cNvPr id="26" name="TextBox 25">
+            <a:extLst>
+              <a:ext uri="{FF2B5EF4-FFF2-40B4-BE49-F238E27FC236}">
+                <a16:creationId xmlns:a16="http://schemas.microsoft.com/office/drawing/2014/main" id="{F1C0F239-3038-9FEC-AAA1-1CC75A447968}"/>
               </a:ext>
             </a:extLst>
           </p:cNvPr>
@@ -14315,10 +14402,10 @@
       </p:sp>
       <p:sp>
         <p:nvSpPr>
-          <p:cNvPr id="25" name="TextBox 24">
-            <a:extLst>
-              <a:ext uri="{FF2B5EF4-FFF2-40B4-BE49-F238E27FC236}">
-                <a16:creationId xmlns:a16="http://schemas.microsoft.com/office/drawing/2014/main" id="{FDAAB7E6-C1D6-4CE9-4840-A61DB6E39C64}"/>
+          <p:cNvPr id="27" name="TextBox 26">
+            <a:extLst>
+              <a:ext uri="{FF2B5EF4-FFF2-40B4-BE49-F238E27FC236}">
+                <a16:creationId xmlns:a16="http://schemas.microsoft.com/office/drawing/2014/main" id="{D36F097E-BF9A-0165-F402-9C763869ED41}"/>
               </a:ext>
             </a:extLst>
           </p:cNvPr>
@@ -14363,7 +14450,7 @@
     </p:spTree>
     <p:extLst>
       <p:ext uri="{BB962C8B-B14F-4D97-AF65-F5344CB8AC3E}">
-        <p14:creationId xmlns:p14="http://schemas.microsoft.com/office/powerpoint/2010/main" val="3490375824"/>
+        <p14:creationId xmlns:p14="http://schemas.microsoft.com/office/powerpoint/2010/main" val="1282277067"/>
       </p:ext>
     </p:extLst>
   </p:cSld>
@@ -14403,7 +14490,7 @@
           <p:cNvPr id="2" name="TextBox 1">
             <a:extLst>
               <a:ext uri="{FF2B5EF4-FFF2-40B4-BE49-F238E27FC236}">
-                <a16:creationId xmlns:a16="http://schemas.microsoft.com/office/drawing/2014/main" id="{424996D4-C1A9-DC54-DE8D-D2C5ED26711C}"/>
+                <a16:creationId xmlns:a16="http://schemas.microsoft.com/office/drawing/2014/main" id="{732C0FFA-99E4-9CF1-4AFA-1B784ACE555F}"/>
               </a:ext>
             </a:extLst>
           </p:cNvPr>
@@ -14449,7 +14536,7 @@
           <p:cNvPr id="3" name="TextBox 2">
             <a:extLst>
               <a:ext uri="{FF2B5EF4-FFF2-40B4-BE49-F238E27FC236}">
-                <a16:creationId xmlns:a16="http://schemas.microsoft.com/office/drawing/2014/main" id="{06959762-9A91-CE97-9078-3C3EC3E8B8BA}"/>
+                <a16:creationId xmlns:a16="http://schemas.microsoft.com/office/drawing/2014/main" id="{71F3C40E-3337-DA38-0D04-FBED2AAB4A3B}"/>
               </a:ext>
             </a:extLst>
           </p:cNvPr>
@@ -14509,7 +14596,7 @@
           <p:cNvPr id="4" name="직사각형 3">
             <a:extLst>
               <a:ext uri="{FF2B5EF4-FFF2-40B4-BE49-F238E27FC236}">
-                <a16:creationId xmlns:a16="http://schemas.microsoft.com/office/drawing/2014/main" id="{19BA894E-C297-A1B1-1946-3D596FB4955C}"/>
+                <a16:creationId xmlns:a16="http://schemas.microsoft.com/office/drawing/2014/main" id="{95E88766-FD1E-826F-C93A-3A2BDBD2C6D8}"/>
               </a:ext>
             </a:extLst>
           </p:cNvPr>
@@ -14577,7 +14664,7 @@
           <p:cNvPr id="5" name="TextBox 4">
             <a:extLst>
               <a:ext uri="{FF2B5EF4-FFF2-40B4-BE49-F238E27FC236}">
-                <a16:creationId xmlns:a16="http://schemas.microsoft.com/office/drawing/2014/main" id="{5CBC6148-55ED-F5BE-4FF2-F2501AE652C8}"/>
+                <a16:creationId xmlns:a16="http://schemas.microsoft.com/office/drawing/2014/main" id="{6DB1B1CD-BE5D-7712-7FB9-E7371DDF4726}"/>
               </a:ext>
             </a:extLst>
           </p:cNvPr>
@@ -14875,7 +14962,7 @@
           <p:cNvPr id="6" name="TextBox 5">
             <a:extLst>
               <a:ext uri="{FF2B5EF4-FFF2-40B4-BE49-F238E27FC236}">
-                <a16:creationId xmlns:a16="http://schemas.microsoft.com/office/drawing/2014/main" id="{E93FEB70-8EC6-AC2C-097C-E1D237792046}"/>
+                <a16:creationId xmlns:a16="http://schemas.microsoft.com/office/drawing/2014/main" id="{4A6B0A2B-D5F6-230E-AF86-8478D94A2429}"/>
               </a:ext>
             </a:extLst>
           </p:cNvPr>
@@ -14915,7 +15002,7 @@
           <p:cNvPr id="7" name="TextBox 6">
             <a:extLst>
               <a:ext uri="{FF2B5EF4-FFF2-40B4-BE49-F238E27FC236}">
-                <a16:creationId xmlns:a16="http://schemas.microsoft.com/office/drawing/2014/main" id="{3464CC18-31CB-697B-11F2-2737CE75D54D}"/>
+                <a16:creationId xmlns:a16="http://schemas.microsoft.com/office/drawing/2014/main" id="{4312CB86-091B-8127-92F6-8A373267DBAD}"/>
               </a:ext>
             </a:extLst>
           </p:cNvPr>
@@ -15006,7 +15093,7 @@
           <p:cNvPr id="8" name="TextBox 7">
             <a:extLst>
               <a:ext uri="{FF2B5EF4-FFF2-40B4-BE49-F238E27FC236}">
-                <a16:creationId xmlns:a16="http://schemas.microsoft.com/office/drawing/2014/main" id="{46158DE9-940A-1C68-8605-80A78B779F2B}"/>
+                <a16:creationId xmlns:a16="http://schemas.microsoft.com/office/drawing/2014/main" id="{7E3CE1C9-D8AA-BAA3-37BC-1D17BCAAF902}"/>
               </a:ext>
             </a:extLst>
           </p:cNvPr>
@@ -15116,7 +15203,7 @@
     </p:spTree>
     <p:extLst>
       <p:ext uri="{BB962C8B-B14F-4D97-AF65-F5344CB8AC3E}">
-        <p14:creationId xmlns:p14="http://schemas.microsoft.com/office/powerpoint/2010/main" val="3389368228"/>
+        <p14:creationId xmlns:p14="http://schemas.microsoft.com/office/powerpoint/2010/main" val="787530246"/>
       </p:ext>
     </p:extLst>
   </p:cSld>
@@ -15148,7 +15235,7 @@
           <p:cNvPr id="2" name="TextBox 1">
             <a:extLst>
               <a:ext uri="{FF2B5EF4-FFF2-40B4-BE49-F238E27FC236}">
-                <a16:creationId xmlns:a16="http://schemas.microsoft.com/office/drawing/2014/main" id="{B5B55C3B-D362-D98E-F636-032834AA9121}"/>
+                <a16:creationId xmlns:a16="http://schemas.microsoft.com/office/drawing/2014/main" id="{F78B709C-5F00-8693-9226-DDFFF6119C98}"/>
               </a:ext>
             </a:extLst>
           </p:cNvPr>
@@ -15197,7 +15284,7 @@
           <p:cNvPr id="3" name="TextBox 2">
             <a:extLst>
               <a:ext uri="{FF2B5EF4-FFF2-40B4-BE49-F238E27FC236}">
-                <a16:creationId xmlns:a16="http://schemas.microsoft.com/office/drawing/2014/main" id="{91A2733E-82FD-1567-2DF2-E00DF22B0D0B}"/>
+                <a16:creationId xmlns:a16="http://schemas.microsoft.com/office/drawing/2014/main" id="{90CD446E-1605-811A-E73A-3FA9B868D54A}"/>
               </a:ext>
             </a:extLst>
           </p:cNvPr>
@@ -15237,7 +15324,7 @@
           <p:cNvPr id="4" name="직사각형 3">
             <a:extLst>
               <a:ext uri="{FF2B5EF4-FFF2-40B4-BE49-F238E27FC236}">
-                <a16:creationId xmlns:a16="http://schemas.microsoft.com/office/drawing/2014/main" id="{EAA6D8C5-8248-44AF-99CA-50D0BE698C16}"/>
+                <a16:creationId xmlns:a16="http://schemas.microsoft.com/office/drawing/2014/main" id="{67724E47-B8D7-AA3D-9AC0-2DCCDB1CEF9D}"/>
               </a:ext>
             </a:extLst>
           </p:cNvPr>
@@ -15305,7 +15392,7 @@
           <p:cNvPr id="5" name="TextBox 4">
             <a:extLst>
               <a:ext uri="{FF2B5EF4-FFF2-40B4-BE49-F238E27FC236}">
-                <a16:creationId xmlns:a16="http://schemas.microsoft.com/office/drawing/2014/main" id="{CB6C09F6-5878-B8D7-D054-8AD05C0AE0EE}"/>
+                <a16:creationId xmlns:a16="http://schemas.microsoft.com/office/drawing/2014/main" id="{8ACAE7DE-B3A9-B83D-96EA-8D9C6AD1C0BD}"/>
               </a:ext>
             </a:extLst>
           </p:cNvPr>
@@ -15351,7 +15438,7 @@
           <p:cNvPr id="6" name="TextBox 5">
             <a:extLst>
               <a:ext uri="{FF2B5EF4-FFF2-40B4-BE49-F238E27FC236}">
-                <a16:creationId xmlns:a16="http://schemas.microsoft.com/office/drawing/2014/main" id="{04DC196C-9053-B50E-D1C9-1236C249DB4D}"/>
+                <a16:creationId xmlns:a16="http://schemas.microsoft.com/office/drawing/2014/main" id="{E2AF1547-C477-D51A-75A6-FE6284FDF288}"/>
               </a:ext>
             </a:extLst>
           </p:cNvPr>
@@ -15391,7 +15478,7 @@
           <p:cNvPr id="7" name="TextBox 6">
             <a:extLst>
               <a:ext uri="{FF2B5EF4-FFF2-40B4-BE49-F238E27FC236}">
-                <a16:creationId xmlns:a16="http://schemas.microsoft.com/office/drawing/2014/main" id="{1267F18B-C2E4-3FCB-F8D5-3DB78502498B}"/>
+                <a16:creationId xmlns:a16="http://schemas.microsoft.com/office/drawing/2014/main" id="{2EE80ADF-6373-C0ED-45C3-235CDA6C6162}"/>
               </a:ext>
             </a:extLst>
           </p:cNvPr>
@@ -15478,7 +15565,7 @@
           <p:cNvPr id="8" name="직선 연결선 7">
             <a:extLst>
               <a:ext uri="{FF2B5EF4-FFF2-40B4-BE49-F238E27FC236}">
-                <a16:creationId xmlns:a16="http://schemas.microsoft.com/office/drawing/2014/main" id="{C91F4620-ED71-BD27-9874-A09AC8FDACAD}"/>
+                <a16:creationId xmlns:a16="http://schemas.microsoft.com/office/drawing/2014/main" id="{43ACD664-79FE-F195-1E4B-AF6B8DAAA7B7}"/>
               </a:ext>
             </a:extLst>
           </p:cNvPr>
@@ -15519,7 +15606,7 @@
           <p:cNvPr id="9" name="TextBox 8">
             <a:extLst>
               <a:ext uri="{FF2B5EF4-FFF2-40B4-BE49-F238E27FC236}">
-                <a16:creationId xmlns:a16="http://schemas.microsoft.com/office/drawing/2014/main" id="{E8883625-BF16-2752-EE89-4191C47BEE47}"/>
+                <a16:creationId xmlns:a16="http://schemas.microsoft.com/office/drawing/2014/main" id="{80D4F266-7354-C2E8-4F7F-E44775C5AB25}"/>
               </a:ext>
             </a:extLst>
           </p:cNvPr>
@@ -15565,7 +15652,7 @@
           <p:cNvPr id="10" name="TextBox 9">
             <a:extLst>
               <a:ext uri="{FF2B5EF4-FFF2-40B4-BE49-F238E27FC236}">
-                <a16:creationId xmlns:a16="http://schemas.microsoft.com/office/drawing/2014/main" id="{8AF18A45-599C-3129-5FD7-2D2CE96CCB8E}"/>
+                <a16:creationId xmlns:a16="http://schemas.microsoft.com/office/drawing/2014/main" id="{9BDBB241-8CFF-773C-85A8-62370CEF54C4}"/>
               </a:ext>
             </a:extLst>
           </p:cNvPr>
@@ -15605,7 +15692,7 @@
           <p:cNvPr id="11" name="TextBox 10">
             <a:extLst>
               <a:ext uri="{FF2B5EF4-FFF2-40B4-BE49-F238E27FC236}">
-                <a16:creationId xmlns:a16="http://schemas.microsoft.com/office/drawing/2014/main" id="{19D8832A-763B-C8EA-7EDA-519129CBB48C}"/>
+                <a16:creationId xmlns:a16="http://schemas.microsoft.com/office/drawing/2014/main" id="{ADAACF1B-557E-6BA3-5E93-1CF880BFCADF}"/>
               </a:ext>
             </a:extLst>
           </p:cNvPr>
@@ -15683,7 +15770,7 @@
           <p:cNvPr id="12" name="직선 연결선 11">
             <a:extLst>
               <a:ext uri="{FF2B5EF4-FFF2-40B4-BE49-F238E27FC236}">
-                <a16:creationId xmlns:a16="http://schemas.microsoft.com/office/drawing/2014/main" id="{C04D9D1F-0F7A-4697-1100-C6C407428644}"/>
+                <a16:creationId xmlns:a16="http://schemas.microsoft.com/office/drawing/2014/main" id="{399C22BD-E8F0-E3EA-91C1-4B44D924947C}"/>
               </a:ext>
             </a:extLst>
           </p:cNvPr>
@@ -15724,7 +15811,7 @@
           <p:cNvPr id="13" name="TextBox 12">
             <a:extLst>
               <a:ext uri="{FF2B5EF4-FFF2-40B4-BE49-F238E27FC236}">
-                <a16:creationId xmlns:a16="http://schemas.microsoft.com/office/drawing/2014/main" id="{9EEF51D5-B226-41E9-E9E8-9D2B5B6C3715}"/>
+                <a16:creationId xmlns:a16="http://schemas.microsoft.com/office/drawing/2014/main" id="{0CFFBAB8-64BE-0CDF-0761-4CD0BD72D2FE}"/>
               </a:ext>
             </a:extLst>
           </p:cNvPr>
@@ -15770,7 +15857,7 @@
           <p:cNvPr id="14" name="TextBox 13">
             <a:extLst>
               <a:ext uri="{FF2B5EF4-FFF2-40B4-BE49-F238E27FC236}">
-                <a16:creationId xmlns:a16="http://schemas.microsoft.com/office/drawing/2014/main" id="{2A150999-8D28-A50B-F18C-60BBBF0A4C46}"/>
+                <a16:creationId xmlns:a16="http://schemas.microsoft.com/office/drawing/2014/main" id="{1BC1A3F5-0C44-171E-6ADA-582560FB267E}"/>
               </a:ext>
             </a:extLst>
           </p:cNvPr>
@@ -15810,7 +15897,7 @@
           <p:cNvPr id="15" name="TextBox 14">
             <a:extLst>
               <a:ext uri="{FF2B5EF4-FFF2-40B4-BE49-F238E27FC236}">
-                <a16:creationId xmlns:a16="http://schemas.microsoft.com/office/drawing/2014/main" id="{01CBAD36-1C02-AD30-927C-F47350655A54}"/>
+                <a16:creationId xmlns:a16="http://schemas.microsoft.com/office/drawing/2014/main" id="{95915B31-D2E3-D53B-2842-31410A502FC2}"/>
               </a:ext>
             </a:extLst>
           </p:cNvPr>
@@ -15897,7 +15984,7 @@
           <p:cNvPr id="16" name="사각형: 둥근 모서리 15">
             <a:extLst>
               <a:ext uri="{FF2B5EF4-FFF2-40B4-BE49-F238E27FC236}">
-                <a16:creationId xmlns:a16="http://schemas.microsoft.com/office/drawing/2014/main" id="{C8A26F00-5F5B-850C-ED72-C15372502BC7}"/>
+                <a16:creationId xmlns:a16="http://schemas.microsoft.com/office/drawing/2014/main" id="{E30A78B7-6A8F-1CA4-EA85-1565360392ED}"/>
               </a:ext>
             </a:extLst>
           </p:cNvPr>
@@ -15965,7 +16052,7 @@
           <p:cNvPr id="17" name="TextBox 16">
             <a:extLst>
               <a:ext uri="{FF2B5EF4-FFF2-40B4-BE49-F238E27FC236}">
-                <a16:creationId xmlns:a16="http://schemas.microsoft.com/office/drawing/2014/main" id="{00CFAAAF-DC37-B17D-6B4A-8CCE2DF7C295}"/>
+                <a16:creationId xmlns:a16="http://schemas.microsoft.com/office/drawing/2014/main" id="{2D261E4D-54C9-918C-8A39-502512410C7B}"/>
               </a:ext>
             </a:extLst>
           </p:cNvPr>
@@ -16005,7 +16092,7 @@
           <p:cNvPr id="18" name="TextBox 17">
             <a:extLst>
               <a:ext uri="{FF2B5EF4-FFF2-40B4-BE49-F238E27FC236}">
-                <a16:creationId xmlns:a16="http://schemas.microsoft.com/office/drawing/2014/main" id="{01261F84-F8D6-ABDC-79DB-FECD14242D29}"/>
+                <a16:creationId xmlns:a16="http://schemas.microsoft.com/office/drawing/2014/main" id="{1194FD53-0874-AB64-C766-422761C4356A}"/>
               </a:ext>
             </a:extLst>
           </p:cNvPr>
@@ -16132,7 +16219,7 @@
           <p:cNvPr id="19" name="직선 연결선 18">
             <a:extLst>
               <a:ext uri="{FF2B5EF4-FFF2-40B4-BE49-F238E27FC236}">
-                <a16:creationId xmlns:a16="http://schemas.microsoft.com/office/drawing/2014/main" id="{4F0C8A4C-CC38-A08A-E92E-98205547AD8B}"/>
+                <a16:creationId xmlns:a16="http://schemas.microsoft.com/office/drawing/2014/main" id="{A9BF0DA3-B2EE-6D23-1A64-E013E6F099CE}"/>
               </a:ext>
             </a:extLst>
           </p:cNvPr>
@@ -16173,7 +16260,7 @@
           <p:cNvPr id="20" name="TextBox 19">
             <a:extLst>
               <a:ext uri="{FF2B5EF4-FFF2-40B4-BE49-F238E27FC236}">
-                <a16:creationId xmlns:a16="http://schemas.microsoft.com/office/drawing/2014/main" id="{32AA49BE-9AA3-BE49-BED9-3246F947608D}"/>
+                <a16:creationId xmlns:a16="http://schemas.microsoft.com/office/drawing/2014/main" id="{C3829C5F-C1D2-A8B2-64AA-5FB57290517A}"/>
               </a:ext>
             </a:extLst>
           </p:cNvPr>
@@ -16258,7 +16345,7 @@
           <p:cNvPr id="21" name="TextBox 20">
             <a:extLst>
               <a:ext uri="{FF2B5EF4-FFF2-40B4-BE49-F238E27FC236}">
-                <a16:creationId xmlns:a16="http://schemas.microsoft.com/office/drawing/2014/main" id="{B5D5539B-DCC2-BD89-3A2D-9A21E3B5B12E}"/>
+                <a16:creationId xmlns:a16="http://schemas.microsoft.com/office/drawing/2014/main" id="{8E454270-A7FE-2923-CA7B-11258479725A}"/>
               </a:ext>
             </a:extLst>
           </p:cNvPr>
@@ -16303,7 +16390,7 @@
     </p:spTree>
     <p:extLst>
       <p:ext uri="{BB962C8B-B14F-4D97-AF65-F5344CB8AC3E}">
-        <p14:creationId xmlns:p14="http://schemas.microsoft.com/office/powerpoint/2010/main" val="2271379065"/>
+        <p14:creationId xmlns:p14="http://schemas.microsoft.com/office/powerpoint/2010/main" val="1707413153"/>
       </p:ext>
     </p:extLst>
   </p:cSld>
@@ -16335,7 +16422,7 @@
           <p:cNvPr id="2" name="TextBox 1">
             <a:extLst>
               <a:ext uri="{FF2B5EF4-FFF2-40B4-BE49-F238E27FC236}">
-                <a16:creationId xmlns:a16="http://schemas.microsoft.com/office/drawing/2014/main" id="{37B1DEFB-6A70-382D-5C25-BEF0835D57C6}"/>
+                <a16:creationId xmlns:a16="http://schemas.microsoft.com/office/drawing/2014/main" id="{E5099CBB-52D2-F83E-8C80-B38551BC215E}"/>
               </a:ext>
             </a:extLst>
           </p:cNvPr>
@@ -16384,7 +16471,7 @@
           <p:cNvPr id="3" name="TextBox 2">
             <a:extLst>
               <a:ext uri="{FF2B5EF4-FFF2-40B4-BE49-F238E27FC236}">
-                <a16:creationId xmlns:a16="http://schemas.microsoft.com/office/drawing/2014/main" id="{5C170273-D368-5824-4D4F-8B320634C798}"/>
+                <a16:creationId xmlns:a16="http://schemas.microsoft.com/office/drawing/2014/main" id="{0FD6CA02-84B7-3B63-B591-957B0666A58D}"/>
               </a:ext>
             </a:extLst>
           </p:cNvPr>
@@ -16424,7 +16511,7 @@
           <p:cNvPr id="4" name="직사각형 3">
             <a:extLst>
               <a:ext uri="{FF2B5EF4-FFF2-40B4-BE49-F238E27FC236}">
-                <a16:creationId xmlns:a16="http://schemas.microsoft.com/office/drawing/2014/main" id="{338C4C19-B912-2CB1-AD3C-7777E2233728}"/>
+                <a16:creationId xmlns:a16="http://schemas.microsoft.com/office/drawing/2014/main" id="{6C8D71BC-60BC-ACC0-B850-A00D64A8671C}"/>
               </a:ext>
             </a:extLst>
           </p:cNvPr>
@@ -16492,7 +16579,7 @@
           <p:cNvPr id="5" name="사각형: 둥근 모서리 4">
             <a:extLst>
               <a:ext uri="{FF2B5EF4-FFF2-40B4-BE49-F238E27FC236}">
-                <a16:creationId xmlns:a16="http://schemas.microsoft.com/office/drawing/2014/main" id="{9CA56365-75C5-59DA-F8AB-F8E9E61EF504}"/>
+                <a16:creationId xmlns:a16="http://schemas.microsoft.com/office/drawing/2014/main" id="{4D7A4A77-514E-888E-DF63-192425545A93}"/>
               </a:ext>
             </a:extLst>
           </p:cNvPr>
@@ -16546,7 +16633,7 @@
           <p:cNvPr id="7" name="그림 6">
             <a:extLst>
               <a:ext uri="{FF2B5EF4-FFF2-40B4-BE49-F238E27FC236}">
-                <a16:creationId xmlns:a16="http://schemas.microsoft.com/office/drawing/2014/main" id="{5F95EC64-C975-16ED-A4F3-F6E261510AF8}"/>
+                <a16:creationId xmlns:a16="http://schemas.microsoft.com/office/drawing/2014/main" id="{9F482932-7F1B-1727-2E37-19F55FD0CDD8}"/>
               </a:ext>
             </a:extLst>
           </p:cNvPr>
@@ -16582,7 +16669,7 @@
           <p:cNvPr id="8" name="TextBox 7">
             <a:extLst>
               <a:ext uri="{FF2B5EF4-FFF2-40B4-BE49-F238E27FC236}">
-                <a16:creationId xmlns:a16="http://schemas.microsoft.com/office/drawing/2014/main" id="{6C9B7144-902B-4BC8-6895-3B84C31BDB52}"/>
+                <a16:creationId xmlns:a16="http://schemas.microsoft.com/office/drawing/2014/main" id="{C3C45569-252F-8BFC-E440-1F8C9901801F}"/>
               </a:ext>
             </a:extLst>
           </p:cNvPr>
@@ -16622,7 +16709,7 @@
           <p:cNvPr id="9" name="TextBox 8">
             <a:extLst>
               <a:ext uri="{FF2B5EF4-FFF2-40B4-BE49-F238E27FC236}">
-                <a16:creationId xmlns:a16="http://schemas.microsoft.com/office/drawing/2014/main" id="{60F7AA77-5579-86B0-3DB0-07ACEDDA7EB9}"/>
+                <a16:creationId xmlns:a16="http://schemas.microsoft.com/office/drawing/2014/main" id="{D271B574-97AD-54E7-ADFC-A544292456FF}"/>
               </a:ext>
             </a:extLst>
           </p:cNvPr>
@@ -16803,7 +16890,7 @@
           <p:cNvPr id="10" name="직선 연결선 9">
             <a:extLst>
               <a:ext uri="{FF2B5EF4-FFF2-40B4-BE49-F238E27FC236}">
-                <a16:creationId xmlns:a16="http://schemas.microsoft.com/office/drawing/2014/main" id="{28834D2A-0D0F-EA9B-E8E1-7936D06D97B7}"/>
+                <a16:creationId xmlns:a16="http://schemas.microsoft.com/office/drawing/2014/main" id="{91B7C616-BB16-E428-01BC-74BA96835914}"/>
               </a:ext>
             </a:extLst>
           </p:cNvPr>
@@ -16844,7 +16931,7 @@
           <p:cNvPr id="11" name="TextBox 10">
             <a:extLst>
               <a:ext uri="{FF2B5EF4-FFF2-40B4-BE49-F238E27FC236}">
-                <a16:creationId xmlns:a16="http://schemas.microsoft.com/office/drawing/2014/main" id="{A9F067A9-B75C-3CC0-F99E-78CBE7524951}"/>
+                <a16:creationId xmlns:a16="http://schemas.microsoft.com/office/drawing/2014/main" id="{41CF8362-230A-CDBB-B53C-7D6B1B85587F}"/>
               </a:ext>
             </a:extLst>
           </p:cNvPr>
@@ -16884,7 +16971,7 @@
           <p:cNvPr id="12" name="TextBox 11">
             <a:extLst>
               <a:ext uri="{FF2B5EF4-FFF2-40B4-BE49-F238E27FC236}">
-                <a16:creationId xmlns:a16="http://schemas.microsoft.com/office/drawing/2014/main" id="{4516A769-B58D-2298-B2E3-42D9E03A7678}"/>
+                <a16:creationId xmlns:a16="http://schemas.microsoft.com/office/drawing/2014/main" id="{B43829D2-322F-4694-CF7D-9337AB954599}"/>
               </a:ext>
             </a:extLst>
           </p:cNvPr>
@@ -17069,7 +17156,7 @@
           <p:cNvPr id="13" name="직선 연결선 12">
             <a:extLst>
               <a:ext uri="{FF2B5EF4-FFF2-40B4-BE49-F238E27FC236}">
-                <a16:creationId xmlns:a16="http://schemas.microsoft.com/office/drawing/2014/main" id="{673885E7-E99A-8015-8310-9E6F7280A3E9}"/>
+                <a16:creationId xmlns:a16="http://schemas.microsoft.com/office/drawing/2014/main" id="{D3853C98-79AA-4693-9FEE-F0C72FCCCF58}"/>
               </a:ext>
             </a:extLst>
           </p:cNvPr>
@@ -17110,7 +17197,7 @@
           <p:cNvPr id="14" name="TextBox 13">
             <a:extLst>
               <a:ext uri="{FF2B5EF4-FFF2-40B4-BE49-F238E27FC236}">
-                <a16:creationId xmlns:a16="http://schemas.microsoft.com/office/drawing/2014/main" id="{3B456AE2-D76C-3B96-6430-1C11F8CF427D}"/>
+                <a16:creationId xmlns:a16="http://schemas.microsoft.com/office/drawing/2014/main" id="{739EF57B-9394-BD07-E6D9-5C73D35BCFCA}"/>
               </a:ext>
             </a:extLst>
           </p:cNvPr>
@@ -17195,7 +17282,7 @@
           <p:cNvPr id="15" name="TextBox 14">
             <a:extLst>
               <a:ext uri="{FF2B5EF4-FFF2-40B4-BE49-F238E27FC236}">
-                <a16:creationId xmlns:a16="http://schemas.microsoft.com/office/drawing/2014/main" id="{EEC43095-D8AC-EE6F-102E-7A241DE80F48}"/>
+                <a16:creationId xmlns:a16="http://schemas.microsoft.com/office/drawing/2014/main" id="{4C4235D4-45C1-7A78-652D-566D4B3A7249}"/>
               </a:ext>
             </a:extLst>
           </p:cNvPr>
@@ -17240,7 +17327,7 @@
     </p:spTree>
     <p:extLst>
       <p:ext uri="{BB962C8B-B14F-4D97-AF65-F5344CB8AC3E}">
-        <p14:creationId xmlns:p14="http://schemas.microsoft.com/office/powerpoint/2010/main" val="3743667527"/>
+        <p14:creationId xmlns:p14="http://schemas.microsoft.com/office/powerpoint/2010/main" val="1512738036"/>
       </p:ext>
     </p:extLst>
   </p:cSld>
@@ -17272,7 +17359,7 @@
           <p:cNvPr id="2" name="TextBox 1">
             <a:extLst>
               <a:ext uri="{FF2B5EF4-FFF2-40B4-BE49-F238E27FC236}">
-                <a16:creationId xmlns:a16="http://schemas.microsoft.com/office/drawing/2014/main" id="{C23CF64A-5C38-B5B7-0FE3-6A3D59713BA6}"/>
+                <a16:creationId xmlns:a16="http://schemas.microsoft.com/office/drawing/2014/main" id="{DEB540C9-DE51-3467-A20E-21BB028887E2}"/>
               </a:ext>
             </a:extLst>
           </p:cNvPr>
@@ -17321,7 +17408,7 @@
           <p:cNvPr id="3" name="TextBox 2">
             <a:extLst>
               <a:ext uri="{FF2B5EF4-FFF2-40B4-BE49-F238E27FC236}">
-                <a16:creationId xmlns:a16="http://schemas.microsoft.com/office/drawing/2014/main" id="{6614D537-DFD9-F0A1-2072-9B6938CDC7FF}"/>
+                <a16:creationId xmlns:a16="http://schemas.microsoft.com/office/drawing/2014/main" id="{A901A6A8-28A6-0A20-6A8F-E04437CBBE27}"/>
               </a:ext>
             </a:extLst>
           </p:cNvPr>
@@ -17379,7 +17466,7 @@
           <p:cNvPr id="4" name="직사각형 3">
             <a:extLst>
               <a:ext uri="{FF2B5EF4-FFF2-40B4-BE49-F238E27FC236}">
-                <a16:creationId xmlns:a16="http://schemas.microsoft.com/office/drawing/2014/main" id="{2A082524-3927-AE80-1756-86123B227909}"/>
+                <a16:creationId xmlns:a16="http://schemas.microsoft.com/office/drawing/2014/main" id="{1F54B407-BF46-6958-3E01-13CA565D2E8E}"/>
               </a:ext>
             </a:extLst>
           </p:cNvPr>
@@ -17447,7 +17534,7 @@
           <p:cNvPr id="5" name="직선 연결선 4">
             <a:extLst>
               <a:ext uri="{FF2B5EF4-FFF2-40B4-BE49-F238E27FC236}">
-                <a16:creationId xmlns:a16="http://schemas.microsoft.com/office/drawing/2014/main" id="{1218BD80-A563-B393-1626-44697F43BD9C}"/>
+                <a16:creationId xmlns:a16="http://schemas.microsoft.com/office/drawing/2014/main" id="{CA286526-DA45-397B-D914-F7B94E1EEAA5}"/>
               </a:ext>
             </a:extLst>
           </p:cNvPr>
@@ -17489,7 +17576,7 @@
           <p:cNvPr id="6" name="사각형: 둥근 모서리 5">
             <a:extLst>
               <a:ext uri="{FF2B5EF4-FFF2-40B4-BE49-F238E27FC236}">
-                <a16:creationId xmlns:a16="http://schemas.microsoft.com/office/drawing/2014/main" id="{DBEB4C9F-666F-0017-D613-DC0BDE1D34C6}"/>
+                <a16:creationId xmlns:a16="http://schemas.microsoft.com/office/drawing/2014/main" id="{D7DABD7B-E6CA-D7F8-720F-E8B0ED32FFF7}"/>
               </a:ext>
             </a:extLst>
           </p:cNvPr>
@@ -17557,7 +17644,7 @@
           <p:cNvPr id="7" name="TextBox 6">
             <a:extLst>
               <a:ext uri="{FF2B5EF4-FFF2-40B4-BE49-F238E27FC236}">
-                <a16:creationId xmlns:a16="http://schemas.microsoft.com/office/drawing/2014/main" id="{BA5490A8-3FA3-54E9-0531-23B773A8829D}"/>
+                <a16:creationId xmlns:a16="http://schemas.microsoft.com/office/drawing/2014/main" id="{BD654356-BA81-45A1-7D9C-2C3711EA29F3}"/>
               </a:ext>
             </a:extLst>
           </p:cNvPr>
@@ -17613,7 +17700,7 @@
           <p:cNvPr id="8" name="TextBox 7">
             <a:extLst>
               <a:ext uri="{FF2B5EF4-FFF2-40B4-BE49-F238E27FC236}">
-                <a16:creationId xmlns:a16="http://schemas.microsoft.com/office/drawing/2014/main" id="{2F29E3C6-901A-8005-A37B-A21B821FE147}"/>
+                <a16:creationId xmlns:a16="http://schemas.microsoft.com/office/drawing/2014/main" id="{8751591E-9257-8F9C-1C3F-2C26F2F44CEA}"/>
               </a:ext>
             </a:extLst>
           </p:cNvPr>
@@ -17708,7 +17795,7 @@
           <p:cNvPr id="9" name="직선 연결선 8">
             <a:extLst>
               <a:ext uri="{FF2B5EF4-FFF2-40B4-BE49-F238E27FC236}">
-                <a16:creationId xmlns:a16="http://schemas.microsoft.com/office/drawing/2014/main" id="{DC812E96-ADD1-1B4A-B517-BAB3DE7B6DB9}"/>
+                <a16:creationId xmlns:a16="http://schemas.microsoft.com/office/drawing/2014/main" id="{C60057AE-40E6-48C7-6904-1DE99E60A67F}"/>
               </a:ext>
             </a:extLst>
           </p:cNvPr>
@@ -17750,7 +17837,7 @@
           <p:cNvPr id="10" name="사각형: 둥근 모서리 9">
             <a:extLst>
               <a:ext uri="{FF2B5EF4-FFF2-40B4-BE49-F238E27FC236}">
-                <a16:creationId xmlns:a16="http://schemas.microsoft.com/office/drawing/2014/main" id="{7E6754B5-6B08-FA98-C854-FFA8BE884292}"/>
+                <a16:creationId xmlns:a16="http://schemas.microsoft.com/office/drawing/2014/main" id="{FEFDD52B-4742-9299-FF59-15FC9166642B}"/>
               </a:ext>
             </a:extLst>
           </p:cNvPr>
@@ -17818,7 +17905,7 @@
           <p:cNvPr id="11" name="TextBox 10">
             <a:extLst>
               <a:ext uri="{FF2B5EF4-FFF2-40B4-BE49-F238E27FC236}">
-                <a16:creationId xmlns:a16="http://schemas.microsoft.com/office/drawing/2014/main" id="{C503CE0E-16A1-BA3A-2E01-48595AF9ED9A}"/>
+                <a16:creationId xmlns:a16="http://schemas.microsoft.com/office/drawing/2014/main" id="{0D247F97-0D56-5108-C7F3-CE2697AFE68E}"/>
               </a:ext>
             </a:extLst>
           </p:cNvPr>
@@ -17859,7 +17946,7 @@
           <p:cNvPr id="12" name="TextBox 11">
             <a:extLst>
               <a:ext uri="{FF2B5EF4-FFF2-40B4-BE49-F238E27FC236}">
-                <a16:creationId xmlns:a16="http://schemas.microsoft.com/office/drawing/2014/main" id="{B36A61F9-0551-455D-712F-A7DB0B2C27FD}"/>
+                <a16:creationId xmlns:a16="http://schemas.microsoft.com/office/drawing/2014/main" id="{96DD5F88-F31F-889E-6DFB-D4ACAD40E436}"/>
               </a:ext>
             </a:extLst>
           </p:cNvPr>
@@ -17936,7 +18023,7 @@
           <p:cNvPr id="13" name="직선 연결선 12">
             <a:extLst>
               <a:ext uri="{FF2B5EF4-FFF2-40B4-BE49-F238E27FC236}">
-                <a16:creationId xmlns:a16="http://schemas.microsoft.com/office/drawing/2014/main" id="{23F79E25-40E5-DCEA-DAD0-E30F9C3AEA2D}"/>
+                <a16:creationId xmlns:a16="http://schemas.microsoft.com/office/drawing/2014/main" id="{82073A44-5F59-9EEA-9E78-5094C46320C1}"/>
               </a:ext>
             </a:extLst>
           </p:cNvPr>
@@ -17978,7 +18065,7 @@
           <p:cNvPr id="14" name="사각형: 둥근 모서리 13">
             <a:extLst>
               <a:ext uri="{FF2B5EF4-FFF2-40B4-BE49-F238E27FC236}">
-                <a16:creationId xmlns:a16="http://schemas.microsoft.com/office/drawing/2014/main" id="{622BA818-8C55-2301-F512-67819C54867B}"/>
+                <a16:creationId xmlns:a16="http://schemas.microsoft.com/office/drawing/2014/main" id="{4F137ED4-E3C4-EEB5-A6AC-CD56E5BA40C5}"/>
               </a:ext>
             </a:extLst>
           </p:cNvPr>
@@ -18046,7 +18133,7 @@
           <p:cNvPr id="15" name="TextBox 14">
             <a:extLst>
               <a:ext uri="{FF2B5EF4-FFF2-40B4-BE49-F238E27FC236}">
-                <a16:creationId xmlns:a16="http://schemas.microsoft.com/office/drawing/2014/main" id="{DEBC86ED-F2D6-8D25-8747-8F4975EDA918}"/>
+                <a16:creationId xmlns:a16="http://schemas.microsoft.com/office/drawing/2014/main" id="{C43386F0-AB19-D89E-F927-FA830D62D64E}"/>
               </a:ext>
             </a:extLst>
           </p:cNvPr>
@@ -18096,7 +18183,7 @@
           <p:cNvPr id="16" name="TextBox 15">
             <a:extLst>
               <a:ext uri="{FF2B5EF4-FFF2-40B4-BE49-F238E27FC236}">
-                <a16:creationId xmlns:a16="http://schemas.microsoft.com/office/drawing/2014/main" id="{90B0EF4E-3F5F-19CE-070B-BE5CF74ABA5E}"/>
+                <a16:creationId xmlns:a16="http://schemas.microsoft.com/office/drawing/2014/main" id="{BD74B1E5-C09A-508A-F515-7E93B9EF83B9}"/>
               </a:ext>
             </a:extLst>
           </p:cNvPr>
@@ -18143,7 +18230,7 @@
           <p:cNvPr id="17" name="직선 연결선 16">
             <a:extLst>
               <a:ext uri="{FF2B5EF4-FFF2-40B4-BE49-F238E27FC236}">
-                <a16:creationId xmlns:a16="http://schemas.microsoft.com/office/drawing/2014/main" id="{A909A20F-F25C-4D80-BFF1-9F0FE9C1239A}"/>
+                <a16:creationId xmlns:a16="http://schemas.microsoft.com/office/drawing/2014/main" id="{56007A7D-A9A2-FADE-AA1B-E957B71A2B49}"/>
               </a:ext>
             </a:extLst>
           </p:cNvPr>
@@ -18185,7 +18272,7 @@
           <p:cNvPr id="18" name="사각형: 둥근 모서리 17">
             <a:extLst>
               <a:ext uri="{FF2B5EF4-FFF2-40B4-BE49-F238E27FC236}">
-                <a16:creationId xmlns:a16="http://schemas.microsoft.com/office/drawing/2014/main" id="{19767608-BB72-1D5F-8571-984383032FBB}"/>
+                <a16:creationId xmlns:a16="http://schemas.microsoft.com/office/drawing/2014/main" id="{C54D5EFA-C6C0-48AE-6A56-49F443C3B5F5}"/>
               </a:ext>
             </a:extLst>
           </p:cNvPr>
@@ -18253,7 +18340,7 @@
           <p:cNvPr id="19" name="TextBox 18">
             <a:extLst>
               <a:ext uri="{FF2B5EF4-FFF2-40B4-BE49-F238E27FC236}">
-                <a16:creationId xmlns:a16="http://schemas.microsoft.com/office/drawing/2014/main" id="{422C76D6-7EC8-EC46-2071-62649AD5C7CA}"/>
+                <a16:creationId xmlns:a16="http://schemas.microsoft.com/office/drawing/2014/main" id="{C485E492-0538-0707-E724-195D77355EFA}"/>
               </a:ext>
             </a:extLst>
           </p:cNvPr>
@@ -18294,7 +18381,7 @@
           <p:cNvPr id="20" name="TextBox 19">
             <a:extLst>
               <a:ext uri="{FF2B5EF4-FFF2-40B4-BE49-F238E27FC236}">
-                <a16:creationId xmlns:a16="http://schemas.microsoft.com/office/drawing/2014/main" id="{6CE71554-C0F3-E005-BDDD-ED9E9845B94D}"/>
+                <a16:creationId xmlns:a16="http://schemas.microsoft.com/office/drawing/2014/main" id="{2E17C975-B0E6-45AA-0787-0A940AFC3C9E}"/>
               </a:ext>
             </a:extLst>
           </p:cNvPr>
@@ -18359,7 +18446,7 @@
           <p:cNvPr id="21" name="사각형: 둥근 모서리 20">
             <a:extLst>
               <a:ext uri="{FF2B5EF4-FFF2-40B4-BE49-F238E27FC236}">
-                <a16:creationId xmlns:a16="http://schemas.microsoft.com/office/drawing/2014/main" id="{29A8016A-EC58-C05C-0056-73A6BF40F7F4}"/>
+                <a16:creationId xmlns:a16="http://schemas.microsoft.com/office/drawing/2014/main" id="{27667C82-6125-4BF5-C6E8-63A8C3ECB1F2}"/>
               </a:ext>
             </a:extLst>
           </p:cNvPr>
@@ -18427,7 +18514,7 @@
           <p:cNvPr id="22" name="TextBox 21">
             <a:extLst>
               <a:ext uri="{FF2B5EF4-FFF2-40B4-BE49-F238E27FC236}">
-                <a16:creationId xmlns:a16="http://schemas.microsoft.com/office/drawing/2014/main" id="{8CB4D146-82E2-CE6A-BB6B-E65F9F306AEB}"/>
+                <a16:creationId xmlns:a16="http://schemas.microsoft.com/office/drawing/2014/main" id="{6B6343A3-AC0C-A2EC-2432-B960EC09204E}"/>
               </a:ext>
             </a:extLst>
           </p:cNvPr>
@@ -18468,7 +18555,7 @@
           <p:cNvPr id="23" name="TextBox 22">
             <a:extLst>
               <a:ext uri="{FF2B5EF4-FFF2-40B4-BE49-F238E27FC236}">
-                <a16:creationId xmlns:a16="http://schemas.microsoft.com/office/drawing/2014/main" id="{B0946831-4758-7DF8-3A59-B2270DC48FE9}"/>
+                <a16:creationId xmlns:a16="http://schemas.microsoft.com/office/drawing/2014/main" id="{067107BF-23B3-B2BA-6E78-65654739B797}"/>
               </a:ext>
             </a:extLst>
           </p:cNvPr>
@@ -18527,7 +18614,7 @@
           <p:cNvPr id="24" name="사각형: 둥근 모서리 23">
             <a:extLst>
               <a:ext uri="{FF2B5EF4-FFF2-40B4-BE49-F238E27FC236}">
-                <a16:creationId xmlns:a16="http://schemas.microsoft.com/office/drawing/2014/main" id="{052ED080-C78F-7F34-03D6-290B159CE545}"/>
+                <a16:creationId xmlns:a16="http://schemas.microsoft.com/office/drawing/2014/main" id="{889702FE-6E26-B839-ED16-0B9F6EBEBC29}"/>
               </a:ext>
             </a:extLst>
           </p:cNvPr>
@@ -18595,7 +18682,7 @@
           <p:cNvPr id="25" name="TextBox 24">
             <a:extLst>
               <a:ext uri="{FF2B5EF4-FFF2-40B4-BE49-F238E27FC236}">
-                <a16:creationId xmlns:a16="http://schemas.microsoft.com/office/drawing/2014/main" id="{A5C832A3-7587-213F-D6CD-DEA191567B4A}"/>
+                <a16:creationId xmlns:a16="http://schemas.microsoft.com/office/drawing/2014/main" id="{3B002351-21F1-3C93-6604-26F15E0BD166}"/>
               </a:ext>
             </a:extLst>
           </p:cNvPr>
@@ -18635,7 +18722,7 @@
           <p:cNvPr id="26" name="TextBox 25">
             <a:extLst>
               <a:ext uri="{FF2B5EF4-FFF2-40B4-BE49-F238E27FC236}">
-                <a16:creationId xmlns:a16="http://schemas.microsoft.com/office/drawing/2014/main" id="{8A46CDBA-046D-0174-0B65-827619EE596E}"/>
+                <a16:creationId xmlns:a16="http://schemas.microsoft.com/office/drawing/2014/main" id="{49F0C958-434A-9E6F-D509-38F3C1128CCB}"/>
               </a:ext>
             </a:extLst>
           </p:cNvPr>
@@ -18753,7 +18840,7 @@
           <p:cNvPr id="27" name="직선 연결선 26">
             <a:extLst>
               <a:ext uri="{FF2B5EF4-FFF2-40B4-BE49-F238E27FC236}">
-                <a16:creationId xmlns:a16="http://schemas.microsoft.com/office/drawing/2014/main" id="{925F2364-A960-B097-8A16-938B945DA8AF}"/>
+                <a16:creationId xmlns:a16="http://schemas.microsoft.com/office/drawing/2014/main" id="{D7FAF1F3-608F-D090-FE75-834349934AE5}"/>
               </a:ext>
             </a:extLst>
           </p:cNvPr>
@@ -18794,7 +18881,7 @@
           <p:cNvPr id="28" name="TextBox 27">
             <a:extLst>
               <a:ext uri="{FF2B5EF4-FFF2-40B4-BE49-F238E27FC236}">
-                <a16:creationId xmlns:a16="http://schemas.microsoft.com/office/drawing/2014/main" id="{CCBE12AE-6802-8CF1-9C15-C2C68E70BBF4}"/>
+                <a16:creationId xmlns:a16="http://schemas.microsoft.com/office/drawing/2014/main" id="{8B3C3997-9078-0427-7527-F93000F7C128}"/>
               </a:ext>
             </a:extLst>
           </p:cNvPr>
@@ -18879,7 +18966,7 @@
           <p:cNvPr id="29" name="TextBox 28">
             <a:extLst>
               <a:ext uri="{FF2B5EF4-FFF2-40B4-BE49-F238E27FC236}">
-                <a16:creationId xmlns:a16="http://schemas.microsoft.com/office/drawing/2014/main" id="{9E6EA366-44F0-F445-A90C-B1D8591EA762}"/>
+                <a16:creationId xmlns:a16="http://schemas.microsoft.com/office/drawing/2014/main" id="{ED0B01BF-83B9-8ABC-1F43-99FE00AFD61B}"/>
               </a:ext>
             </a:extLst>
           </p:cNvPr>
@@ -18924,7 +19011,7 @@
     </p:spTree>
     <p:extLst>
       <p:ext uri="{BB962C8B-B14F-4D97-AF65-F5344CB8AC3E}">
-        <p14:creationId xmlns:p14="http://schemas.microsoft.com/office/powerpoint/2010/main" val="2686794826"/>
+        <p14:creationId xmlns:p14="http://schemas.microsoft.com/office/powerpoint/2010/main" val="3928529102"/>
       </p:ext>
     </p:extLst>
   </p:cSld>
@@ -18956,7 +19043,7 @@
           <p:cNvPr id="2" name="TextBox 1">
             <a:extLst>
               <a:ext uri="{FF2B5EF4-FFF2-40B4-BE49-F238E27FC236}">
-                <a16:creationId xmlns:a16="http://schemas.microsoft.com/office/drawing/2014/main" id="{99C2B1E4-5364-A030-CB64-5DB5272E7E3B}"/>
+                <a16:creationId xmlns:a16="http://schemas.microsoft.com/office/drawing/2014/main" id="{921F5404-92CE-BDDA-D7D9-FA0B28A25A3C}"/>
               </a:ext>
             </a:extLst>
           </p:cNvPr>
@@ -19005,7 +19092,7 @@
           <p:cNvPr id="3" name="TextBox 2">
             <a:extLst>
               <a:ext uri="{FF2B5EF4-FFF2-40B4-BE49-F238E27FC236}">
-                <a16:creationId xmlns:a16="http://schemas.microsoft.com/office/drawing/2014/main" id="{C1E1BC3B-E88B-37DD-8E2A-7D5C1FFA9814}"/>
+                <a16:creationId xmlns:a16="http://schemas.microsoft.com/office/drawing/2014/main" id="{36C946C5-87EA-CFEB-DB2C-5FB3E655BF02}"/>
               </a:ext>
             </a:extLst>
           </p:cNvPr>
@@ -19045,7 +19132,7 @@
           <p:cNvPr id="4" name="직사각형 3">
             <a:extLst>
               <a:ext uri="{FF2B5EF4-FFF2-40B4-BE49-F238E27FC236}">
-                <a16:creationId xmlns:a16="http://schemas.microsoft.com/office/drawing/2014/main" id="{514CE5FF-7DDB-8230-C53A-71FF94B8548E}"/>
+                <a16:creationId xmlns:a16="http://schemas.microsoft.com/office/drawing/2014/main" id="{8D3C30AC-CBFB-D79B-51E3-9563E6E155FD}"/>
               </a:ext>
             </a:extLst>
           </p:cNvPr>
@@ -19113,7 +19200,7 @@
           <p:cNvPr id="5" name="직사각형 4">
             <a:extLst>
               <a:ext uri="{FF2B5EF4-FFF2-40B4-BE49-F238E27FC236}">
-                <a16:creationId xmlns:a16="http://schemas.microsoft.com/office/drawing/2014/main" id="{3A8D6B25-E80A-62E7-68CC-2CBCFD6AE8BC}"/>
+                <a16:creationId xmlns:a16="http://schemas.microsoft.com/office/drawing/2014/main" id="{2E9F49B0-00FA-B070-1486-8CA25266DDB3}"/>
               </a:ext>
             </a:extLst>
           </p:cNvPr>
@@ -19181,7 +19268,7 @@
           <p:cNvPr id="6" name="TextBox 5">
             <a:extLst>
               <a:ext uri="{FF2B5EF4-FFF2-40B4-BE49-F238E27FC236}">
-                <a16:creationId xmlns:a16="http://schemas.microsoft.com/office/drawing/2014/main" id="{A01184D2-8D18-FA65-4180-137A62B10555}"/>
+                <a16:creationId xmlns:a16="http://schemas.microsoft.com/office/drawing/2014/main" id="{6944F9CB-FE68-3238-D591-AB934452A09C}"/>
               </a:ext>
             </a:extLst>
           </p:cNvPr>
@@ -19221,7 +19308,7 @@
           <p:cNvPr id="7" name="TextBox 6">
             <a:extLst>
               <a:ext uri="{FF2B5EF4-FFF2-40B4-BE49-F238E27FC236}">
-                <a16:creationId xmlns:a16="http://schemas.microsoft.com/office/drawing/2014/main" id="{2DD38E70-E07A-4083-DFED-7609D89C8C9C}"/>
+                <a16:creationId xmlns:a16="http://schemas.microsoft.com/office/drawing/2014/main" id="{F0D5BAA5-5DC4-FF34-65DD-6476445F3B9C}"/>
               </a:ext>
             </a:extLst>
           </p:cNvPr>
@@ -19321,7 +19408,7 @@
           <p:cNvPr id="8" name="TextBox 7">
             <a:extLst>
               <a:ext uri="{FF2B5EF4-FFF2-40B4-BE49-F238E27FC236}">
-                <a16:creationId xmlns:a16="http://schemas.microsoft.com/office/drawing/2014/main" id="{B7D4A4FB-0086-5063-9DAF-479AFDF40467}"/>
+                <a16:creationId xmlns:a16="http://schemas.microsoft.com/office/drawing/2014/main" id="{75E67FB2-7F7F-11B4-F8BE-829B6AF8868F}"/>
               </a:ext>
             </a:extLst>
           </p:cNvPr>
@@ -19362,7 +19449,7 @@
           <p:cNvPr id="9" name="직선 연결선 8">
             <a:extLst>
               <a:ext uri="{FF2B5EF4-FFF2-40B4-BE49-F238E27FC236}">
-                <a16:creationId xmlns:a16="http://schemas.microsoft.com/office/drawing/2014/main" id="{72F619A7-7EE5-9EF4-9607-5E4D212661E6}"/>
+                <a16:creationId xmlns:a16="http://schemas.microsoft.com/office/drawing/2014/main" id="{BB2D1E99-7E06-B440-7773-27EB0E2FA98E}"/>
               </a:ext>
             </a:extLst>
           </p:cNvPr>
@@ -19403,7 +19490,7 @@
           <p:cNvPr id="10" name="직사각형 9">
             <a:extLst>
               <a:ext uri="{FF2B5EF4-FFF2-40B4-BE49-F238E27FC236}">
-                <a16:creationId xmlns:a16="http://schemas.microsoft.com/office/drawing/2014/main" id="{906E10E0-9627-DEEB-718A-733E0AFC5983}"/>
+                <a16:creationId xmlns:a16="http://schemas.microsoft.com/office/drawing/2014/main" id="{596156F1-C1A1-C4A4-ED4B-7CA8E4A3B6C2}"/>
               </a:ext>
             </a:extLst>
           </p:cNvPr>
@@ -19471,7 +19558,7 @@
           <p:cNvPr id="11" name="TextBox 10">
             <a:extLst>
               <a:ext uri="{FF2B5EF4-FFF2-40B4-BE49-F238E27FC236}">
-                <a16:creationId xmlns:a16="http://schemas.microsoft.com/office/drawing/2014/main" id="{16FF1D7B-E1E4-53EE-BD9C-6FEEB55CEDC2}"/>
+                <a16:creationId xmlns:a16="http://schemas.microsoft.com/office/drawing/2014/main" id="{3AE8B764-AEDE-3A1B-3454-5A359FC03EC3}"/>
               </a:ext>
             </a:extLst>
           </p:cNvPr>
@@ -19529,7 +19616,7 @@
           <p:cNvPr id="12" name="TextBox 11">
             <a:extLst>
               <a:ext uri="{FF2B5EF4-FFF2-40B4-BE49-F238E27FC236}">
-                <a16:creationId xmlns:a16="http://schemas.microsoft.com/office/drawing/2014/main" id="{E04119D8-B7BE-7C6D-23FE-6AB3CE3FD5EF}"/>
+                <a16:creationId xmlns:a16="http://schemas.microsoft.com/office/drawing/2014/main" id="{E1955740-5A81-2E27-8368-83A1B9806581}"/>
               </a:ext>
             </a:extLst>
           </p:cNvPr>
@@ -19629,7 +19716,7 @@
           <p:cNvPr id="13" name="TextBox 12">
             <a:extLst>
               <a:ext uri="{FF2B5EF4-FFF2-40B4-BE49-F238E27FC236}">
-                <a16:creationId xmlns:a16="http://schemas.microsoft.com/office/drawing/2014/main" id="{83EFBC6E-6AEF-A5C2-F5B9-35052E1A50C2}"/>
+                <a16:creationId xmlns:a16="http://schemas.microsoft.com/office/drawing/2014/main" id="{F0C66918-6848-37F9-7937-FE80F41B16C4}"/>
               </a:ext>
             </a:extLst>
           </p:cNvPr>
@@ -19670,7 +19757,7 @@
           <p:cNvPr id="14" name="직선 연결선 13">
             <a:extLst>
               <a:ext uri="{FF2B5EF4-FFF2-40B4-BE49-F238E27FC236}">
-                <a16:creationId xmlns:a16="http://schemas.microsoft.com/office/drawing/2014/main" id="{14F16D02-1AB8-E69C-C0F4-9B2850683CC6}"/>
+                <a16:creationId xmlns:a16="http://schemas.microsoft.com/office/drawing/2014/main" id="{EA3D4434-D9CB-910E-ECB8-33A867EBCA24}"/>
               </a:ext>
             </a:extLst>
           </p:cNvPr>
@@ -19711,7 +19798,7 @@
           <p:cNvPr id="15" name="직사각형 14">
             <a:extLst>
               <a:ext uri="{FF2B5EF4-FFF2-40B4-BE49-F238E27FC236}">
-                <a16:creationId xmlns:a16="http://schemas.microsoft.com/office/drawing/2014/main" id="{81A76314-2BB6-D96E-E1DE-E89EDE94BFCB}"/>
+                <a16:creationId xmlns:a16="http://schemas.microsoft.com/office/drawing/2014/main" id="{3D473975-ADA9-467A-B057-AF130A3C5894}"/>
               </a:ext>
             </a:extLst>
           </p:cNvPr>
@@ -19779,7 +19866,7 @@
           <p:cNvPr id="16" name="TextBox 15">
             <a:extLst>
               <a:ext uri="{FF2B5EF4-FFF2-40B4-BE49-F238E27FC236}">
-                <a16:creationId xmlns:a16="http://schemas.microsoft.com/office/drawing/2014/main" id="{7420627A-F809-D608-0CE8-7B0FAB2C477B}"/>
+                <a16:creationId xmlns:a16="http://schemas.microsoft.com/office/drawing/2014/main" id="{6068A8ED-123C-4DD3-81F2-D7CE2051873F}"/>
               </a:ext>
             </a:extLst>
           </p:cNvPr>
@@ -19819,7 +19906,7 @@
           <p:cNvPr id="17" name="TextBox 16">
             <a:extLst>
               <a:ext uri="{FF2B5EF4-FFF2-40B4-BE49-F238E27FC236}">
-                <a16:creationId xmlns:a16="http://schemas.microsoft.com/office/drawing/2014/main" id="{21D84CA3-BF80-947A-77F3-2B64FC6805AD}"/>
+                <a16:creationId xmlns:a16="http://schemas.microsoft.com/office/drawing/2014/main" id="{6434D3CD-2104-1A89-283B-118ACA44611F}"/>
               </a:ext>
             </a:extLst>
           </p:cNvPr>
@@ -19883,7 +19970,7 @@
           <p:cNvPr id="18" name="TextBox 17">
             <a:extLst>
               <a:ext uri="{FF2B5EF4-FFF2-40B4-BE49-F238E27FC236}">
-                <a16:creationId xmlns:a16="http://schemas.microsoft.com/office/drawing/2014/main" id="{60E97EC2-440C-A6A1-A6F4-B8DCB34FAD3E}"/>
+                <a16:creationId xmlns:a16="http://schemas.microsoft.com/office/drawing/2014/main" id="{C2CC1AB1-42F3-F34D-51C9-6B1EBE09179A}"/>
               </a:ext>
             </a:extLst>
           </p:cNvPr>
@@ -19924,7 +20011,7 @@
           <p:cNvPr id="19" name="직선 연결선 18">
             <a:extLst>
               <a:ext uri="{FF2B5EF4-FFF2-40B4-BE49-F238E27FC236}">
-                <a16:creationId xmlns:a16="http://schemas.microsoft.com/office/drawing/2014/main" id="{C2A708D2-BA4D-4A72-5256-E2E864AC6FC9}"/>
+                <a16:creationId xmlns:a16="http://schemas.microsoft.com/office/drawing/2014/main" id="{4B255846-45B3-8F3B-AA38-7E4CF0EF557E}"/>
               </a:ext>
             </a:extLst>
           </p:cNvPr>
@@ -19965,7 +20052,7 @@
           <p:cNvPr id="20" name="직사각형 19">
             <a:extLst>
               <a:ext uri="{FF2B5EF4-FFF2-40B4-BE49-F238E27FC236}">
-                <a16:creationId xmlns:a16="http://schemas.microsoft.com/office/drawing/2014/main" id="{B7B95455-4B28-2021-198D-F9EA7E14BA45}"/>
+                <a16:creationId xmlns:a16="http://schemas.microsoft.com/office/drawing/2014/main" id="{4EC992E4-D297-469D-84D9-BC9DF28C7C7C}"/>
               </a:ext>
             </a:extLst>
           </p:cNvPr>
@@ -20033,7 +20120,7 @@
           <p:cNvPr id="21" name="TextBox 20">
             <a:extLst>
               <a:ext uri="{FF2B5EF4-FFF2-40B4-BE49-F238E27FC236}">
-                <a16:creationId xmlns:a16="http://schemas.microsoft.com/office/drawing/2014/main" id="{95682FF3-B3AE-E350-47C8-DE7B48E1F437}"/>
+                <a16:creationId xmlns:a16="http://schemas.microsoft.com/office/drawing/2014/main" id="{B7A02508-2C03-CEDE-61F4-52EB929DD4D3}"/>
               </a:ext>
             </a:extLst>
           </p:cNvPr>
@@ -20073,7 +20160,7 @@
           <p:cNvPr id="22" name="TextBox 21">
             <a:extLst>
               <a:ext uri="{FF2B5EF4-FFF2-40B4-BE49-F238E27FC236}">
-                <a16:creationId xmlns:a16="http://schemas.microsoft.com/office/drawing/2014/main" id="{03BEBB3D-6292-4338-11C0-3BA58C530619}"/>
+                <a16:creationId xmlns:a16="http://schemas.microsoft.com/office/drawing/2014/main" id="{F10E6398-B012-A69F-FA16-7A0F675D6118}"/>
               </a:ext>
             </a:extLst>
           </p:cNvPr>
@@ -20149,7 +20236,7 @@
           <p:cNvPr id="23" name="TextBox 22">
             <a:extLst>
               <a:ext uri="{FF2B5EF4-FFF2-40B4-BE49-F238E27FC236}">
-                <a16:creationId xmlns:a16="http://schemas.microsoft.com/office/drawing/2014/main" id="{C912B598-ECFF-9B9C-0580-6F2539E60175}"/>
+                <a16:creationId xmlns:a16="http://schemas.microsoft.com/office/drawing/2014/main" id="{FBD30C7F-45F7-4C72-68B6-9888F41374F4}"/>
               </a:ext>
             </a:extLst>
           </p:cNvPr>
@@ -20190,7 +20277,7 @@
           <p:cNvPr id="24" name="직선 연결선 23">
             <a:extLst>
               <a:ext uri="{FF2B5EF4-FFF2-40B4-BE49-F238E27FC236}">
-                <a16:creationId xmlns:a16="http://schemas.microsoft.com/office/drawing/2014/main" id="{446C0BCD-1EB7-E9DC-A707-782FFC847026}"/>
+                <a16:creationId xmlns:a16="http://schemas.microsoft.com/office/drawing/2014/main" id="{D9E48773-0D56-AACB-5F68-85FFD6C573FB}"/>
               </a:ext>
             </a:extLst>
           </p:cNvPr>
@@ -20231,7 +20318,7 @@
           <p:cNvPr id="25" name="TextBox 24">
             <a:extLst>
               <a:ext uri="{FF2B5EF4-FFF2-40B4-BE49-F238E27FC236}">
-                <a16:creationId xmlns:a16="http://schemas.microsoft.com/office/drawing/2014/main" id="{45F7FA57-9EB5-1510-8138-496FC58E2390}"/>
+                <a16:creationId xmlns:a16="http://schemas.microsoft.com/office/drawing/2014/main" id="{62574FCF-857F-3D88-A7DE-301C63BC387E}"/>
               </a:ext>
             </a:extLst>
           </p:cNvPr>
@@ -20323,7 +20410,7 @@
           <p:cNvPr id="26" name="직선 연결선 25">
             <a:extLst>
               <a:ext uri="{FF2B5EF4-FFF2-40B4-BE49-F238E27FC236}">
-                <a16:creationId xmlns:a16="http://schemas.microsoft.com/office/drawing/2014/main" id="{0BA3D6BD-385C-431F-4A9D-2A06D7CD1125}"/>
+                <a16:creationId xmlns:a16="http://schemas.microsoft.com/office/drawing/2014/main" id="{CCB94364-1815-FDC6-CCA7-FBF8EC531111}"/>
               </a:ext>
             </a:extLst>
           </p:cNvPr>
@@ -20364,7 +20451,7 @@
           <p:cNvPr id="27" name="TextBox 26">
             <a:extLst>
               <a:ext uri="{FF2B5EF4-FFF2-40B4-BE49-F238E27FC236}">
-                <a16:creationId xmlns:a16="http://schemas.microsoft.com/office/drawing/2014/main" id="{8522FA48-97E6-E29D-D698-FE8E76CAF858}"/>
+                <a16:creationId xmlns:a16="http://schemas.microsoft.com/office/drawing/2014/main" id="{D92C2082-3D10-DD5A-6CEC-DFCD45C1513A}"/>
               </a:ext>
             </a:extLst>
           </p:cNvPr>
@@ -20449,7 +20536,7 @@
           <p:cNvPr id="28" name="TextBox 27">
             <a:extLst>
               <a:ext uri="{FF2B5EF4-FFF2-40B4-BE49-F238E27FC236}">
-                <a16:creationId xmlns:a16="http://schemas.microsoft.com/office/drawing/2014/main" id="{DCCD4F77-70AF-1E4C-85E7-A6822719E0F6}"/>
+                <a16:creationId xmlns:a16="http://schemas.microsoft.com/office/drawing/2014/main" id="{0E15EC33-FE12-AB59-933D-56BD58E7C156}"/>
               </a:ext>
             </a:extLst>
           </p:cNvPr>
@@ -20494,7 +20581,7 @@
     </p:spTree>
     <p:extLst>
       <p:ext uri="{BB962C8B-B14F-4D97-AF65-F5344CB8AC3E}">
-        <p14:creationId xmlns:p14="http://schemas.microsoft.com/office/powerpoint/2010/main" val="3763647798"/>
+        <p14:creationId xmlns:p14="http://schemas.microsoft.com/office/powerpoint/2010/main" val="3322993431"/>
       </p:ext>
     </p:extLst>
   </p:cSld>
@@ -20526,7 +20613,7 @@
           <p:cNvPr id="2" name="TextBox 1">
             <a:extLst>
               <a:ext uri="{FF2B5EF4-FFF2-40B4-BE49-F238E27FC236}">
-                <a16:creationId xmlns:a16="http://schemas.microsoft.com/office/drawing/2014/main" id="{CFDCA565-9262-D093-71FB-383765962B52}"/>
+                <a16:creationId xmlns:a16="http://schemas.microsoft.com/office/drawing/2014/main" id="{F49EB261-0471-C4A4-55E6-C7494EDA76B2}"/>
               </a:ext>
             </a:extLst>
           </p:cNvPr>
@@ -20572,7 +20659,7 @@
           <p:cNvPr id="3" name="TextBox 2">
             <a:extLst>
               <a:ext uri="{FF2B5EF4-FFF2-40B4-BE49-F238E27FC236}">
-                <a16:creationId xmlns:a16="http://schemas.microsoft.com/office/drawing/2014/main" id="{9487847F-CB1B-F441-1592-BAC69A8FB983}"/>
+                <a16:creationId xmlns:a16="http://schemas.microsoft.com/office/drawing/2014/main" id="{846200A8-A710-40A0-DFBC-5CFBFB630456}"/>
               </a:ext>
             </a:extLst>
           </p:cNvPr>
@@ -20630,7 +20717,7 @@
           <p:cNvPr id="4" name="직사각형 3">
             <a:extLst>
               <a:ext uri="{FF2B5EF4-FFF2-40B4-BE49-F238E27FC236}">
-                <a16:creationId xmlns:a16="http://schemas.microsoft.com/office/drawing/2014/main" id="{5EB98D8C-1567-944A-5C64-3FE120C8D992}"/>
+                <a16:creationId xmlns:a16="http://schemas.microsoft.com/office/drawing/2014/main" id="{B57F389D-C53E-A73B-57EC-581C85B3DA96}"/>
               </a:ext>
             </a:extLst>
           </p:cNvPr>
@@ -20698,7 +20785,7 @@
           <p:cNvPr id="5" name="TextBox 4">
             <a:extLst>
               <a:ext uri="{FF2B5EF4-FFF2-40B4-BE49-F238E27FC236}">
-                <a16:creationId xmlns:a16="http://schemas.microsoft.com/office/drawing/2014/main" id="{6DC2614A-DE95-0B6C-4691-3BC936E86B5A}"/>
+                <a16:creationId xmlns:a16="http://schemas.microsoft.com/office/drawing/2014/main" id="{66B72272-EBD4-371A-0852-03F49F70C976}"/>
               </a:ext>
             </a:extLst>
           </p:cNvPr>
@@ -20745,7 +20832,7 @@
           <p:cNvPr id="6" name="직사각형 5">
             <a:extLst>
               <a:ext uri="{FF2B5EF4-FFF2-40B4-BE49-F238E27FC236}">
-                <a16:creationId xmlns:a16="http://schemas.microsoft.com/office/drawing/2014/main" id="{62285D62-A04E-5CD8-7C32-86D902B9C043}"/>
+                <a16:creationId xmlns:a16="http://schemas.microsoft.com/office/drawing/2014/main" id="{E2F78962-336D-7E95-46BB-B3022355BF19}"/>
               </a:ext>
             </a:extLst>
           </p:cNvPr>
@@ -20799,7 +20886,7 @@
           <p:cNvPr id="7" name="직사각형 6">
             <a:extLst>
               <a:ext uri="{FF2B5EF4-FFF2-40B4-BE49-F238E27FC236}">
-                <a16:creationId xmlns:a16="http://schemas.microsoft.com/office/drawing/2014/main" id="{837CFC59-DDF5-EDBF-4C3D-7EEE9278A221}"/>
+                <a16:creationId xmlns:a16="http://schemas.microsoft.com/office/drawing/2014/main" id="{EE1816BE-2EC2-3B7E-B000-184A076995D0}"/>
               </a:ext>
             </a:extLst>
           </p:cNvPr>
@@ -20853,7 +20940,7 @@
           <p:cNvPr id="8" name="TextBox 7">
             <a:extLst>
               <a:ext uri="{FF2B5EF4-FFF2-40B4-BE49-F238E27FC236}">
-                <a16:creationId xmlns:a16="http://schemas.microsoft.com/office/drawing/2014/main" id="{6BA8934F-1A7A-3B96-EE56-F6833A450EC8}"/>
+                <a16:creationId xmlns:a16="http://schemas.microsoft.com/office/drawing/2014/main" id="{51964C84-79EC-EA75-0205-4AEE627F4319}"/>
               </a:ext>
             </a:extLst>
           </p:cNvPr>
@@ -20894,7 +20981,7 @@
           <p:cNvPr id="9" name="직사각형 8">
             <a:extLst>
               <a:ext uri="{FF2B5EF4-FFF2-40B4-BE49-F238E27FC236}">
-                <a16:creationId xmlns:a16="http://schemas.microsoft.com/office/drawing/2014/main" id="{04A3055E-D7A0-4161-4B01-A4D2B1D2BA64}"/>
+                <a16:creationId xmlns:a16="http://schemas.microsoft.com/office/drawing/2014/main" id="{6013EF5B-0611-ECF6-9404-F1638551ACDF}"/>
               </a:ext>
             </a:extLst>
           </p:cNvPr>
@@ -20948,7 +21035,7 @@
           <p:cNvPr id="10" name="TextBox 9">
             <a:extLst>
               <a:ext uri="{FF2B5EF4-FFF2-40B4-BE49-F238E27FC236}">
-                <a16:creationId xmlns:a16="http://schemas.microsoft.com/office/drawing/2014/main" id="{2C481800-5A6A-97C1-3607-A9156676715D}"/>
+                <a16:creationId xmlns:a16="http://schemas.microsoft.com/office/drawing/2014/main" id="{2E4155E5-6165-274A-5899-7DE8C263E5C3}"/>
               </a:ext>
             </a:extLst>
           </p:cNvPr>
@@ -20989,7 +21076,7 @@
           <p:cNvPr id="11" name="직사각형 10">
             <a:extLst>
               <a:ext uri="{FF2B5EF4-FFF2-40B4-BE49-F238E27FC236}">
-                <a16:creationId xmlns:a16="http://schemas.microsoft.com/office/drawing/2014/main" id="{281322B4-8BA2-A8E8-525F-054456333153}"/>
+                <a16:creationId xmlns:a16="http://schemas.microsoft.com/office/drawing/2014/main" id="{3436E4ED-0144-B70F-4A6A-7003235A39C6}"/>
               </a:ext>
             </a:extLst>
           </p:cNvPr>
@@ -21043,7 +21130,7 @@
           <p:cNvPr id="12" name="TextBox 11">
             <a:extLst>
               <a:ext uri="{FF2B5EF4-FFF2-40B4-BE49-F238E27FC236}">
-                <a16:creationId xmlns:a16="http://schemas.microsoft.com/office/drawing/2014/main" id="{C55D8E4A-27BC-E8AF-144B-07EE43126204}"/>
+                <a16:creationId xmlns:a16="http://schemas.microsoft.com/office/drawing/2014/main" id="{7486D461-0F6A-1962-8C10-483A14278591}"/>
               </a:ext>
             </a:extLst>
           </p:cNvPr>
@@ -21090,7 +21177,7 @@
           <p:cNvPr id="13" name="직사각형 12">
             <a:extLst>
               <a:ext uri="{FF2B5EF4-FFF2-40B4-BE49-F238E27FC236}">
-                <a16:creationId xmlns:a16="http://schemas.microsoft.com/office/drawing/2014/main" id="{780E08CB-0E28-2D0E-937B-8A91CA47B539}"/>
+                <a16:creationId xmlns:a16="http://schemas.microsoft.com/office/drawing/2014/main" id="{38F62FAD-91AA-FBE0-647F-B5994DD6234D}"/>
               </a:ext>
             </a:extLst>
           </p:cNvPr>
@@ -21144,7 +21231,7 @@
           <p:cNvPr id="14" name="직사각형 13">
             <a:extLst>
               <a:ext uri="{FF2B5EF4-FFF2-40B4-BE49-F238E27FC236}">
-                <a16:creationId xmlns:a16="http://schemas.microsoft.com/office/drawing/2014/main" id="{997F7EA1-013B-296E-9710-D9343DBF08E1}"/>
+                <a16:creationId xmlns:a16="http://schemas.microsoft.com/office/drawing/2014/main" id="{74B9681F-8551-CA72-3DC1-5AC07990E623}"/>
               </a:ext>
             </a:extLst>
           </p:cNvPr>
@@ -21198,7 +21285,7 @@
           <p:cNvPr id="15" name="TextBox 14">
             <a:extLst>
               <a:ext uri="{FF2B5EF4-FFF2-40B4-BE49-F238E27FC236}">
-                <a16:creationId xmlns:a16="http://schemas.microsoft.com/office/drawing/2014/main" id="{8BC93777-EABA-6400-2C53-E8B294546272}"/>
+                <a16:creationId xmlns:a16="http://schemas.microsoft.com/office/drawing/2014/main" id="{B86630E4-1F66-38F5-DC0E-BB07433C990D}"/>
               </a:ext>
             </a:extLst>
           </p:cNvPr>
@@ -21245,7 +21332,7 @@
           <p:cNvPr id="16" name="직사각형 15">
             <a:extLst>
               <a:ext uri="{FF2B5EF4-FFF2-40B4-BE49-F238E27FC236}">
-                <a16:creationId xmlns:a16="http://schemas.microsoft.com/office/drawing/2014/main" id="{FB8B8844-750A-B67A-1212-20DDE8F230F7}"/>
+                <a16:creationId xmlns:a16="http://schemas.microsoft.com/office/drawing/2014/main" id="{DE9984FC-38C0-8B30-F2F7-D59A89E51FC5}"/>
               </a:ext>
             </a:extLst>
           </p:cNvPr>
@@ -21299,7 +21386,7 @@
           <p:cNvPr id="17" name="TextBox 16">
             <a:extLst>
               <a:ext uri="{FF2B5EF4-FFF2-40B4-BE49-F238E27FC236}">
-                <a16:creationId xmlns:a16="http://schemas.microsoft.com/office/drawing/2014/main" id="{8DA2E9A9-2602-F95A-FF05-7588003AD073}"/>
+                <a16:creationId xmlns:a16="http://schemas.microsoft.com/office/drawing/2014/main" id="{2BA2B429-CE65-6640-27E7-8436E559670D}"/>
               </a:ext>
             </a:extLst>
           </p:cNvPr>
@@ -21346,7 +21433,7 @@
           <p:cNvPr id="18" name="직사각형 17">
             <a:extLst>
               <a:ext uri="{FF2B5EF4-FFF2-40B4-BE49-F238E27FC236}">
-                <a16:creationId xmlns:a16="http://schemas.microsoft.com/office/drawing/2014/main" id="{FA13F7E5-8393-8DCF-1A60-FD9DF979ABAB}"/>
+                <a16:creationId xmlns:a16="http://schemas.microsoft.com/office/drawing/2014/main" id="{9A063AD4-A4EF-3B01-261E-34DA1CAC0119}"/>
               </a:ext>
             </a:extLst>
           </p:cNvPr>
@@ -21400,7 +21487,7 @@
           <p:cNvPr id="19" name="TextBox 18">
             <a:extLst>
               <a:ext uri="{FF2B5EF4-FFF2-40B4-BE49-F238E27FC236}">
-                <a16:creationId xmlns:a16="http://schemas.microsoft.com/office/drawing/2014/main" id="{176FDB48-4D61-BF1F-4A97-86FDAB0A383C}"/>
+                <a16:creationId xmlns:a16="http://schemas.microsoft.com/office/drawing/2014/main" id="{19AC32BF-7253-962D-DEC8-9AD41490098A}"/>
               </a:ext>
             </a:extLst>
           </p:cNvPr>
@@ -21447,7 +21534,7 @@
           <p:cNvPr id="20" name="직사각형 19">
             <a:extLst>
               <a:ext uri="{FF2B5EF4-FFF2-40B4-BE49-F238E27FC236}">
-                <a16:creationId xmlns:a16="http://schemas.microsoft.com/office/drawing/2014/main" id="{B7C52D19-76A7-905F-BDE7-78E3D5243154}"/>
+                <a16:creationId xmlns:a16="http://schemas.microsoft.com/office/drawing/2014/main" id="{839E7498-240C-0FD8-05BC-51B3F5072835}"/>
               </a:ext>
             </a:extLst>
           </p:cNvPr>
@@ -21501,7 +21588,7 @@
           <p:cNvPr id="21" name="직사각형 20">
             <a:extLst>
               <a:ext uri="{FF2B5EF4-FFF2-40B4-BE49-F238E27FC236}">
-                <a16:creationId xmlns:a16="http://schemas.microsoft.com/office/drawing/2014/main" id="{5686166F-99BA-CEF0-8ABC-1254A853CFD5}"/>
+                <a16:creationId xmlns:a16="http://schemas.microsoft.com/office/drawing/2014/main" id="{8E38608B-A742-D1C1-8722-6F680067E8A2}"/>
               </a:ext>
             </a:extLst>
           </p:cNvPr>
@@ -21555,7 +21642,7 @@
           <p:cNvPr id="22" name="TextBox 21">
             <a:extLst>
               <a:ext uri="{FF2B5EF4-FFF2-40B4-BE49-F238E27FC236}">
-                <a16:creationId xmlns:a16="http://schemas.microsoft.com/office/drawing/2014/main" id="{D88D1239-48A0-9DF9-513F-0B814AEB2EB9}"/>
+                <a16:creationId xmlns:a16="http://schemas.microsoft.com/office/drawing/2014/main" id="{DB29FF2B-89FF-3258-B5E8-94F5C5AEA726}"/>
               </a:ext>
             </a:extLst>
           </p:cNvPr>
@@ -21602,7 +21689,7 @@
           <p:cNvPr id="23" name="직사각형 22">
             <a:extLst>
               <a:ext uri="{FF2B5EF4-FFF2-40B4-BE49-F238E27FC236}">
-                <a16:creationId xmlns:a16="http://schemas.microsoft.com/office/drawing/2014/main" id="{0FEF7A74-EFE2-1C4C-239D-A62370234968}"/>
+                <a16:creationId xmlns:a16="http://schemas.microsoft.com/office/drawing/2014/main" id="{F75C088D-ECDC-9F60-216C-6906431AEA2E}"/>
               </a:ext>
             </a:extLst>
           </p:cNvPr>
@@ -21656,7 +21743,7 @@
           <p:cNvPr id="24" name="TextBox 23">
             <a:extLst>
               <a:ext uri="{FF2B5EF4-FFF2-40B4-BE49-F238E27FC236}">
-                <a16:creationId xmlns:a16="http://schemas.microsoft.com/office/drawing/2014/main" id="{135C13E3-DFF8-9C0F-687E-A5F06D73253A}"/>
+                <a16:creationId xmlns:a16="http://schemas.microsoft.com/office/drawing/2014/main" id="{C8DD9F4C-E4D2-D0CC-F220-E8DC178F5313}"/>
               </a:ext>
             </a:extLst>
           </p:cNvPr>
@@ -21703,7 +21790,7 @@
           <p:cNvPr id="25" name="직사각형 24">
             <a:extLst>
               <a:ext uri="{FF2B5EF4-FFF2-40B4-BE49-F238E27FC236}">
-                <a16:creationId xmlns:a16="http://schemas.microsoft.com/office/drawing/2014/main" id="{978EA22B-370B-DF2F-56CE-6444EE95189A}"/>
+                <a16:creationId xmlns:a16="http://schemas.microsoft.com/office/drawing/2014/main" id="{6CE9598F-BCF6-FCC6-73ED-1993309D2C69}"/>
               </a:ext>
             </a:extLst>
           </p:cNvPr>
@@ -21757,7 +21844,7 @@
           <p:cNvPr id="26" name="TextBox 25">
             <a:extLst>
               <a:ext uri="{FF2B5EF4-FFF2-40B4-BE49-F238E27FC236}">
-                <a16:creationId xmlns:a16="http://schemas.microsoft.com/office/drawing/2014/main" id="{38FF10B4-9DE0-D659-F596-7EC57FAA3BC9}"/>
+                <a16:creationId xmlns:a16="http://schemas.microsoft.com/office/drawing/2014/main" id="{84AE8FFF-4F29-CCB8-FD9F-2F8C60894101}"/>
               </a:ext>
             </a:extLst>
           </p:cNvPr>
@@ -21804,7 +21891,7 @@
           <p:cNvPr id="27" name="직사각형 26">
             <a:extLst>
               <a:ext uri="{FF2B5EF4-FFF2-40B4-BE49-F238E27FC236}">
-                <a16:creationId xmlns:a16="http://schemas.microsoft.com/office/drawing/2014/main" id="{325AF589-8118-125B-6A04-2938BBAFFCD6}"/>
+                <a16:creationId xmlns:a16="http://schemas.microsoft.com/office/drawing/2014/main" id="{6562EEB0-EE52-6786-D902-CC1EDB36A58B}"/>
               </a:ext>
             </a:extLst>
           </p:cNvPr>
@@ -21858,7 +21945,7 @@
           <p:cNvPr id="28" name="직사각형 27">
             <a:extLst>
               <a:ext uri="{FF2B5EF4-FFF2-40B4-BE49-F238E27FC236}">
-                <a16:creationId xmlns:a16="http://schemas.microsoft.com/office/drawing/2014/main" id="{9EF95A8B-2B48-3958-0DE2-FE32B1C25260}"/>
+                <a16:creationId xmlns:a16="http://schemas.microsoft.com/office/drawing/2014/main" id="{762B19E6-4FBE-E4F6-4635-57AEA12EF5F4}"/>
               </a:ext>
             </a:extLst>
           </p:cNvPr>
@@ -21912,7 +21999,7 @@
           <p:cNvPr id="29" name="TextBox 28">
             <a:extLst>
               <a:ext uri="{FF2B5EF4-FFF2-40B4-BE49-F238E27FC236}">
-                <a16:creationId xmlns:a16="http://schemas.microsoft.com/office/drawing/2014/main" id="{1F8A3A5E-0274-CCC0-1E00-C6C1CBA80731}"/>
+                <a16:creationId xmlns:a16="http://schemas.microsoft.com/office/drawing/2014/main" id="{AE175134-BFE4-EA1E-4E75-0FA9D03031C7}"/>
               </a:ext>
             </a:extLst>
           </p:cNvPr>
@@ -21953,7 +22040,7 @@
           <p:cNvPr id="30" name="직사각형 29">
             <a:extLst>
               <a:ext uri="{FF2B5EF4-FFF2-40B4-BE49-F238E27FC236}">
-                <a16:creationId xmlns:a16="http://schemas.microsoft.com/office/drawing/2014/main" id="{53EEEA33-D0BB-3231-FB64-5793C525F75F}"/>
+                <a16:creationId xmlns:a16="http://schemas.microsoft.com/office/drawing/2014/main" id="{04E20980-CF56-9BF3-42F9-3F154BE0CBAB}"/>
               </a:ext>
             </a:extLst>
           </p:cNvPr>
@@ -22007,7 +22094,7 @@
           <p:cNvPr id="31" name="TextBox 30">
             <a:extLst>
               <a:ext uri="{FF2B5EF4-FFF2-40B4-BE49-F238E27FC236}">
-                <a16:creationId xmlns:a16="http://schemas.microsoft.com/office/drawing/2014/main" id="{1373F7F0-E821-F616-552A-857002DEA1E9}"/>
+                <a16:creationId xmlns:a16="http://schemas.microsoft.com/office/drawing/2014/main" id="{2FFA6738-C1CB-1B97-3BDC-019FEC3FE6A6}"/>
               </a:ext>
             </a:extLst>
           </p:cNvPr>
@@ -22054,7 +22141,7 @@
           <p:cNvPr id="32" name="직사각형 31">
             <a:extLst>
               <a:ext uri="{FF2B5EF4-FFF2-40B4-BE49-F238E27FC236}">
-                <a16:creationId xmlns:a16="http://schemas.microsoft.com/office/drawing/2014/main" id="{2458C084-2041-9E67-6E3F-6FCDEBE4A850}"/>
+                <a16:creationId xmlns:a16="http://schemas.microsoft.com/office/drawing/2014/main" id="{6EEE5661-1C69-2B26-E5DE-E3EE09CF6E70}"/>
               </a:ext>
             </a:extLst>
           </p:cNvPr>
@@ -22108,7 +22195,7 @@
           <p:cNvPr id="33" name="직사각형 32">
             <a:extLst>
               <a:ext uri="{FF2B5EF4-FFF2-40B4-BE49-F238E27FC236}">
-                <a16:creationId xmlns:a16="http://schemas.microsoft.com/office/drawing/2014/main" id="{50C2B686-82E3-600D-F30B-4CCC5D4F7147}"/>
+                <a16:creationId xmlns:a16="http://schemas.microsoft.com/office/drawing/2014/main" id="{E8BC878D-738F-E4A7-9232-EAE11CD7C282}"/>
               </a:ext>
             </a:extLst>
           </p:cNvPr>
@@ -22162,7 +22249,7 @@
           <p:cNvPr id="34" name="TextBox 33">
             <a:extLst>
               <a:ext uri="{FF2B5EF4-FFF2-40B4-BE49-F238E27FC236}">
-                <a16:creationId xmlns:a16="http://schemas.microsoft.com/office/drawing/2014/main" id="{93E9AEDD-C93F-31B4-F4AF-FE5A5E6E03D3}"/>
+                <a16:creationId xmlns:a16="http://schemas.microsoft.com/office/drawing/2014/main" id="{B1D092FE-832B-B4C9-E6BA-8D7733A38C9F}"/>
               </a:ext>
             </a:extLst>
           </p:cNvPr>
@@ -22209,7 +22296,7 @@
           <p:cNvPr id="35" name="직사각형 34">
             <a:extLst>
               <a:ext uri="{FF2B5EF4-FFF2-40B4-BE49-F238E27FC236}">
-                <a16:creationId xmlns:a16="http://schemas.microsoft.com/office/drawing/2014/main" id="{78995EAD-FCC8-08E6-414C-CFB89B53E14D}"/>
+                <a16:creationId xmlns:a16="http://schemas.microsoft.com/office/drawing/2014/main" id="{61CC4183-36C4-5312-0373-491214B78044}"/>
               </a:ext>
             </a:extLst>
           </p:cNvPr>
@@ -22263,7 +22350,7 @@
           <p:cNvPr id="36" name="TextBox 35">
             <a:extLst>
               <a:ext uri="{FF2B5EF4-FFF2-40B4-BE49-F238E27FC236}">
-                <a16:creationId xmlns:a16="http://schemas.microsoft.com/office/drawing/2014/main" id="{E4CDFC3F-4536-2012-CAF2-6DA0780754C6}"/>
+                <a16:creationId xmlns:a16="http://schemas.microsoft.com/office/drawing/2014/main" id="{84098FD6-9FFC-3EF7-2057-007689ADDF64}"/>
               </a:ext>
             </a:extLst>
           </p:cNvPr>
@@ -22310,7 +22397,7 @@
           <p:cNvPr id="37" name="직사각형 36">
             <a:extLst>
               <a:ext uri="{FF2B5EF4-FFF2-40B4-BE49-F238E27FC236}">
-                <a16:creationId xmlns:a16="http://schemas.microsoft.com/office/drawing/2014/main" id="{3BDDC798-A985-F1F1-EF5D-EB5D2BB09F34}"/>
+                <a16:creationId xmlns:a16="http://schemas.microsoft.com/office/drawing/2014/main" id="{B03A1F43-EF37-F65F-3DA0-D15D20D75293}"/>
               </a:ext>
             </a:extLst>
           </p:cNvPr>
@@ -22364,7 +22451,7 @@
           <p:cNvPr id="38" name="직사각형 37">
             <a:extLst>
               <a:ext uri="{FF2B5EF4-FFF2-40B4-BE49-F238E27FC236}">
-                <a16:creationId xmlns:a16="http://schemas.microsoft.com/office/drawing/2014/main" id="{1FBB7339-015A-E6BC-6EA1-7CED81C25329}"/>
+                <a16:creationId xmlns:a16="http://schemas.microsoft.com/office/drawing/2014/main" id="{3CC548FB-3432-8D25-A340-F7B473DB06E2}"/>
               </a:ext>
             </a:extLst>
           </p:cNvPr>
@@ -22418,7 +22505,7 @@
           <p:cNvPr id="39" name="TextBox 38">
             <a:extLst>
               <a:ext uri="{FF2B5EF4-FFF2-40B4-BE49-F238E27FC236}">
-                <a16:creationId xmlns:a16="http://schemas.microsoft.com/office/drawing/2014/main" id="{DB980634-7A56-2A7D-CD33-A6037ABA3C74}"/>
+                <a16:creationId xmlns:a16="http://schemas.microsoft.com/office/drawing/2014/main" id="{FDDA270D-970F-5C93-F1A3-83DA9FAC0BC6}"/>
               </a:ext>
             </a:extLst>
           </p:cNvPr>
@@ -22492,7 +22579,7 @@
           <p:cNvPr id="40" name="직사각형 39">
             <a:extLst>
               <a:ext uri="{FF2B5EF4-FFF2-40B4-BE49-F238E27FC236}">
-                <a16:creationId xmlns:a16="http://schemas.microsoft.com/office/drawing/2014/main" id="{8741679B-1517-81DA-50F6-4CA7508F3656}"/>
+                <a16:creationId xmlns:a16="http://schemas.microsoft.com/office/drawing/2014/main" id="{159509D4-943C-3333-DB36-0BC02B5107DB}"/>
               </a:ext>
             </a:extLst>
           </p:cNvPr>
@@ -22546,7 +22633,7 @@
           <p:cNvPr id="41" name="사각형: 둥근 모서리 40">
             <a:extLst>
               <a:ext uri="{FF2B5EF4-FFF2-40B4-BE49-F238E27FC236}">
-                <a16:creationId xmlns:a16="http://schemas.microsoft.com/office/drawing/2014/main" id="{35E67DAF-7019-4D3B-0023-99D4C6687AEB}"/>
+                <a16:creationId xmlns:a16="http://schemas.microsoft.com/office/drawing/2014/main" id="{008CC565-C726-156F-547B-EE8BDF39AF2A}"/>
               </a:ext>
             </a:extLst>
           </p:cNvPr>
@@ -22614,7 +22701,7 @@
           <p:cNvPr id="42" name="TextBox 41">
             <a:extLst>
               <a:ext uri="{FF2B5EF4-FFF2-40B4-BE49-F238E27FC236}">
-                <a16:creationId xmlns:a16="http://schemas.microsoft.com/office/drawing/2014/main" id="{15968B09-1D55-0197-7D87-76AA5E7B1A72}"/>
+                <a16:creationId xmlns:a16="http://schemas.microsoft.com/office/drawing/2014/main" id="{A15AC9A0-53BB-9A4A-2DFD-77CABB5B0803}"/>
               </a:ext>
             </a:extLst>
           </p:cNvPr>
@@ -22661,7 +22748,7 @@
           <p:cNvPr id="43" name="사각형: 둥근 모서리 42">
             <a:extLst>
               <a:ext uri="{FF2B5EF4-FFF2-40B4-BE49-F238E27FC236}">
-                <a16:creationId xmlns:a16="http://schemas.microsoft.com/office/drawing/2014/main" id="{669AAD80-EF6D-6705-4CB6-2B7630B9862A}"/>
+                <a16:creationId xmlns:a16="http://schemas.microsoft.com/office/drawing/2014/main" id="{D3C1A66C-19D2-52D5-8D64-EB1C969B1F36}"/>
               </a:ext>
             </a:extLst>
           </p:cNvPr>
@@ -22729,7 +22816,7 @@
           <p:cNvPr id="44" name="TextBox 43">
             <a:extLst>
               <a:ext uri="{FF2B5EF4-FFF2-40B4-BE49-F238E27FC236}">
-                <a16:creationId xmlns:a16="http://schemas.microsoft.com/office/drawing/2014/main" id="{1BAD89B0-96B9-C821-D7B6-E07CBEB0F87E}"/>
+                <a16:creationId xmlns:a16="http://schemas.microsoft.com/office/drawing/2014/main" id="{F18073AD-12A0-5F3B-940E-F6F7D471ACB1}"/>
               </a:ext>
             </a:extLst>
           </p:cNvPr>
@@ -22776,7 +22863,7 @@
           <p:cNvPr id="45" name="TextBox 44">
             <a:extLst>
               <a:ext uri="{FF2B5EF4-FFF2-40B4-BE49-F238E27FC236}">
-                <a16:creationId xmlns:a16="http://schemas.microsoft.com/office/drawing/2014/main" id="{150EB17F-FEEE-CC84-1F3F-8565F4324EC2}"/>
+                <a16:creationId xmlns:a16="http://schemas.microsoft.com/office/drawing/2014/main" id="{B68848C7-6691-DB54-37F0-698ACBCB8699}"/>
               </a:ext>
             </a:extLst>
           </p:cNvPr>
@@ -22871,7 +22958,7 @@
           <p:cNvPr id="46" name="직선 연결선 45">
             <a:extLst>
               <a:ext uri="{FF2B5EF4-FFF2-40B4-BE49-F238E27FC236}">
-                <a16:creationId xmlns:a16="http://schemas.microsoft.com/office/drawing/2014/main" id="{C132D9DC-E45E-391C-98F3-7D6D9D986AE4}"/>
+                <a16:creationId xmlns:a16="http://schemas.microsoft.com/office/drawing/2014/main" id="{1D93F8A9-E8D3-EDA0-9E6A-F7F726915F1E}"/>
               </a:ext>
             </a:extLst>
           </p:cNvPr>
@@ -22912,7 +22999,7 @@
           <p:cNvPr id="47" name="TextBox 46">
             <a:extLst>
               <a:ext uri="{FF2B5EF4-FFF2-40B4-BE49-F238E27FC236}">
-                <a16:creationId xmlns:a16="http://schemas.microsoft.com/office/drawing/2014/main" id="{1392A769-B5E3-BF17-29FE-8D1AF7FCE513}"/>
+                <a16:creationId xmlns:a16="http://schemas.microsoft.com/office/drawing/2014/main" id="{08F4900E-A222-EE8B-8C4B-64F9806651D1}"/>
               </a:ext>
             </a:extLst>
           </p:cNvPr>
@@ -22997,7 +23084,7 @@
           <p:cNvPr id="48" name="TextBox 47">
             <a:extLst>
               <a:ext uri="{FF2B5EF4-FFF2-40B4-BE49-F238E27FC236}">
-                <a16:creationId xmlns:a16="http://schemas.microsoft.com/office/drawing/2014/main" id="{E96E6F90-D7B5-16E3-05E1-5F3477D03145}"/>
+                <a16:creationId xmlns:a16="http://schemas.microsoft.com/office/drawing/2014/main" id="{29B1250E-2962-325E-2009-90C0AF516D3E}"/>
               </a:ext>
             </a:extLst>
           </p:cNvPr>
@@ -23042,7 +23129,7 @@
     </p:spTree>
     <p:extLst>
       <p:ext uri="{BB962C8B-B14F-4D97-AF65-F5344CB8AC3E}">
-        <p14:creationId xmlns:p14="http://schemas.microsoft.com/office/powerpoint/2010/main" val="3616024785"/>
+        <p14:creationId xmlns:p14="http://schemas.microsoft.com/office/powerpoint/2010/main" val="2767143500"/>
       </p:ext>
     </p:extLst>
   </p:cSld>
@@ -23074,7 +23161,7 @@
           <p:cNvPr id="2" name="TextBox 1">
             <a:extLst>
               <a:ext uri="{FF2B5EF4-FFF2-40B4-BE49-F238E27FC236}">
-                <a16:creationId xmlns:a16="http://schemas.microsoft.com/office/drawing/2014/main" id="{D8F5A5C2-2F8C-8B70-4F4A-3591D3976605}"/>
+                <a16:creationId xmlns:a16="http://schemas.microsoft.com/office/drawing/2014/main" id="{B6CE503A-1B35-8655-0161-A8C3677CC2EE}"/>
               </a:ext>
             </a:extLst>
           </p:cNvPr>
@@ -23123,7 +23210,7 @@
           <p:cNvPr id="3" name="TextBox 2">
             <a:extLst>
               <a:ext uri="{FF2B5EF4-FFF2-40B4-BE49-F238E27FC236}">
-                <a16:creationId xmlns:a16="http://schemas.microsoft.com/office/drawing/2014/main" id="{6ABA3F07-50B2-D9DE-2699-B3ED19D7F049}"/>
+                <a16:creationId xmlns:a16="http://schemas.microsoft.com/office/drawing/2014/main" id="{541BDF1B-1906-FEA3-7543-911B65519FF9}"/>
               </a:ext>
             </a:extLst>
           </p:cNvPr>
@@ -23244,7 +23331,7 @@
           <p:cNvPr id="4" name="직사각형 3">
             <a:extLst>
               <a:ext uri="{FF2B5EF4-FFF2-40B4-BE49-F238E27FC236}">
-                <a16:creationId xmlns:a16="http://schemas.microsoft.com/office/drawing/2014/main" id="{09699175-63DD-5A1E-6E4E-ACC34C8F1B70}"/>
+                <a16:creationId xmlns:a16="http://schemas.microsoft.com/office/drawing/2014/main" id="{570E9647-FC10-27DC-2DA7-75B6B1A92C84}"/>
               </a:ext>
             </a:extLst>
           </p:cNvPr>
@@ -23312,7 +23399,7 @@
           <p:cNvPr id="5" name="직선 연결선 4">
             <a:extLst>
               <a:ext uri="{FF2B5EF4-FFF2-40B4-BE49-F238E27FC236}">
-                <a16:creationId xmlns:a16="http://schemas.microsoft.com/office/drawing/2014/main" id="{942AEFEA-1065-7999-08F6-086D59EED8A0}"/>
+                <a16:creationId xmlns:a16="http://schemas.microsoft.com/office/drawing/2014/main" id="{3D9E8378-F021-DDB8-D3D1-559339EF6CE8}"/>
               </a:ext>
             </a:extLst>
           </p:cNvPr>
@@ -23353,7 +23440,7 @@
           <p:cNvPr id="6" name="사각형: 둥근 모서리 5">
             <a:extLst>
               <a:ext uri="{FF2B5EF4-FFF2-40B4-BE49-F238E27FC236}">
-                <a16:creationId xmlns:a16="http://schemas.microsoft.com/office/drawing/2014/main" id="{0ADC9745-0782-8CE6-E4E8-66F5F6FEF465}"/>
+                <a16:creationId xmlns:a16="http://schemas.microsoft.com/office/drawing/2014/main" id="{CDABEFBA-92EE-20E2-D67E-9E15ADD20703}"/>
               </a:ext>
             </a:extLst>
           </p:cNvPr>
@@ -23421,7 +23508,7 @@
           <p:cNvPr id="7" name="TextBox 6">
             <a:extLst>
               <a:ext uri="{FF2B5EF4-FFF2-40B4-BE49-F238E27FC236}">
-                <a16:creationId xmlns:a16="http://schemas.microsoft.com/office/drawing/2014/main" id="{0BD94D83-ACCF-FC60-41A8-8F9E20CE3EDE}"/>
+                <a16:creationId xmlns:a16="http://schemas.microsoft.com/office/drawing/2014/main" id="{B6C02888-E62C-CCA1-BC28-B386E734B70F}"/>
               </a:ext>
             </a:extLst>
           </p:cNvPr>
@@ -23468,7 +23555,7 @@
           <p:cNvPr id="8" name="사각형: 둥근 모서리 7">
             <a:extLst>
               <a:ext uri="{FF2B5EF4-FFF2-40B4-BE49-F238E27FC236}">
-                <a16:creationId xmlns:a16="http://schemas.microsoft.com/office/drawing/2014/main" id="{044A02E5-2C0E-3BD5-E278-7FE5D382CF11}"/>
+                <a16:creationId xmlns:a16="http://schemas.microsoft.com/office/drawing/2014/main" id="{37361077-2F0E-E7AE-F685-C74C360D8863}"/>
               </a:ext>
             </a:extLst>
           </p:cNvPr>
@@ -23536,7 +23623,7 @@
           <p:cNvPr id="9" name="TextBox 8">
             <a:extLst>
               <a:ext uri="{FF2B5EF4-FFF2-40B4-BE49-F238E27FC236}">
-                <a16:creationId xmlns:a16="http://schemas.microsoft.com/office/drawing/2014/main" id="{E62AD856-7807-E18C-3260-859EDBD728CB}"/>
+                <a16:creationId xmlns:a16="http://schemas.microsoft.com/office/drawing/2014/main" id="{395AECC2-6BEB-8A78-7D6F-64AEBAC4B703}"/>
               </a:ext>
             </a:extLst>
           </p:cNvPr>
@@ -23582,7 +23669,7 @@
           <p:cNvPr id="10" name="TextBox 9">
             <a:extLst>
               <a:ext uri="{FF2B5EF4-FFF2-40B4-BE49-F238E27FC236}">
-                <a16:creationId xmlns:a16="http://schemas.microsoft.com/office/drawing/2014/main" id="{6C780987-7668-7072-46D6-F4671EA6B0CF}"/>
+                <a16:creationId xmlns:a16="http://schemas.microsoft.com/office/drawing/2014/main" id="{D12DF95A-93BF-1CC6-22C4-716C81DAC50B}"/>
               </a:ext>
             </a:extLst>
           </p:cNvPr>
@@ -23687,7 +23774,7 @@
           <p:cNvPr id="11" name="직선 연결선 10">
             <a:extLst>
               <a:ext uri="{FF2B5EF4-FFF2-40B4-BE49-F238E27FC236}">
-                <a16:creationId xmlns:a16="http://schemas.microsoft.com/office/drawing/2014/main" id="{066990B4-913E-37FC-24DC-46AD619641D1}"/>
+                <a16:creationId xmlns:a16="http://schemas.microsoft.com/office/drawing/2014/main" id="{815E1651-8AC7-27B6-541D-B13A7543C938}"/>
               </a:ext>
             </a:extLst>
           </p:cNvPr>
@@ -23729,7 +23816,7 @@
           <p:cNvPr id="12" name="사각형: 둥근 모서리 11">
             <a:extLst>
               <a:ext uri="{FF2B5EF4-FFF2-40B4-BE49-F238E27FC236}">
-                <a16:creationId xmlns:a16="http://schemas.microsoft.com/office/drawing/2014/main" id="{ECF67E4F-8CD1-C438-46DD-D4512796624F}"/>
+                <a16:creationId xmlns:a16="http://schemas.microsoft.com/office/drawing/2014/main" id="{46262759-FC84-DA1F-A0A8-9CAB0BB26C80}"/>
               </a:ext>
             </a:extLst>
           </p:cNvPr>
@@ -23797,7 +23884,7 @@
           <p:cNvPr id="13" name="TextBox 12">
             <a:extLst>
               <a:ext uri="{FF2B5EF4-FFF2-40B4-BE49-F238E27FC236}">
-                <a16:creationId xmlns:a16="http://schemas.microsoft.com/office/drawing/2014/main" id="{36DE952D-864B-651B-CB2F-421E1DC82A89}"/>
+                <a16:creationId xmlns:a16="http://schemas.microsoft.com/office/drawing/2014/main" id="{737E21AF-EF4F-3F2A-2552-9ACDD328B2E8}"/>
               </a:ext>
             </a:extLst>
           </p:cNvPr>
@@ -23843,7 +23930,7 @@
           <p:cNvPr id="14" name="TextBox 13">
             <a:extLst>
               <a:ext uri="{FF2B5EF4-FFF2-40B4-BE49-F238E27FC236}">
-                <a16:creationId xmlns:a16="http://schemas.microsoft.com/office/drawing/2014/main" id="{45E97E62-0E16-697B-9E5A-FE3DBD3C7F6B}"/>
+                <a16:creationId xmlns:a16="http://schemas.microsoft.com/office/drawing/2014/main" id="{229952A9-5828-DD1F-2FAF-450C2D7A353E}"/>
               </a:ext>
             </a:extLst>
           </p:cNvPr>
@@ -23921,7 +24008,7 @@
           <p:cNvPr id="15" name="직선 연결선 14">
             <a:extLst>
               <a:ext uri="{FF2B5EF4-FFF2-40B4-BE49-F238E27FC236}">
-                <a16:creationId xmlns:a16="http://schemas.microsoft.com/office/drawing/2014/main" id="{A4D58A3D-C6B8-8CEC-AA41-247A79BD719D}"/>
+                <a16:creationId xmlns:a16="http://schemas.microsoft.com/office/drawing/2014/main" id="{7581AA5F-6528-FAFE-886F-EB5A22F1C6FD}"/>
               </a:ext>
             </a:extLst>
           </p:cNvPr>
@@ -23963,7 +24050,7 @@
           <p:cNvPr id="16" name="사각형: 둥근 모서리 15">
             <a:extLst>
               <a:ext uri="{FF2B5EF4-FFF2-40B4-BE49-F238E27FC236}">
-                <a16:creationId xmlns:a16="http://schemas.microsoft.com/office/drawing/2014/main" id="{EA22D789-CE8B-AD39-3F51-43BD0D4DDB7E}"/>
+                <a16:creationId xmlns:a16="http://schemas.microsoft.com/office/drawing/2014/main" id="{478B19B7-DC12-18FB-8035-BB3DBE8DBB84}"/>
               </a:ext>
             </a:extLst>
           </p:cNvPr>
@@ -24031,7 +24118,7 @@
           <p:cNvPr id="17" name="TextBox 16">
             <a:extLst>
               <a:ext uri="{FF2B5EF4-FFF2-40B4-BE49-F238E27FC236}">
-                <a16:creationId xmlns:a16="http://schemas.microsoft.com/office/drawing/2014/main" id="{C996C4D3-C8CB-871F-14CE-81D55EB600EB}"/>
+                <a16:creationId xmlns:a16="http://schemas.microsoft.com/office/drawing/2014/main" id="{F3D17C01-EB86-ECE2-4D3D-A4D88D09DBA4}"/>
               </a:ext>
             </a:extLst>
           </p:cNvPr>
@@ -24077,7 +24164,7 @@
           <p:cNvPr id="18" name="TextBox 17">
             <a:extLst>
               <a:ext uri="{FF2B5EF4-FFF2-40B4-BE49-F238E27FC236}">
-                <a16:creationId xmlns:a16="http://schemas.microsoft.com/office/drawing/2014/main" id="{E741AF77-9A93-1BE1-C697-FE73D579593C}"/>
+                <a16:creationId xmlns:a16="http://schemas.microsoft.com/office/drawing/2014/main" id="{F39DCE74-62EB-09BB-06DB-6D2DBE9DBCC0}"/>
               </a:ext>
             </a:extLst>
           </p:cNvPr>
@@ -24155,7 +24242,7 @@
           <p:cNvPr id="19" name="직선 연결선 18">
             <a:extLst>
               <a:ext uri="{FF2B5EF4-FFF2-40B4-BE49-F238E27FC236}">
-                <a16:creationId xmlns:a16="http://schemas.microsoft.com/office/drawing/2014/main" id="{21260AF9-D6CB-1BF9-4BA6-03F877785489}"/>
+                <a16:creationId xmlns:a16="http://schemas.microsoft.com/office/drawing/2014/main" id="{C35F9989-F1FC-7460-41E5-C456ED169CCF}"/>
               </a:ext>
             </a:extLst>
           </p:cNvPr>
@@ -24197,7 +24284,7 @@
           <p:cNvPr id="20" name="사각형: 둥근 모서리 19">
             <a:extLst>
               <a:ext uri="{FF2B5EF4-FFF2-40B4-BE49-F238E27FC236}">
-                <a16:creationId xmlns:a16="http://schemas.microsoft.com/office/drawing/2014/main" id="{6A2259B5-6B87-D710-B7EC-5B16ADD3A19E}"/>
+                <a16:creationId xmlns:a16="http://schemas.microsoft.com/office/drawing/2014/main" id="{68DE0889-19C4-A6F6-B912-03862E9CC020}"/>
               </a:ext>
             </a:extLst>
           </p:cNvPr>
@@ -24265,7 +24352,7 @@
           <p:cNvPr id="21" name="TextBox 20">
             <a:extLst>
               <a:ext uri="{FF2B5EF4-FFF2-40B4-BE49-F238E27FC236}">
-                <a16:creationId xmlns:a16="http://schemas.microsoft.com/office/drawing/2014/main" id="{EE015ECC-37BA-1C62-837A-E40931155DA4}"/>
+                <a16:creationId xmlns:a16="http://schemas.microsoft.com/office/drawing/2014/main" id="{76A9110C-A4AF-1467-51E5-479303C0C309}"/>
               </a:ext>
             </a:extLst>
           </p:cNvPr>
@@ -24311,7 +24398,7 @@
           <p:cNvPr id="22" name="TextBox 21">
             <a:extLst>
               <a:ext uri="{FF2B5EF4-FFF2-40B4-BE49-F238E27FC236}">
-                <a16:creationId xmlns:a16="http://schemas.microsoft.com/office/drawing/2014/main" id="{3540CF48-C2DF-9FC6-6522-0FC05A086F67}"/>
+                <a16:creationId xmlns:a16="http://schemas.microsoft.com/office/drawing/2014/main" id="{77CC5E42-50F8-7604-AE26-B503AC95966E}"/>
               </a:ext>
             </a:extLst>
           </p:cNvPr>
@@ -24461,7 +24548,7 @@
           <p:cNvPr id="23" name="직선 연결선 22">
             <a:extLst>
               <a:ext uri="{FF2B5EF4-FFF2-40B4-BE49-F238E27FC236}">
-                <a16:creationId xmlns:a16="http://schemas.microsoft.com/office/drawing/2014/main" id="{1B10399D-3AF0-120F-B8E4-9C8F126F215B}"/>
+                <a16:creationId xmlns:a16="http://schemas.microsoft.com/office/drawing/2014/main" id="{522ACA3F-607F-33FB-B0B8-EC8D2352DF58}"/>
               </a:ext>
             </a:extLst>
           </p:cNvPr>
@@ -24503,7 +24590,7 @@
           <p:cNvPr id="24" name="TextBox 23">
             <a:extLst>
               <a:ext uri="{FF2B5EF4-FFF2-40B4-BE49-F238E27FC236}">
-                <a16:creationId xmlns:a16="http://schemas.microsoft.com/office/drawing/2014/main" id="{32794FCD-368B-634D-F5B4-5B6B08E9989B}"/>
+                <a16:creationId xmlns:a16="http://schemas.microsoft.com/office/drawing/2014/main" id="{EE9F5C0E-8188-8E18-2945-AD356C4416CF}"/>
               </a:ext>
             </a:extLst>
           </p:cNvPr>
@@ -24589,7 +24676,7 @@
           <p:cNvPr id="25" name="직선 연결선 24">
             <a:extLst>
               <a:ext uri="{FF2B5EF4-FFF2-40B4-BE49-F238E27FC236}">
-                <a16:creationId xmlns:a16="http://schemas.microsoft.com/office/drawing/2014/main" id="{3358D583-17A7-9B34-BF12-52A8CB26E956}"/>
+                <a16:creationId xmlns:a16="http://schemas.microsoft.com/office/drawing/2014/main" id="{A004DA20-B9D8-BA2C-FCAF-96F87FD3220F}"/>
               </a:ext>
             </a:extLst>
           </p:cNvPr>
@@ -24630,7 +24717,7 @@
           <p:cNvPr id="26" name="TextBox 25">
             <a:extLst>
               <a:ext uri="{FF2B5EF4-FFF2-40B4-BE49-F238E27FC236}">
-                <a16:creationId xmlns:a16="http://schemas.microsoft.com/office/drawing/2014/main" id="{8E0F6628-DFEF-CBAA-01AC-B607691FCC86}"/>
+                <a16:creationId xmlns:a16="http://schemas.microsoft.com/office/drawing/2014/main" id="{9E6E2C14-312C-BA25-EF19-F2D558295B2C}"/>
               </a:ext>
             </a:extLst>
           </p:cNvPr>
@@ -24715,7 +24802,7 @@
           <p:cNvPr id="27" name="TextBox 26">
             <a:extLst>
               <a:ext uri="{FF2B5EF4-FFF2-40B4-BE49-F238E27FC236}">
-                <a16:creationId xmlns:a16="http://schemas.microsoft.com/office/drawing/2014/main" id="{A471F1CF-DDCF-8697-19E4-8E0A02426225}"/>
+                <a16:creationId xmlns:a16="http://schemas.microsoft.com/office/drawing/2014/main" id="{5207B4CF-FAA6-ABB4-526C-FCF51FD6AE0D}"/>
               </a:ext>
             </a:extLst>
           </p:cNvPr>
@@ -24760,7 +24847,7 @@
     </p:spTree>
     <p:extLst>
       <p:ext uri="{BB962C8B-B14F-4D97-AF65-F5344CB8AC3E}">
-        <p14:creationId xmlns:p14="http://schemas.microsoft.com/office/powerpoint/2010/main" val="4027644414"/>
+        <p14:creationId xmlns:p14="http://schemas.microsoft.com/office/powerpoint/2010/main" val="2002811009"/>
       </p:ext>
     </p:extLst>
   </p:cSld>
@@ -24792,7 +24879,7 @@
           <p:cNvPr id="2" name="TextBox 1">
             <a:extLst>
               <a:ext uri="{FF2B5EF4-FFF2-40B4-BE49-F238E27FC236}">
-                <a16:creationId xmlns:a16="http://schemas.microsoft.com/office/drawing/2014/main" id="{77DA9CFA-D760-A30E-30F5-D1BC6AA36BAE}"/>
+                <a16:creationId xmlns:a16="http://schemas.microsoft.com/office/drawing/2014/main" id="{21936F5F-C296-710C-4DDF-9529C23F3676}"/>
               </a:ext>
             </a:extLst>
           </p:cNvPr>
@@ -24841,7 +24928,7 @@
           <p:cNvPr id="3" name="TextBox 2">
             <a:extLst>
               <a:ext uri="{FF2B5EF4-FFF2-40B4-BE49-F238E27FC236}">
-                <a16:creationId xmlns:a16="http://schemas.microsoft.com/office/drawing/2014/main" id="{62FDF141-846A-338D-427C-86350E4F5A6C}"/>
+                <a16:creationId xmlns:a16="http://schemas.microsoft.com/office/drawing/2014/main" id="{55885AA4-8188-D387-69B9-54B307FB528E}"/>
               </a:ext>
             </a:extLst>
           </p:cNvPr>
@@ -24935,7 +25022,7 @@
           <p:cNvPr id="4" name="직사각형 3">
             <a:extLst>
               <a:ext uri="{FF2B5EF4-FFF2-40B4-BE49-F238E27FC236}">
-                <a16:creationId xmlns:a16="http://schemas.microsoft.com/office/drawing/2014/main" id="{5F9612D0-521B-EFA7-D9F1-13C8ECD61B0F}"/>
+                <a16:creationId xmlns:a16="http://schemas.microsoft.com/office/drawing/2014/main" id="{94795E93-C2F1-BC6B-7242-295EB6CBCEB9}"/>
               </a:ext>
             </a:extLst>
           </p:cNvPr>
@@ -25003,7 +25090,7 @@
           <p:cNvPr id="5" name="사각형: 둥근 모서리 4">
             <a:extLst>
               <a:ext uri="{FF2B5EF4-FFF2-40B4-BE49-F238E27FC236}">
-                <a16:creationId xmlns:a16="http://schemas.microsoft.com/office/drawing/2014/main" id="{0BD0177E-6329-A56E-D521-1426E028653B}"/>
+                <a16:creationId xmlns:a16="http://schemas.microsoft.com/office/drawing/2014/main" id="{30928FE3-9069-186B-D85B-FB213AA5641A}"/>
               </a:ext>
             </a:extLst>
           </p:cNvPr>
@@ -25071,7 +25158,7 @@
           <p:cNvPr id="6" name="TextBox 5">
             <a:extLst>
               <a:ext uri="{FF2B5EF4-FFF2-40B4-BE49-F238E27FC236}">
-                <a16:creationId xmlns:a16="http://schemas.microsoft.com/office/drawing/2014/main" id="{902ECCD7-9357-1F54-7FBA-5C148CADF6F2}"/>
+                <a16:creationId xmlns:a16="http://schemas.microsoft.com/office/drawing/2014/main" id="{39579DB2-D66D-F2C1-8BFB-FF520BE2458F}"/>
               </a:ext>
             </a:extLst>
           </p:cNvPr>
@@ -25126,7 +25213,7 @@
           <p:cNvPr id="7" name="TextBox 6">
             <a:extLst>
               <a:ext uri="{FF2B5EF4-FFF2-40B4-BE49-F238E27FC236}">
-                <a16:creationId xmlns:a16="http://schemas.microsoft.com/office/drawing/2014/main" id="{D3C093CD-09C1-844D-978E-9394C2C670A2}"/>
+                <a16:creationId xmlns:a16="http://schemas.microsoft.com/office/drawing/2014/main" id="{5DDBBB38-16FE-5EA6-BBE3-8B313AECF728}"/>
               </a:ext>
             </a:extLst>
           </p:cNvPr>
@@ -25190,7 +25277,7 @@
           <p:cNvPr id="8" name="TextBox 7">
             <a:extLst>
               <a:ext uri="{FF2B5EF4-FFF2-40B4-BE49-F238E27FC236}">
-                <a16:creationId xmlns:a16="http://schemas.microsoft.com/office/drawing/2014/main" id="{110315E9-3470-5418-1C02-2974B4F62B79}"/>
+                <a16:creationId xmlns:a16="http://schemas.microsoft.com/office/drawing/2014/main" id="{25AA5A90-0019-DB24-F625-9B63E1F4481E}"/>
               </a:ext>
             </a:extLst>
           </p:cNvPr>
@@ -25284,7 +25371,7 @@
           <p:cNvPr id="9" name="TextBox 8">
             <a:extLst>
               <a:ext uri="{FF2B5EF4-FFF2-40B4-BE49-F238E27FC236}">
-                <a16:creationId xmlns:a16="http://schemas.microsoft.com/office/drawing/2014/main" id="{D86FEF83-26BB-7434-3026-6ED2A6CB1377}"/>
+                <a16:creationId xmlns:a16="http://schemas.microsoft.com/office/drawing/2014/main" id="{AC6FBC39-77C0-CC16-452D-5DE60C27CBBC}"/>
               </a:ext>
             </a:extLst>
           </p:cNvPr>
@@ -25324,7 +25411,7 @@
           <p:cNvPr id="10" name="TextBox 9">
             <a:extLst>
               <a:ext uri="{FF2B5EF4-FFF2-40B4-BE49-F238E27FC236}">
-                <a16:creationId xmlns:a16="http://schemas.microsoft.com/office/drawing/2014/main" id="{6BF86A72-AE32-0B0D-5183-66F49265D498}"/>
+                <a16:creationId xmlns:a16="http://schemas.microsoft.com/office/drawing/2014/main" id="{4C2A14F7-B787-4DCA-AC0A-A0B3CF98CE4F}"/>
               </a:ext>
             </a:extLst>
           </p:cNvPr>
@@ -25397,7 +25484,7 @@
           <p:cNvPr id="11" name="TextBox 10">
             <a:extLst>
               <a:ext uri="{FF2B5EF4-FFF2-40B4-BE49-F238E27FC236}">
-                <a16:creationId xmlns:a16="http://schemas.microsoft.com/office/drawing/2014/main" id="{B9BA91CB-3143-5A68-2F43-5468BE2974CD}"/>
+                <a16:creationId xmlns:a16="http://schemas.microsoft.com/office/drawing/2014/main" id="{9B8DAA01-07FA-A9A1-9C49-CB89F2FD4BD7}"/>
               </a:ext>
             </a:extLst>
           </p:cNvPr>
@@ -25455,7 +25542,7 @@
           <p:cNvPr id="12" name="직선 연결선 11">
             <a:extLst>
               <a:ext uri="{FF2B5EF4-FFF2-40B4-BE49-F238E27FC236}">
-                <a16:creationId xmlns:a16="http://schemas.microsoft.com/office/drawing/2014/main" id="{3DB5F821-83B6-BD4B-2856-330A7727B332}"/>
+                <a16:creationId xmlns:a16="http://schemas.microsoft.com/office/drawing/2014/main" id="{66768ACE-F6AA-1BDC-C910-2E984A471BDB}"/>
               </a:ext>
             </a:extLst>
           </p:cNvPr>
@@ -25496,7 +25583,7 @@
           <p:cNvPr id="13" name="TextBox 12">
             <a:extLst>
               <a:ext uri="{FF2B5EF4-FFF2-40B4-BE49-F238E27FC236}">
-                <a16:creationId xmlns:a16="http://schemas.microsoft.com/office/drawing/2014/main" id="{27B6253D-DFD3-F8E4-17A8-819995645E96}"/>
+                <a16:creationId xmlns:a16="http://schemas.microsoft.com/office/drawing/2014/main" id="{161E8211-718A-F0C5-4A03-331C5BD93DE7}"/>
               </a:ext>
             </a:extLst>
           </p:cNvPr>
@@ -25536,7 +25623,7 @@
           <p:cNvPr id="14" name="사각형: 둥근 모서리 13">
             <a:extLst>
               <a:ext uri="{FF2B5EF4-FFF2-40B4-BE49-F238E27FC236}">
-                <a16:creationId xmlns:a16="http://schemas.microsoft.com/office/drawing/2014/main" id="{76A41C5C-576E-FCEE-18FB-3413433FDA44}"/>
+                <a16:creationId xmlns:a16="http://schemas.microsoft.com/office/drawing/2014/main" id="{D6E2B304-989F-AE4F-AE60-9588C9471D9D}"/>
               </a:ext>
             </a:extLst>
           </p:cNvPr>
@@ -25604,7 +25691,7 @@
           <p:cNvPr id="15" name="TextBox 14">
             <a:extLst>
               <a:ext uri="{FF2B5EF4-FFF2-40B4-BE49-F238E27FC236}">
-                <a16:creationId xmlns:a16="http://schemas.microsoft.com/office/drawing/2014/main" id="{A5ACFFD6-429E-3A7A-1603-92E984ECF73B}"/>
+                <a16:creationId xmlns:a16="http://schemas.microsoft.com/office/drawing/2014/main" id="{3EA94A5C-F3FA-A3D3-A325-870E27D0DFCC}"/>
               </a:ext>
             </a:extLst>
           </p:cNvPr>
@@ -25651,7 +25738,7 @@
           <p:cNvPr id="16" name="사각형: 둥근 모서리 15">
             <a:extLst>
               <a:ext uri="{FF2B5EF4-FFF2-40B4-BE49-F238E27FC236}">
-                <a16:creationId xmlns:a16="http://schemas.microsoft.com/office/drawing/2014/main" id="{DE4A89A7-8813-F5AA-3B31-763AC9A29150}"/>
+                <a16:creationId xmlns:a16="http://schemas.microsoft.com/office/drawing/2014/main" id="{A6917E3A-A596-1066-AC6A-65855E905040}"/>
               </a:ext>
             </a:extLst>
           </p:cNvPr>
@@ -25719,7 +25806,7 @@
           <p:cNvPr id="17" name="TextBox 16">
             <a:extLst>
               <a:ext uri="{FF2B5EF4-FFF2-40B4-BE49-F238E27FC236}">
-                <a16:creationId xmlns:a16="http://schemas.microsoft.com/office/drawing/2014/main" id="{313BF96A-1B75-86DE-FD22-7DE379CD7937}"/>
+                <a16:creationId xmlns:a16="http://schemas.microsoft.com/office/drawing/2014/main" id="{2DBD2AF1-3177-D081-5E44-06066E3BCD6A}"/>
               </a:ext>
             </a:extLst>
           </p:cNvPr>
@@ -25766,7 +25853,7 @@
           <p:cNvPr id="18" name="사각형: 둥근 모서리 17">
             <a:extLst>
               <a:ext uri="{FF2B5EF4-FFF2-40B4-BE49-F238E27FC236}">
-                <a16:creationId xmlns:a16="http://schemas.microsoft.com/office/drawing/2014/main" id="{BE17662A-E907-38A9-64E1-23A9F6FF396A}"/>
+                <a16:creationId xmlns:a16="http://schemas.microsoft.com/office/drawing/2014/main" id="{C75EC38F-137A-3EE7-82DE-0E41B02F76EE}"/>
               </a:ext>
             </a:extLst>
           </p:cNvPr>
@@ -25834,7 +25921,7 @@
           <p:cNvPr id="19" name="TextBox 18">
             <a:extLst>
               <a:ext uri="{FF2B5EF4-FFF2-40B4-BE49-F238E27FC236}">
-                <a16:creationId xmlns:a16="http://schemas.microsoft.com/office/drawing/2014/main" id="{0E99513F-DEC9-6F70-99B7-673AB3E1D9E8}"/>
+                <a16:creationId xmlns:a16="http://schemas.microsoft.com/office/drawing/2014/main" id="{4CBE2186-2BA1-3C12-7685-E5F2D15905A6}"/>
               </a:ext>
             </a:extLst>
           </p:cNvPr>
@@ -25881,7 +25968,7 @@
           <p:cNvPr id="20" name="사각형: 둥근 모서리 19">
             <a:extLst>
               <a:ext uri="{FF2B5EF4-FFF2-40B4-BE49-F238E27FC236}">
-                <a16:creationId xmlns:a16="http://schemas.microsoft.com/office/drawing/2014/main" id="{091E6FA0-EC34-0B6E-C0D9-D157CEA5F974}"/>
+                <a16:creationId xmlns:a16="http://schemas.microsoft.com/office/drawing/2014/main" id="{EE1E4D4F-6CC6-9347-BF7E-6A0F40C180F6}"/>
               </a:ext>
             </a:extLst>
           </p:cNvPr>
@@ -25949,7 +26036,7 @@
           <p:cNvPr id="21" name="TextBox 20">
             <a:extLst>
               <a:ext uri="{FF2B5EF4-FFF2-40B4-BE49-F238E27FC236}">
-                <a16:creationId xmlns:a16="http://schemas.microsoft.com/office/drawing/2014/main" id="{61D2F4DE-DD6C-9A4E-3F83-2ACA4F62135C}"/>
+                <a16:creationId xmlns:a16="http://schemas.microsoft.com/office/drawing/2014/main" id="{1C4A066B-38E4-2DD5-9DFF-F61893A5D32A}"/>
               </a:ext>
             </a:extLst>
           </p:cNvPr>
@@ -25996,7 +26083,7 @@
           <p:cNvPr id="22" name="TextBox 21">
             <a:extLst>
               <a:ext uri="{FF2B5EF4-FFF2-40B4-BE49-F238E27FC236}">
-                <a16:creationId xmlns:a16="http://schemas.microsoft.com/office/drawing/2014/main" id="{71BAA2DB-2AAF-1377-2758-D388EDDD3E2E}"/>
+                <a16:creationId xmlns:a16="http://schemas.microsoft.com/office/drawing/2014/main" id="{CFB7CE16-B225-F312-524B-41093BAAEC76}"/>
               </a:ext>
             </a:extLst>
           </p:cNvPr>
@@ -26105,7 +26192,7 @@
           <p:cNvPr id="23" name="사각형: 둥근 모서리 22">
             <a:extLst>
               <a:ext uri="{FF2B5EF4-FFF2-40B4-BE49-F238E27FC236}">
-                <a16:creationId xmlns:a16="http://schemas.microsoft.com/office/drawing/2014/main" id="{DCE7A72F-BFBD-C0CB-DC93-3A07F4ED7C09}"/>
+                <a16:creationId xmlns:a16="http://schemas.microsoft.com/office/drawing/2014/main" id="{CECB7BE4-1B20-142E-5294-6758D5B15AF5}"/>
               </a:ext>
             </a:extLst>
           </p:cNvPr>
@@ -26173,7 +26260,7 @@
           <p:cNvPr id="24" name="TextBox 23">
             <a:extLst>
               <a:ext uri="{FF2B5EF4-FFF2-40B4-BE49-F238E27FC236}">
-                <a16:creationId xmlns:a16="http://schemas.microsoft.com/office/drawing/2014/main" id="{E7E198AB-EE61-6B6A-4517-05B26610378A}"/>
+                <a16:creationId xmlns:a16="http://schemas.microsoft.com/office/drawing/2014/main" id="{852DED1F-2861-649C-4D0F-C9019A76D327}"/>
               </a:ext>
             </a:extLst>
           </p:cNvPr>
@@ -26336,7 +26423,7 @@
           <p:cNvPr id="25" name="직선 연결선 24">
             <a:extLst>
               <a:ext uri="{FF2B5EF4-FFF2-40B4-BE49-F238E27FC236}">
-                <a16:creationId xmlns:a16="http://schemas.microsoft.com/office/drawing/2014/main" id="{5EE4E437-9D9A-0788-AD60-97DF02548CCC}"/>
+                <a16:creationId xmlns:a16="http://schemas.microsoft.com/office/drawing/2014/main" id="{FCACE9B1-D0D0-A002-0B62-F737A2FF74FE}"/>
               </a:ext>
             </a:extLst>
           </p:cNvPr>
@@ -26377,7 +26464,7 @@
           <p:cNvPr id="26" name="TextBox 25">
             <a:extLst>
               <a:ext uri="{FF2B5EF4-FFF2-40B4-BE49-F238E27FC236}">
-                <a16:creationId xmlns:a16="http://schemas.microsoft.com/office/drawing/2014/main" id="{3FD18DE7-B3C8-EBEC-3120-0787C27CFD31}"/>
+                <a16:creationId xmlns:a16="http://schemas.microsoft.com/office/drawing/2014/main" id="{C9FD3700-BB56-D2B5-E985-EA7F09EF14F8}"/>
               </a:ext>
             </a:extLst>
           </p:cNvPr>
@@ -26462,7 +26549,7 @@
           <p:cNvPr id="27" name="TextBox 26">
             <a:extLst>
               <a:ext uri="{FF2B5EF4-FFF2-40B4-BE49-F238E27FC236}">
-                <a16:creationId xmlns:a16="http://schemas.microsoft.com/office/drawing/2014/main" id="{5251ED60-5906-5B19-3803-2E531ADF4ECF}"/>
+                <a16:creationId xmlns:a16="http://schemas.microsoft.com/office/drawing/2014/main" id="{24E45569-1469-910A-80AF-46C383B612F2}"/>
               </a:ext>
             </a:extLst>
           </p:cNvPr>
@@ -26507,7 +26594,7 @@
     </p:spTree>
     <p:extLst>
       <p:ext uri="{BB962C8B-B14F-4D97-AF65-F5344CB8AC3E}">
-        <p14:creationId xmlns:p14="http://schemas.microsoft.com/office/powerpoint/2010/main" val="3958170066"/>
+        <p14:creationId xmlns:p14="http://schemas.microsoft.com/office/powerpoint/2010/main" val="2389267440"/>
       </p:ext>
     </p:extLst>
   </p:cSld>
@@ -26539,7 +26626,7 @@
           <p:cNvPr id="2" name="TextBox 1">
             <a:extLst>
               <a:ext uri="{FF2B5EF4-FFF2-40B4-BE49-F238E27FC236}">
-                <a16:creationId xmlns:a16="http://schemas.microsoft.com/office/drawing/2014/main" id="{2A4F2D99-ECE1-9C1B-CC1B-258EF7FF8F4F}"/>
+                <a16:creationId xmlns:a16="http://schemas.microsoft.com/office/drawing/2014/main" id="{FFAF42B3-F732-8721-7A03-70F39EF33A8D}"/>
               </a:ext>
             </a:extLst>
           </p:cNvPr>
@@ -26588,7 +26675,7 @@
           <p:cNvPr id="3" name="TextBox 2">
             <a:extLst>
               <a:ext uri="{FF2B5EF4-FFF2-40B4-BE49-F238E27FC236}">
-                <a16:creationId xmlns:a16="http://schemas.microsoft.com/office/drawing/2014/main" id="{D716CB6F-5C6A-E613-0DEE-9C8CA2B161ED}"/>
+                <a16:creationId xmlns:a16="http://schemas.microsoft.com/office/drawing/2014/main" id="{7337369E-6D89-832B-D9EB-A06E82237AE1}"/>
               </a:ext>
             </a:extLst>
           </p:cNvPr>
@@ -26646,7 +26733,7 @@
           <p:cNvPr id="4" name="직사각형 3">
             <a:extLst>
               <a:ext uri="{FF2B5EF4-FFF2-40B4-BE49-F238E27FC236}">
-                <a16:creationId xmlns:a16="http://schemas.microsoft.com/office/drawing/2014/main" id="{2361BCC0-EC42-7939-A3F2-CE14CB523718}"/>
+                <a16:creationId xmlns:a16="http://schemas.microsoft.com/office/drawing/2014/main" id="{36D39D28-AB3E-6E47-7C65-36FC57B541A6}"/>
               </a:ext>
             </a:extLst>
           </p:cNvPr>
@@ -26714,7 +26801,7 @@
           <p:cNvPr id="5" name="사각형: 둥근 모서리 4">
             <a:extLst>
               <a:ext uri="{FF2B5EF4-FFF2-40B4-BE49-F238E27FC236}">
-                <a16:creationId xmlns:a16="http://schemas.microsoft.com/office/drawing/2014/main" id="{8A659133-4ADA-0F72-AB96-FABAEEAF794D}"/>
+                <a16:creationId xmlns:a16="http://schemas.microsoft.com/office/drawing/2014/main" id="{3A80F221-A43D-B100-9A3C-60B2E9BA6573}"/>
               </a:ext>
             </a:extLst>
           </p:cNvPr>
@@ -26782,7 +26869,7 @@
           <p:cNvPr id="6" name="TextBox 5">
             <a:extLst>
               <a:ext uri="{FF2B5EF4-FFF2-40B4-BE49-F238E27FC236}">
-                <a16:creationId xmlns:a16="http://schemas.microsoft.com/office/drawing/2014/main" id="{0CB46AE3-5B1A-2055-3D79-5F8ABE477010}"/>
+                <a16:creationId xmlns:a16="http://schemas.microsoft.com/office/drawing/2014/main" id="{2C9E0255-60E4-520B-F6FB-2BA953CC858F}"/>
               </a:ext>
             </a:extLst>
           </p:cNvPr>
@@ -26831,7 +26918,7 @@
           <p:cNvPr id="7" name="TextBox 6">
             <a:extLst>
               <a:ext uri="{FF2B5EF4-FFF2-40B4-BE49-F238E27FC236}">
-                <a16:creationId xmlns:a16="http://schemas.microsoft.com/office/drawing/2014/main" id="{E07ACB18-8691-807D-003B-C6ED2509462D}"/>
+                <a16:creationId xmlns:a16="http://schemas.microsoft.com/office/drawing/2014/main" id="{F96A22C0-18BD-C744-ED87-C25438D6FA73}"/>
               </a:ext>
             </a:extLst>
           </p:cNvPr>
@@ -26985,7 +27072,7 @@
           <p:cNvPr id="8" name="사각형: 둥근 모서리 7">
             <a:extLst>
               <a:ext uri="{FF2B5EF4-FFF2-40B4-BE49-F238E27FC236}">
-                <a16:creationId xmlns:a16="http://schemas.microsoft.com/office/drawing/2014/main" id="{65CFDB7C-7E10-B7B2-0CE5-A76204167F6B}"/>
+                <a16:creationId xmlns:a16="http://schemas.microsoft.com/office/drawing/2014/main" id="{0C3D9552-561E-6617-C368-2D67E796B70E}"/>
               </a:ext>
             </a:extLst>
           </p:cNvPr>
@@ -27053,7 +27140,7 @@
           <p:cNvPr id="9" name="TextBox 8">
             <a:extLst>
               <a:ext uri="{FF2B5EF4-FFF2-40B4-BE49-F238E27FC236}">
-                <a16:creationId xmlns:a16="http://schemas.microsoft.com/office/drawing/2014/main" id="{32AD553F-F22D-D500-8E5A-274F5E35210D}"/>
+                <a16:creationId xmlns:a16="http://schemas.microsoft.com/office/drawing/2014/main" id="{1D8F9181-70A9-F540-3CD0-C417591A2294}"/>
               </a:ext>
             </a:extLst>
           </p:cNvPr>
@@ -27102,7 +27189,7 @@
           <p:cNvPr id="10" name="TextBox 9">
             <a:extLst>
               <a:ext uri="{FF2B5EF4-FFF2-40B4-BE49-F238E27FC236}">
-                <a16:creationId xmlns:a16="http://schemas.microsoft.com/office/drawing/2014/main" id="{A75750CF-57E0-E369-19BE-210602412233}"/>
+                <a16:creationId xmlns:a16="http://schemas.microsoft.com/office/drawing/2014/main" id="{3FE92F17-34A7-74CA-6109-1A7C76A9B9BA}"/>
               </a:ext>
             </a:extLst>
           </p:cNvPr>
@@ -27229,7 +27316,7 @@
           <p:cNvPr id="11" name="TextBox 10">
             <a:extLst>
               <a:ext uri="{FF2B5EF4-FFF2-40B4-BE49-F238E27FC236}">
-                <a16:creationId xmlns:a16="http://schemas.microsoft.com/office/drawing/2014/main" id="{8D7D3336-5808-AC71-6C32-EC288DB17816}"/>
+                <a16:creationId xmlns:a16="http://schemas.microsoft.com/office/drawing/2014/main" id="{29D6A490-E8A0-02DE-B8A8-CDD3E3F902D0}"/>
               </a:ext>
             </a:extLst>
           </p:cNvPr>
@@ -27315,7 +27402,7 @@
           <p:cNvPr id="12" name="직선 연결선 11">
             <a:extLst>
               <a:ext uri="{FF2B5EF4-FFF2-40B4-BE49-F238E27FC236}">
-                <a16:creationId xmlns:a16="http://schemas.microsoft.com/office/drawing/2014/main" id="{9FCDFA28-39EF-6D97-33CF-2ED23EF15629}"/>
+                <a16:creationId xmlns:a16="http://schemas.microsoft.com/office/drawing/2014/main" id="{FADF0C49-1948-18C9-FE6D-70843FFCC2F7}"/>
               </a:ext>
             </a:extLst>
           </p:cNvPr>
@@ -27356,7 +27443,7 @@
           <p:cNvPr id="13" name="TextBox 12">
             <a:extLst>
               <a:ext uri="{FF2B5EF4-FFF2-40B4-BE49-F238E27FC236}">
-                <a16:creationId xmlns:a16="http://schemas.microsoft.com/office/drawing/2014/main" id="{606265C8-DFC0-0EB0-210E-2CD573730E56}"/>
+                <a16:creationId xmlns:a16="http://schemas.microsoft.com/office/drawing/2014/main" id="{64858EAA-1060-183B-FA81-60279AFD962C}"/>
               </a:ext>
             </a:extLst>
           </p:cNvPr>
@@ -27441,7 +27528,7 @@
           <p:cNvPr id="14" name="TextBox 13">
             <a:extLst>
               <a:ext uri="{FF2B5EF4-FFF2-40B4-BE49-F238E27FC236}">
-                <a16:creationId xmlns:a16="http://schemas.microsoft.com/office/drawing/2014/main" id="{505B259E-C7F2-2BAC-03EE-AA5A317090AE}"/>
+                <a16:creationId xmlns:a16="http://schemas.microsoft.com/office/drawing/2014/main" id="{85041D94-B495-0102-8C7B-D323E179B266}"/>
               </a:ext>
             </a:extLst>
           </p:cNvPr>
@@ -27486,7 +27573,7 @@
     </p:spTree>
     <p:extLst>
       <p:ext uri="{BB962C8B-B14F-4D97-AF65-F5344CB8AC3E}">
-        <p14:creationId xmlns:p14="http://schemas.microsoft.com/office/powerpoint/2010/main" val="1291170374"/>
+        <p14:creationId xmlns:p14="http://schemas.microsoft.com/office/powerpoint/2010/main" val="700281295"/>
       </p:ext>
     </p:extLst>
   </p:cSld>

</xml_diff>